<commit_message>
Polish VKR package after teacher review
</commit_message>
<xml_diff>
--- a/Marianovskiy_VKR_ADAS_defense_final.pptx
+++ b/Marianovskiy_VKR_ADAS_defense_final.pptx
@@ -2,22 +2,22 @@
 <file path=ppt/presentation.xml><?xml version="1.0" encoding="utf-8"?>
 <p:presentation xmlns:p="http://schemas.openxmlformats.org/presentationml/2006/main">
   <p:sldMasterIdLst>
-    <p:sldMasterId xmlns:r="http://schemas.openxmlformats.org/officeDocument/2006/relationships" id="2147483648" r:id="R519aa169e9224b49"/>
+    <p:sldMasterId xmlns:r="http://schemas.openxmlformats.org/officeDocument/2006/relationships" id="2147483648" r:id="R5ce15b082f554ba6"/>
   </p:sldMasterIdLst>
   <p:notesMasterIdLst>
-    <p:notesMasterId xmlns:r="http://schemas.openxmlformats.org/officeDocument/2006/relationships" r:id="Rc162260624df4e70"/>
+    <p:notesMasterId xmlns:r="http://schemas.openxmlformats.org/officeDocument/2006/relationships" r:id="Rba44ad804a464a82"/>
   </p:notesMasterIdLst>
   <p:sldIdLst>
-    <p:sldId xmlns:r="http://schemas.openxmlformats.org/officeDocument/2006/relationships" id="256" r:id="R6c375529ef5c4ada"/>
-    <p:sldId xmlns:r="http://schemas.openxmlformats.org/officeDocument/2006/relationships" id="257" r:id="R15c6c875896c4fee"/>
-    <p:sldId xmlns:r="http://schemas.openxmlformats.org/officeDocument/2006/relationships" id="258" r:id="R9ef8ccef0657402c"/>
-    <p:sldId xmlns:r="http://schemas.openxmlformats.org/officeDocument/2006/relationships" id="259" r:id="Rcefd678dd1ed49a2"/>
-    <p:sldId xmlns:r="http://schemas.openxmlformats.org/officeDocument/2006/relationships" id="260" r:id="R929f5d1ec1b34b6d"/>
-    <p:sldId xmlns:r="http://schemas.openxmlformats.org/officeDocument/2006/relationships" id="261" r:id="Rfeb12027230645b3"/>
-    <p:sldId xmlns:r="http://schemas.openxmlformats.org/officeDocument/2006/relationships" id="262" r:id="R90b42a6f7ad54ff7"/>
-    <p:sldId xmlns:r="http://schemas.openxmlformats.org/officeDocument/2006/relationships" id="263" r:id="Rc2a07dc50e29449f"/>
-    <p:sldId xmlns:r="http://schemas.openxmlformats.org/officeDocument/2006/relationships" id="264" r:id="R4f5f693cdcec4268"/>
-    <p:sldId xmlns:r="http://schemas.openxmlformats.org/officeDocument/2006/relationships" id="265" r:id="R32c50cdf8a314b6e"/>
+    <p:sldId xmlns:r="http://schemas.openxmlformats.org/officeDocument/2006/relationships" id="256" r:id="R12c88dfb7c244048"/>
+    <p:sldId xmlns:r="http://schemas.openxmlformats.org/officeDocument/2006/relationships" id="257" r:id="Rb535552363c84cca"/>
+    <p:sldId xmlns:r="http://schemas.openxmlformats.org/officeDocument/2006/relationships" id="258" r:id="R94ef14c306494179"/>
+    <p:sldId xmlns:r="http://schemas.openxmlformats.org/officeDocument/2006/relationships" id="259" r:id="R31410e0acbda4713"/>
+    <p:sldId xmlns:r="http://schemas.openxmlformats.org/officeDocument/2006/relationships" id="260" r:id="R7d98882c708f4333"/>
+    <p:sldId xmlns:r="http://schemas.openxmlformats.org/officeDocument/2006/relationships" id="261" r:id="R302b4576b99a4b8e"/>
+    <p:sldId xmlns:r="http://schemas.openxmlformats.org/officeDocument/2006/relationships" id="262" r:id="R9e2dc50453064a8f"/>
+    <p:sldId xmlns:r="http://schemas.openxmlformats.org/officeDocument/2006/relationships" id="263" r:id="R8fc0390dc80a48d3"/>
+    <p:sldId xmlns:r="http://schemas.openxmlformats.org/officeDocument/2006/relationships" id="264" r:id="R3badb57250004d8b"/>
+    <p:sldId xmlns:r="http://schemas.openxmlformats.org/officeDocument/2006/relationships" id="265" r:id="Rb4d069bff68c4c1e"/>
   </p:sldIdLst>
   <p:sldSz cx="12192000" cy="6858000"/>
   <p:notesSz cx="6858000" cy="9144000"/>
@@ -1076,7 +1076,7 @@
           </a:p>
           <a:p xmlns:a="http://schemas.openxmlformats.org/drawingml/2006/main">
             <a:r>
-              <a:t>Это реальная разметка дорожных сцен, а не синтетические вручную заданные числа.</a:t>
+              <a:t>Это реальные аннотации дорожных сцен KITTI; целевая метка получена фиксированным правилом из наблюдаемых признаков.</a:t>
             </a:r>
           </a:p>
         </p:txBody>
@@ -1294,7 +1294,7 @@
   </p:cSld>
   <p:clrMap bg1="lt1" tx1="dk1" bg2="lt2" tx2="dk2" accent1="accent1" accent2="accent2" accent3="accent3" accent4="accent4" accent5="accent5" accent6="accent6" hlink="hlink" folHlink="folHlink"/>
   <p:sldLayoutIdLst>
-    <p:sldLayoutId xmlns:r="http://schemas.openxmlformats.org/officeDocument/2006/relationships" id="2147483649" r:id="R0f5c432406ae4a0b"/>
+    <p:sldLayoutId xmlns:r="http://schemas.openxmlformats.org/officeDocument/2006/relationships" id="2147483649" r:id="R787a97ca6591413f"/>
   </p:sldLayoutIdLst>
   <p:txStyles>
     <p:titleStyle>
@@ -1845,221 +1845,428 @@
           <p:cNvPr id="1" name="">
             <a:extLst xmlns:a="http://schemas.openxmlformats.org/drawingml/2006/main">
               <a:ext uri="{FF2B5EF4-FFF2-40B4-BE49-F238E27FC236}">
-                <a16:creationId xmlns:a16="http://schemas.microsoft.com/office/drawing/2014/main" id="{17849B2F-3E28-4568-A2EE-32B6D8E6D057}"/>
-              </a:ext>
-            </a:extLst>
-          </p:cNvPr>
-          <p:cNvSpPr>
-            <a:spLocks xmlns:a="http://schemas.openxmlformats.org/drawingml/2006/main" noGrp="1"/>
-          </p:cNvSpPr>
-          <p:nvPr/>
-        </p:nvSpPr>
-        <p:spPr>
-          <a:xfrm xmlns:a="http://schemas.openxmlformats.org/drawingml/2006/main">
-            <a:off x="666750" y="819150"/>
-            <a:ext cx="10096500" cy="1428750"/>
-          </a:xfrm>
-          <a:prstGeom xmlns:a="http://schemas.openxmlformats.org/drawingml/2006/main" prst="rect">
-            <a:avLst/>
-          </a:prstGeom>
-          <a:noFill xmlns:a="http://schemas.openxmlformats.org/drawingml/2006/main"/>
-          <a:ln xmlns:a="http://schemas.openxmlformats.org/drawingml/2006/main" w="0">
-            <a:noFill/>
-            <a:prstDash val="solid"/>
-          </a:ln>
-        </p:spPr>
-        <p:txBody>
-          <a:bodyPr xmlns:a="http://schemas.openxmlformats.org/drawingml/2006/main"/>
-          <a:lstStyle xmlns:a="http://schemas.openxmlformats.org/drawingml/2006/main"/>
-          <a:p xmlns:a="http://schemas.openxmlformats.org/drawingml/2006/main">
-            <a:pPr algn="l">
-              <a:defRPr sz="2550" b="1">
-                <a:solidFill>
-                  <a:srgbClr val="0F172A"/>
-                </a:solidFill>
-              </a:defRPr>
-            </a:pPr>
-            <a:r>
-              <a:rPr sz="2550" b="1">
-                <a:solidFill>
-                  <a:srgbClr val="0F172A"/>
-                </a:solidFill>
-              </a:rPr>
-              <a:t>Разработка методов обнаружения и обработки редких и критических сценариев в мультимодальном восприятии систем ADAS</a:t>
-            </a:r>
-          </a:p>
-        </p:txBody>
-      </p:sp>
-      <p:sp>
-        <p:nvSpPr>
-          <p:cNvPr id="2" name="">
-            <a:extLst xmlns:a="http://schemas.openxmlformats.org/drawingml/2006/main">
-              <a:ext uri="{FF2B5EF4-FFF2-40B4-BE49-F238E27FC236}">
-                <a16:creationId xmlns:a16="http://schemas.microsoft.com/office/drawing/2014/main" id="{C387BB68-D6B7-4D54-864A-C4DC7657CB8F}"/>
-              </a:ext>
-            </a:extLst>
-          </p:cNvPr>
-          <p:cNvSpPr>
-            <a:spLocks xmlns:a="http://schemas.openxmlformats.org/drawingml/2006/main" noGrp="1"/>
-          </p:cNvSpPr>
-          <p:nvPr/>
-        </p:nvSpPr>
-        <p:spPr>
-          <a:xfrm xmlns:a="http://schemas.openxmlformats.org/drawingml/2006/main">
-            <a:off x="666750" y="2305050"/>
-            <a:ext cx="8763000" cy="400050"/>
-          </a:xfrm>
-          <a:prstGeom xmlns:a="http://schemas.openxmlformats.org/drawingml/2006/main" prst="rect">
-            <a:avLst/>
-          </a:prstGeom>
-          <a:noFill xmlns:a="http://schemas.openxmlformats.org/drawingml/2006/main"/>
-          <a:ln xmlns:a="http://schemas.openxmlformats.org/drawingml/2006/main" w="0">
-            <a:noFill/>
-            <a:prstDash val="solid"/>
-          </a:ln>
-        </p:spPr>
-        <p:txBody>
-          <a:bodyPr xmlns:a="http://schemas.openxmlformats.org/drawingml/2006/main"/>
-          <a:lstStyle xmlns:a="http://schemas.openxmlformats.org/drawingml/2006/main"/>
-          <a:p xmlns:a="http://schemas.openxmlformats.org/drawingml/2006/main">
-            <a:pPr algn="l">
-              <a:defRPr sz="1800" b="0">
-                <a:solidFill>
-                  <a:srgbClr val="334155"/>
-                </a:solidFill>
-              </a:defRPr>
-            </a:pPr>
-            <a:r>
-              <a:rPr sz="1800" b="0">
-                <a:solidFill>
-                  <a:srgbClr val="334155"/>
-                </a:solidFill>
-              </a:rPr>
-              <a:t>для повышения безопасности в сложных погодных и дорожных условиях</a:t>
-            </a:r>
-          </a:p>
-        </p:txBody>
-      </p:sp>
-      <p:sp>
-        <p:nvSpPr>
-          <p:cNvPr id="3" name="">
-            <a:extLst xmlns:a="http://schemas.openxmlformats.org/drawingml/2006/main">
-              <a:ext uri="{FF2B5EF4-FFF2-40B4-BE49-F238E27FC236}">
-                <a16:creationId xmlns:a16="http://schemas.microsoft.com/office/drawing/2014/main" id="{2B3E3FA8-F155-4449-AFE9-63EDE27C1593}"/>
-              </a:ext>
-            </a:extLst>
-          </p:cNvPr>
-          <p:cNvSpPr>
-            <a:spLocks xmlns:a="http://schemas.openxmlformats.org/drawingml/2006/main" noGrp="1"/>
-          </p:cNvSpPr>
-          <p:nvPr/>
-        </p:nvSpPr>
-        <p:spPr>
-          <a:xfrm xmlns:a="http://schemas.openxmlformats.org/drawingml/2006/main">
-            <a:off x="666750" y="3619500"/>
-            <a:ext cx="4953000" cy="1257300"/>
+                <a16:creationId xmlns:a16="http://schemas.microsoft.com/office/drawing/2014/main" id="{A7453B2F-F8D4-451A-9211-7E74F18818AC}"/>
+              </a:ext>
+            </a:extLst>
+          </p:cNvPr>
+          <p:cNvSpPr>
+            <a:spLocks xmlns:a="http://schemas.openxmlformats.org/drawingml/2006/main" noGrp="1"/>
+          </p:cNvSpPr>
+          <p:nvPr/>
+        </p:nvSpPr>
+        <p:spPr>
+          <a:xfrm xmlns:a="http://schemas.openxmlformats.org/drawingml/2006/main">
+            <a:off x="304800" y="228600"/>
+            <a:ext cx="11582400" cy="6172200"/>
           </a:xfrm>
           <a:prstGeom xmlns:a="http://schemas.openxmlformats.org/drawingml/2006/main" prst="roundRect">
             <a:avLst>
-              <a:gd name="adj" fmla="val 6061"/>
+              <a:gd name="adj" fmla="val 4321"/>
+            </a:avLst>
+          </a:prstGeom>
+          <a:solidFill xmlns:a="http://schemas.openxmlformats.org/drawingml/2006/main">
+            <a:srgbClr val="2730B6"/>
+          </a:solidFill>
+          <a:ln xmlns:a="http://schemas.openxmlformats.org/drawingml/2006/main" w="0">
+            <a:solidFill>
+              <a:srgbClr val="2730B6"/>
+            </a:solidFill>
+            <a:prstDash val="solid"/>
+          </a:ln>
+        </p:spPr>
+      </p:sp>
+      <p:sp>
+        <p:nvSpPr>
+          <p:cNvPr id="2" name="">
+            <a:extLst xmlns:a="http://schemas.openxmlformats.org/drawingml/2006/main">
+              <a:ext uri="{FF2B5EF4-FFF2-40B4-BE49-F238E27FC236}">
+                <a16:creationId xmlns:a16="http://schemas.microsoft.com/office/drawing/2014/main" id="{4635F429-FD5C-41D6-89C1-78DBE7A38C9D}"/>
+              </a:ext>
+            </a:extLst>
+          </p:cNvPr>
+          <p:cNvSpPr>
+            <a:spLocks xmlns:a="http://schemas.openxmlformats.org/drawingml/2006/main" noGrp="1"/>
+          </p:cNvSpPr>
+          <p:nvPr/>
+        </p:nvSpPr>
+        <p:spPr>
+          <a:xfrm xmlns:a="http://schemas.openxmlformats.org/drawingml/2006/main">
+            <a:off x="8667750" y="1238250"/>
+            <a:ext cx="2000250" cy="2381250"/>
+          </a:xfrm>
+          <a:prstGeom xmlns:a="http://schemas.openxmlformats.org/drawingml/2006/main" prst="roundRect">
+            <a:avLst>
+              <a:gd name="adj" fmla="val 8571"/>
+            </a:avLst>
+          </a:prstGeom>
+          <a:solidFill xmlns:a="http://schemas.openxmlformats.org/drawingml/2006/main">
+            <a:srgbClr val="3F49D4"/>
+          </a:solidFill>
+          <a:ln xmlns:a="http://schemas.openxmlformats.org/drawingml/2006/main" w="9525">
+            <a:solidFill>
+              <a:srgbClr val="4F58DF"/>
+            </a:solidFill>
+            <a:prstDash val="solid"/>
+          </a:ln>
+        </p:spPr>
+      </p:sp>
+      <p:sp>
+        <p:nvSpPr>
+          <p:cNvPr id="3" name="">
+            <a:extLst xmlns:a="http://schemas.openxmlformats.org/drawingml/2006/main">
+              <a:ext uri="{FF2B5EF4-FFF2-40B4-BE49-F238E27FC236}">
+                <a16:creationId xmlns:a16="http://schemas.microsoft.com/office/drawing/2014/main" id="{28F4DD55-DE70-4542-B4B2-CCCD4BDDD708}"/>
+              </a:ext>
+            </a:extLst>
+          </p:cNvPr>
+          <p:cNvSpPr>
+            <a:spLocks xmlns:a="http://schemas.openxmlformats.org/drawingml/2006/main" noGrp="1"/>
+          </p:cNvSpPr>
+          <p:nvPr/>
+        </p:nvSpPr>
+        <p:spPr>
+          <a:xfrm xmlns:a="http://schemas.openxmlformats.org/drawingml/2006/main">
+            <a:off x="9096375" y="2114550"/>
+            <a:ext cx="1162050" cy="876300"/>
+          </a:xfrm>
+          <a:prstGeom xmlns:a="http://schemas.openxmlformats.org/drawingml/2006/main" prst="roundRect">
+            <a:avLst>
+              <a:gd name="adj" fmla="val 23913"/>
             </a:avLst>
           </a:prstGeom>
           <a:solidFill xmlns:a="http://schemas.openxmlformats.org/drawingml/2006/main">
             <a:srgbClr val="F8FAFC"/>
           </a:solidFill>
-          <a:ln xmlns:a="http://schemas.openxmlformats.org/drawingml/2006/main" w="11430">
+          <a:ln xmlns:a="http://schemas.openxmlformats.org/drawingml/2006/main" w="0">
             <a:solidFill>
-              <a:srgbClr val="94A3B8"/>
+              <a:srgbClr val="F8FAFC"/>
             </a:solidFill>
             <a:prstDash val="solid"/>
           </a:ln>
         </p:spPr>
-        <p:txBody>
-          <a:bodyPr xmlns:a="http://schemas.openxmlformats.org/drawingml/2006/main"/>
-          <a:lstStyle xmlns:a="http://schemas.openxmlformats.org/drawingml/2006/main"/>
-          <a:p xmlns:a="http://schemas.openxmlformats.org/drawingml/2006/main">
-            <a:pPr algn="ctr">
-              <a:defRPr sz="1575" b="1">
-                <a:solidFill>
-                  <a:srgbClr val="111827"/>
-                </a:solidFill>
-              </a:defRPr>
-            </a:pPr>
-            <a:r>
-              <a:rPr sz="1575" b="1">
-                <a:solidFill>
-                  <a:srgbClr val="111827"/>
-                </a:solidFill>
-              </a:rPr>
-              <a:t>Марьяновский Владислав Андреевич</a:t>
-            </a:r>
-          </a:p>
-          <a:p xmlns:a="http://schemas.openxmlformats.org/drawingml/2006/main">
-            <a:pPr algn="ctr">
-              <a:defRPr sz="1575" b="1">
-                <a:solidFill>
-                  <a:srgbClr val="111827"/>
-                </a:solidFill>
-              </a:defRPr>
-            </a:pPr>
-            <a:r>
-              <a:rPr sz="1575" b="1">
-                <a:solidFill>
-                  <a:srgbClr val="111827"/>
-                </a:solidFill>
-              </a:rPr>
-              <a:t>Группа 292405-1</a:t>
-            </a:r>
-          </a:p>
-          <a:p xmlns:a="http://schemas.openxmlformats.org/drawingml/2006/main">
-            <a:pPr algn="ctr">
-              <a:defRPr sz="1575" b="1">
-                <a:solidFill>
-                  <a:srgbClr val="111827"/>
-                </a:solidFill>
-              </a:defRPr>
-            </a:pPr>
-            <a:r>
-              <a:rPr sz="1575" b="1">
-                <a:solidFill>
-                  <a:srgbClr val="111827"/>
-                </a:solidFill>
-              </a:rPr>
-              <a:t>09.04.03 Прикладная информатика</a:t>
-            </a:r>
-          </a:p>
-        </p:txBody>
       </p:sp>
       <p:sp>
         <p:nvSpPr>
           <p:cNvPr id="4" name="">
             <a:extLst xmlns:a="http://schemas.openxmlformats.org/drawingml/2006/main">
               <a:ext uri="{FF2B5EF4-FFF2-40B4-BE49-F238E27FC236}">
-                <a16:creationId xmlns:a16="http://schemas.microsoft.com/office/drawing/2014/main" id="{56818372-D253-4191-AE5C-071FF444CCA4}"/>
-              </a:ext>
-            </a:extLst>
-          </p:cNvPr>
-          <p:cNvSpPr>
-            <a:spLocks xmlns:a="http://schemas.openxmlformats.org/drawingml/2006/main" noGrp="1"/>
-          </p:cNvSpPr>
-          <p:nvPr/>
-        </p:nvSpPr>
-        <p:spPr>
-          <a:xfrm xmlns:a="http://schemas.openxmlformats.org/drawingml/2006/main">
-            <a:off x="6191250" y="3619500"/>
-            <a:ext cx="4953000" cy="1257300"/>
+                <a16:creationId xmlns:a16="http://schemas.microsoft.com/office/drawing/2014/main" id="{FD47C648-6867-4A8F-AFFE-944C69717047}"/>
+              </a:ext>
+            </a:extLst>
+          </p:cNvPr>
+          <p:cNvSpPr>
+            <a:spLocks xmlns:a="http://schemas.openxmlformats.org/drawingml/2006/main" noGrp="1"/>
+          </p:cNvSpPr>
+          <p:nvPr/>
+        </p:nvSpPr>
+        <p:spPr>
+          <a:xfrm xmlns:a="http://schemas.openxmlformats.org/drawingml/2006/main">
+            <a:off x="781050" y="400050"/>
+            <a:ext cx="876300" cy="552450"/>
           </a:xfrm>
           <a:prstGeom xmlns:a="http://schemas.openxmlformats.org/drawingml/2006/main" prst="roundRect">
             <a:avLst>
-              <a:gd name="adj" fmla="val 6061"/>
+              <a:gd name="adj" fmla="val 10345"/>
             </a:avLst>
           </a:prstGeom>
+          <a:noFill xmlns:a="http://schemas.openxmlformats.org/drawingml/2006/main"/>
+          <a:ln xmlns:a="http://schemas.openxmlformats.org/drawingml/2006/main" w="19050">
+            <a:solidFill>
+              <a:srgbClr val="FFFFFF"/>
+            </a:solidFill>
+            <a:prstDash val="solid"/>
+          </a:ln>
+        </p:spPr>
+        <p:txBody>
+          <a:bodyPr xmlns:a="http://schemas.openxmlformats.org/drawingml/2006/main"/>
+          <a:lstStyle xmlns:a="http://schemas.openxmlformats.org/drawingml/2006/main"/>
+          <a:p xmlns:a="http://schemas.openxmlformats.org/drawingml/2006/main">
+            <a:pPr algn="ctr">
+              <a:defRPr sz="1125" b="1">
+                <a:solidFill>
+                  <a:srgbClr val="FFFFFF"/>
+                </a:solidFill>
+              </a:defRPr>
+            </a:pPr>
+            <a:r>
+              <a:rPr sz="1125" b="1">
+                <a:solidFill>
+                  <a:srgbClr val="FFFFFF"/>
+                </a:solidFill>
+              </a:rPr>
+              <a:t>ТГУ</a:t>
+            </a:r>
+          </a:p>
+        </p:txBody>
+      </p:sp>
+      <p:sp>
+        <p:nvSpPr>
+          <p:cNvPr id="5" name="">
+            <a:extLst xmlns:a="http://schemas.openxmlformats.org/drawingml/2006/main">
+              <a:ext uri="{FF2B5EF4-FFF2-40B4-BE49-F238E27FC236}">
+                <a16:creationId xmlns:a16="http://schemas.microsoft.com/office/drawing/2014/main" id="{67FECDAA-1C0A-4427-95A7-73C48D45BF26}"/>
+              </a:ext>
+            </a:extLst>
+          </p:cNvPr>
+          <p:cNvSpPr>
+            <a:spLocks xmlns:a="http://schemas.openxmlformats.org/drawingml/2006/main" noGrp="1"/>
+          </p:cNvSpPr>
+          <p:nvPr/>
+        </p:nvSpPr>
+        <p:spPr>
+          <a:xfrm xmlns:a="http://schemas.openxmlformats.org/drawingml/2006/main">
+            <a:off x="1752600" y="428625"/>
+            <a:ext cx="1809750" cy="552450"/>
+          </a:xfrm>
+          <a:prstGeom xmlns:a="http://schemas.openxmlformats.org/drawingml/2006/main" prst="rect">
+            <a:avLst/>
+          </a:prstGeom>
+          <a:noFill xmlns:a="http://schemas.openxmlformats.org/drawingml/2006/main"/>
+          <a:ln xmlns:a="http://schemas.openxmlformats.org/drawingml/2006/main" w="0">
+            <a:noFill/>
+            <a:prstDash val="solid"/>
+          </a:ln>
+        </p:spPr>
+        <p:txBody>
+          <a:bodyPr xmlns:a="http://schemas.openxmlformats.org/drawingml/2006/main"/>
+          <a:lstStyle xmlns:a="http://schemas.openxmlformats.org/drawingml/2006/main"/>
+          <a:p xmlns:a="http://schemas.openxmlformats.org/drawingml/2006/main">
+            <a:pPr algn="l">
+              <a:defRPr sz="975" b="1">
+                <a:solidFill>
+                  <a:srgbClr val="FFFFFF"/>
+                </a:solidFill>
+              </a:defRPr>
+            </a:pPr>
+            <a:r>
+              <a:rPr sz="975" b="1">
+                <a:solidFill>
+                  <a:srgbClr val="FFFFFF"/>
+                </a:solidFill>
+              </a:rPr>
+              <a:t>Томский</a:t>
+            </a:r>
+          </a:p>
+          <a:p xmlns:a="http://schemas.openxmlformats.org/drawingml/2006/main">
+            <a:pPr algn="l">
+              <a:defRPr sz="975" b="1">
+                <a:solidFill>
+                  <a:srgbClr val="FFFFFF"/>
+                </a:solidFill>
+              </a:defRPr>
+            </a:pPr>
+            <a:r>
+              <a:rPr sz="975" b="1">
+                <a:solidFill>
+                  <a:srgbClr val="FFFFFF"/>
+                </a:solidFill>
+              </a:rPr>
+              <a:t>государственный</a:t>
+            </a:r>
+          </a:p>
+          <a:p xmlns:a="http://schemas.openxmlformats.org/drawingml/2006/main">
+            <a:pPr algn="l">
+              <a:defRPr sz="975" b="1">
+                <a:solidFill>
+                  <a:srgbClr val="FFFFFF"/>
+                </a:solidFill>
+              </a:defRPr>
+            </a:pPr>
+            <a:r>
+              <a:rPr sz="975" b="1">
+                <a:solidFill>
+                  <a:srgbClr val="FFFFFF"/>
+                </a:solidFill>
+              </a:rPr>
+              <a:t>университет</a:t>
+            </a:r>
+          </a:p>
+        </p:txBody>
+      </p:sp>
+      <p:sp>
+        <p:nvSpPr>
+          <p:cNvPr id="6" name="">
+            <a:extLst xmlns:a="http://schemas.openxmlformats.org/drawingml/2006/main">
+              <a:ext uri="{FF2B5EF4-FFF2-40B4-BE49-F238E27FC236}">
+                <a16:creationId xmlns:a16="http://schemas.microsoft.com/office/drawing/2014/main" id="{87122F36-CEF4-4313-AC72-161C4AF9468B}"/>
+              </a:ext>
+            </a:extLst>
+          </p:cNvPr>
+          <p:cNvSpPr>
+            <a:spLocks xmlns:a="http://schemas.openxmlformats.org/drawingml/2006/main" noGrp="1"/>
+          </p:cNvSpPr>
+          <p:nvPr/>
+        </p:nvSpPr>
+        <p:spPr>
+          <a:xfrm xmlns:a="http://schemas.openxmlformats.org/drawingml/2006/main">
+            <a:off x="3886200" y="400050"/>
+            <a:ext cx="876300" cy="552450"/>
+          </a:xfrm>
+          <a:prstGeom xmlns:a="http://schemas.openxmlformats.org/drawingml/2006/main" prst="roundRect">
+            <a:avLst>
+              <a:gd name="adj" fmla="val 10345"/>
+            </a:avLst>
+          </a:prstGeom>
+          <a:noFill xmlns:a="http://schemas.openxmlformats.org/drawingml/2006/main"/>
+          <a:ln xmlns:a="http://schemas.openxmlformats.org/drawingml/2006/main" w="19050">
+            <a:solidFill>
+              <a:srgbClr val="FFFFFF"/>
+            </a:solidFill>
+            <a:prstDash val="solid"/>
+          </a:ln>
+        </p:spPr>
+        <p:txBody>
+          <a:bodyPr xmlns:a="http://schemas.openxmlformats.org/drawingml/2006/main"/>
+          <a:lstStyle xmlns:a="http://schemas.openxmlformats.org/drawingml/2006/main"/>
+          <a:p xmlns:a="http://schemas.openxmlformats.org/drawingml/2006/main">
+            <a:pPr algn="ctr">
+              <a:defRPr sz="1125" b="1">
+                <a:solidFill>
+                  <a:srgbClr val="FFFFFF"/>
+                </a:solidFill>
+              </a:defRPr>
+            </a:pPr>
+            <a:r>
+              <a:rPr sz="1125" b="1">
+                <a:solidFill>
+                  <a:srgbClr val="FFFFFF"/>
+                </a:solidFill>
+              </a:rPr>
+              <a:t>IDO</a:t>
+            </a:r>
+          </a:p>
+        </p:txBody>
+      </p:sp>
+      <p:sp>
+        <p:nvSpPr>
+          <p:cNvPr id="7" name="">
+            <a:extLst xmlns:a="http://schemas.openxmlformats.org/drawingml/2006/main">
+              <a:ext uri="{FF2B5EF4-FFF2-40B4-BE49-F238E27FC236}">
+                <a16:creationId xmlns:a16="http://schemas.microsoft.com/office/drawing/2014/main" id="{1900ADA4-847A-4E3F-BA7F-1274221C17C7}"/>
+              </a:ext>
+            </a:extLst>
+          </p:cNvPr>
+          <p:cNvSpPr>
+            <a:spLocks xmlns:a="http://schemas.openxmlformats.org/drawingml/2006/main" noGrp="1"/>
+          </p:cNvSpPr>
+          <p:nvPr/>
+        </p:nvSpPr>
+        <p:spPr>
+          <a:xfrm xmlns:a="http://schemas.openxmlformats.org/drawingml/2006/main">
+            <a:off x="723900" y="1504950"/>
+            <a:ext cx="7334250" cy="1428750"/>
+          </a:xfrm>
+          <a:prstGeom xmlns:a="http://schemas.openxmlformats.org/drawingml/2006/main" prst="rect">
+            <a:avLst/>
+          </a:prstGeom>
+          <a:noFill xmlns:a="http://schemas.openxmlformats.org/drawingml/2006/main"/>
+          <a:ln xmlns:a="http://schemas.openxmlformats.org/drawingml/2006/main" w="0">
+            <a:noFill/>
+            <a:prstDash val="solid"/>
+          </a:ln>
+        </p:spPr>
+        <p:txBody>
+          <a:bodyPr xmlns:a="http://schemas.openxmlformats.org/drawingml/2006/main"/>
+          <a:lstStyle xmlns:a="http://schemas.openxmlformats.org/drawingml/2006/main"/>
+          <a:p xmlns:a="http://schemas.openxmlformats.org/drawingml/2006/main">
+            <a:pPr algn="l">
+              <a:defRPr sz="2550" b="1">
+                <a:solidFill>
+                  <a:srgbClr val="FFFFFF"/>
+                </a:solidFill>
+              </a:defRPr>
+            </a:pPr>
+            <a:r>
+              <a:rPr sz="2550" b="1">
+                <a:solidFill>
+                  <a:srgbClr val="FFFFFF"/>
+                </a:solidFill>
+              </a:rPr>
+              <a:t>Разработка методов обнаружения и обработки редких и критических сценариев в мультимодальном восприятии систем ADAS</a:t>
+            </a:r>
+          </a:p>
+        </p:txBody>
+      </p:sp>
+      <p:sp>
+        <p:nvSpPr>
+          <p:cNvPr id="8" name="">
+            <a:extLst xmlns:a="http://schemas.openxmlformats.org/drawingml/2006/main">
+              <a:ext uri="{FF2B5EF4-FFF2-40B4-BE49-F238E27FC236}">
+                <a16:creationId xmlns:a16="http://schemas.microsoft.com/office/drawing/2014/main" id="{318C67D6-680A-417A-932D-B710C233C0EB}"/>
+              </a:ext>
+            </a:extLst>
+          </p:cNvPr>
+          <p:cNvSpPr>
+            <a:spLocks xmlns:a="http://schemas.openxmlformats.org/drawingml/2006/main" noGrp="1"/>
+          </p:cNvSpPr>
+          <p:nvPr/>
+        </p:nvSpPr>
+        <p:spPr>
+          <a:xfrm xmlns:a="http://schemas.openxmlformats.org/drawingml/2006/main">
+            <a:off x="723900" y="3067050"/>
+            <a:ext cx="7239000" cy="400050"/>
+          </a:xfrm>
+          <a:prstGeom xmlns:a="http://schemas.openxmlformats.org/drawingml/2006/main" prst="rect">
+            <a:avLst/>
+          </a:prstGeom>
+          <a:noFill xmlns:a="http://schemas.openxmlformats.org/drawingml/2006/main"/>
+          <a:ln xmlns:a="http://schemas.openxmlformats.org/drawingml/2006/main" w="0">
+            <a:noFill/>
+            <a:prstDash val="solid"/>
+          </a:ln>
+        </p:spPr>
+        <p:txBody>
+          <a:bodyPr xmlns:a="http://schemas.openxmlformats.org/drawingml/2006/main"/>
+          <a:lstStyle xmlns:a="http://schemas.openxmlformats.org/drawingml/2006/main"/>
+          <a:p xmlns:a="http://schemas.openxmlformats.org/drawingml/2006/main">
+            <a:pPr algn="l">
+              <a:defRPr sz="1800" b="0">
+                <a:solidFill>
+                  <a:srgbClr val="DBEAFE"/>
+                </a:solidFill>
+              </a:defRPr>
+            </a:pPr>
+            <a:r>
+              <a:rPr sz="1800" b="0">
+                <a:solidFill>
+                  <a:srgbClr val="DBEAFE"/>
+                </a:solidFill>
+              </a:rPr>
+              <a:t>для повышения безопасности в сложных погодных и дорожных условиях</a:t>
+            </a:r>
+          </a:p>
+        </p:txBody>
+      </p:sp>
+      <p:sp>
+        <p:nvSpPr>
+          <p:cNvPr id="9" name="">
+            <a:extLst xmlns:a="http://schemas.openxmlformats.org/drawingml/2006/main">
+              <a:ext uri="{FF2B5EF4-FFF2-40B4-BE49-F238E27FC236}">
+                <a16:creationId xmlns:a16="http://schemas.microsoft.com/office/drawing/2014/main" id="{515347BA-195B-4E6C-986F-8EAC050FCB6C}"/>
+              </a:ext>
+            </a:extLst>
+          </p:cNvPr>
+          <p:cNvSpPr>
+            <a:spLocks xmlns:a="http://schemas.openxmlformats.org/drawingml/2006/main" noGrp="1"/>
+          </p:cNvSpPr>
+          <p:nvPr/>
+        </p:nvSpPr>
+        <p:spPr>
+          <a:xfrm xmlns:a="http://schemas.openxmlformats.org/drawingml/2006/main">
+            <a:off x="723900" y="4095750"/>
+            <a:ext cx="4762500" cy="1219200"/>
+          </a:xfrm>
+          <a:prstGeom xmlns:a="http://schemas.openxmlformats.org/drawingml/2006/main" prst="roundRect">
+            <a:avLst>
+              <a:gd name="adj" fmla="val 6250"/>
+            </a:avLst>
+          </a:prstGeom>
           <a:solidFill xmlns:a="http://schemas.openxmlformats.org/drawingml/2006/main">
-            <a:srgbClr val="ECFEFF"/>
+            <a:srgbClr val="FFFFFF"/>
           </a:solidFill>
           <a:ln xmlns:a="http://schemas.openxmlformats.org/drawingml/2006/main" w="11430">
             <a:solidFill>
-              <a:srgbClr val="0F766E"/>
+              <a:srgbClr val="FFFFFF"/>
             </a:solidFill>
             <a:prstDash val="solid"/>
           </a:ln>
@@ -2081,7 +2288,7 @@
                   <a:srgbClr val="111827"/>
                 </a:solidFill>
               </a:rPr>
-              <a:t>НИ ТГУ · Институт дистанционного образования</a:t>
+              <a:t>Марьяновский Владислав Андреевич</a:t>
             </a:r>
           </a:p>
           <a:p xmlns:a="http://schemas.openxmlformats.org/drawingml/2006/main">
@@ -2098,7 +2305,7 @@
                   <a:srgbClr val="111827"/>
                 </a:solidFill>
               </a:rPr>
-              <a:t>Профиль: компьютерное зрение и нейронные сети</a:t>
+              <a:t>Группа 292405-1</a:t>
             </a:r>
           </a:p>
           <a:p xmlns:a="http://schemas.openxmlformats.org/drawingml/2006/main">
@@ -2115,6 +2322,96 @@
                   <a:srgbClr val="111827"/>
                 </a:solidFill>
               </a:rPr>
+              <a:t>09.04.03 Прикладная информатика</a:t>
+            </a:r>
+          </a:p>
+        </p:txBody>
+      </p:sp>
+      <p:sp>
+        <p:nvSpPr>
+          <p:cNvPr id="10" name="">
+            <a:extLst xmlns:a="http://schemas.openxmlformats.org/drawingml/2006/main">
+              <a:ext uri="{FF2B5EF4-FFF2-40B4-BE49-F238E27FC236}">
+                <a16:creationId xmlns:a16="http://schemas.microsoft.com/office/drawing/2014/main" id="{3944F75F-1F6A-4A0C-8EC7-E933D2399DF5}"/>
+              </a:ext>
+            </a:extLst>
+          </p:cNvPr>
+          <p:cNvSpPr>
+            <a:spLocks xmlns:a="http://schemas.openxmlformats.org/drawingml/2006/main" noGrp="1"/>
+          </p:cNvSpPr>
+          <p:nvPr/>
+        </p:nvSpPr>
+        <p:spPr>
+          <a:xfrm xmlns:a="http://schemas.openxmlformats.org/drawingml/2006/main">
+            <a:off x="6000750" y="4095750"/>
+            <a:ext cx="4953000" cy="1219200"/>
+          </a:xfrm>
+          <a:prstGeom xmlns:a="http://schemas.openxmlformats.org/drawingml/2006/main" prst="roundRect">
+            <a:avLst>
+              <a:gd name="adj" fmla="val 6250"/>
+            </a:avLst>
+          </a:prstGeom>
+          <a:solidFill xmlns:a="http://schemas.openxmlformats.org/drawingml/2006/main">
+            <a:srgbClr val="EEF2FF"/>
+          </a:solidFill>
+          <a:ln xmlns:a="http://schemas.openxmlformats.org/drawingml/2006/main" w="11430">
+            <a:solidFill>
+              <a:srgbClr val="FFFFFF"/>
+            </a:solidFill>
+            <a:prstDash val="solid"/>
+          </a:ln>
+        </p:spPr>
+        <p:txBody>
+          <a:bodyPr xmlns:a="http://schemas.openxmlformats.org/drawingml/2006/main"/>
+          <a:lstStyle xmlns:a="http://schemas.openxmlformats.org/drawingml/2006/main"/>
+          <a:p xmlns:a="http://schemas.openxmlformats.org/drawingml/2006/main">
+            <a:pPr algn="ctr">
+              <a:defRPr sz="1575" b="1">
+                <a:solidFill>
+                  <a:srgbClr val="111827"/>
+                </a:solidFill>
+              </a:defRPr>
+            </a:pPr>
+            <a:r>
+              <a:rPr sz="1575" b="1">
+                <a:solidFill>
+                  <a:srgbClr val="111827"/>
+                </a:solidFill>
+              </a:rPr>
+              <a:t>НИ ТГУ · Институт дистанционного образования</a:t>
+            </a:r>
+          </a:p>
+          <a:p xmlns:a="http://schemas.openxmlformats.org/drawingml/2006/main">
+            <a:pPr algn="ctr">
+              <a:defRPr sz="1575" b="1">
+                <a:solidFill>
+                  <a:srgbClr val="111827"/>
+                </a:solidFill>
+              </a:defRPr>
+            </a:pPr>
+            <a:r>
+              <a:rPr sz="1575" b="1">
+                <a:solidFill>
+                  <a:srgbClr val="111827"/>
+                </a:solidFill>
+              </a:rPr>
+              <a:t>Профиль: компьютерное зрение и нейронные сети</a:t>
+            </a:r>
+          </a:p>
+          <a:p xmlns:a="http://schemas.openxmlformats.org/drawingml/2006/main">
+            <a:pPr algn="ctr">
+              <a:defRPr sz="1575" b="1">
+                <a:solidFill>
+                  <a:srgbClr val="111827"/>
+                </a:solidFill>
+              </a:defRPr>
+            </a:pPr>
+            <a:r>
+              <a:rPr sz="1575" b="1">
+                <a:solidFill>
+                  <a:srgbClr val="111827"/>
+                </a:solidFill>
+              </a:rPr>
               <a:t>Томск · 2026</a:t>
             </a:r>
           </a:p>
@@ -2122,10 +2419,10 @@
       </p:sp>
       <p:sp>
         <p:nvSpPr>
-          <p:cNvPr id="5" name="">
-            <a:extLst xmlns:a="http://schemas.openxmlformats.org/drawingml/2006/main">
-              <a:ext uri="{FF2B5EF4-FFF2-40B4-BE49-F238E27FC236}">
-                <a16:creationId xmlns:a16="http://schemas.microsoft.com/office/drawing/2014/main" id="{4D748E88-86C5-49B5-B238-888E82F91117}"/>
+          <p:cNvPr id="11" name="">
+            <a:extLst xmlns:a="http://schemas.openxmlformats.org/drawingml/2006/main">
+              <a:ext uri="{FF2B5EF4-FFF2-40B4-BE49-F238E27FC236}">
+                <a16:creationId xmlns:a16="http://schemas.microsoft.com/office/drawing/2014/main" id="{71618E0E-8BEC-4B1A-9129-E8E47299D72A}"/>
               </a:ext>
             </a:extLst>
           </p:cNvPr>
@@ -2155,14 +2452,14 @@
             <a:pPr algn="l">
               <a:defRPr sz="975" b="0">
                 <a:solidFill>
-                  <a:srgbClr val="64748B"/>
+                  <a:srgbClr val="DBEAFE"/>
                 </a:solidFill>
               </a:defRPr>
             </a:pPr>
             <a:r>
               <a:rPr sz="975" b="0">
                 <a:solidFill>
-                  <a:srgbClr val="64748B"/>
+                  <a:srgbClr val="DBEAFE"/>
                 </a:solidFill>
               </a:rPr>
               <a:t>ADAS ScenarioGuard · ВКР · 2026</a:t>
@@ -2172,10 +2469,10 @@
       </p:sp>
       <p:sp>
         <p:nvSpPr>
-          <p:cNvPr id="6" name="">
-            <a:extLst xmlns:a="http://schemas.openxmlformats.org/drawingml/2006/main">
-              <a:ext uri="{FF2B5EF4-FFF2-40B4-BE49-F238E27FC236}">
-                <a16:creationId xmlns:a16="http://schemas.microsoft.com/office/drawing/2014/main" id="{AA1E25E1-EE31-4754-BF0C-828035A2173A}"/>
+          <p:cNvPr id="12" name="">
+            <a:extLst xmlns:a="http://schemas.openxmlformats.org/drawingml/2006/main">
+              <a:ext uri="{FF2B5EF4-FFF2-40B4-BE49-F238E27FC236}">
+                <a16:creationId xmlns:a16="http://schemas.microsoft.com/office/drawing/2014/main" id="{CEE325CD-61BD-4372-AED0-4DA29B0B60A2}"/>
               </a:ext>
             </a:extLst>
           </p:cNvPr>
@@ -2205,14 +2502,14 @@
             <a:pPr algn="r">
               <a:defRPr sz="975" b="0">
                 <a:solidFill>
-                  <a:srgbClr val="64748B"/>
+                  <a:srgbClr val="DBEAFE"/>
                 </a:solidFill>
               </a:defRPr>
             </a:pPr>
             <a:r>
               <a:rPr sz="975" b="0">
                 <a:solidFill>
-                  <a:srgbClr val="64748B"/>
+                  <a:srgbClr val="DBEAFE"/>
                 </a:solidFill>
               </a:rPr>
               <a:t>1</a:t>
@@ -2223,7 +2520,7 @@
     </p:spTree>
     <p:extLst>
       <p:ext uri="{BB962C8B-B14F-4D97-AF65-F5344CB8AC3E}">
-        <p14:creationId xmlns:p14="http://schemas.microsoft.com/office/powerpoint/2010/main" val="408216278"/>
+        <p14:creationId xmlns:p14="http://schemas.microsoft.com/office/powerpoint/2010/main" val="1288575013"/>
       </p:ext>
     </p:extLst>
   </p:cSld>
@@ -2254,7 +2551,173 @@
           <p:cNvPr id="1" name="">
             <a:extLst xmlns:a="http://schemas.openxmlformats.org/drawingml/2006/main">
               <a:ext uri="{FF2B5EF4-FFF2-40B4-BE49-F238E27FC236}">
-                <a16:creationId xmlns:a16="http://schemas.microsoft.com/office/drawing/2014/main" id="{94884813-92BF-406A-AE05-BDE8D5FF9316}"/>
+                <a16:creationId xmlns:a16="http://schemas.microsoft.com/office/drawing/2014/main" id="{F5E9667A-A205-40CB-9CC9-C4225C4D9248}"/>
+              </a:ext>
+            </a:extLst>
+          </p:cNvPr>
+          <p:cNvSpPr>
+            <a:spLocks xmlns:a="http://schemas.openxmlformats.org/drawingml/2006/main" noGrp="1"/>
+          </p:cNvSpPr>
+          <p:nvPr/>
+        </p:nvSpPr>
+        <p:spPr>
+          <a:xfrm xmlns:a="http://schemas.openxmlformats.org/drawingml/2006/main">
+            <a:off x="0" y="0"/>
+            <a:ext cx="12192000" cy="171450"/>
+          </a:xfrm>
+          <a:prstGeom xmlns:a="http://schemas.openxmlformats.org/drawingml/2006/main" prst="rect">
+            <a:avLst/>
+          </a:prstGeom>
+          <a:solidFill xmlns:a="http://schemas.openxmlformats.org/drawingml/2006/main">
+            <a:srgbClr val="2730B6"/>
+          </a:solidFill>
+          <a:ln xmlns:a="http://schemas.openxmlformats.org/drawingml/2006/main" w="0">
+            <a:solidFill>
+              <a:srgbClr val="2730B6"/>
+            </a:solidFill>
+            <a:prstDash val="solid"/>
+          </a:ln>
+        </p:spPr>
+      </p:sp>
+      <p:sp>
+        <p:nvSpPr>
+          <p:cNvPr id="2" name="">
+            <a:extLst xmlns:a="http://schemas.openxmlformats.org/drawingml/2006/main">
+              <a:ext uri="{FF2B5EF4-FFF2-40B4-BE49-F238E27FC236}">
+                <a16:creationId xmlns:a16="http://schemas.microsoft.com/office/drawing/2014/main" id="{B7E13FE2-4C75-45A5-BF44-4CA2B47666F8}"/>
+              </a:ext>
+            </a:extLst>
+          </p:cNvPr>
+          <p:cNvSpPr>
+            <a:spLocks xmlns:a="http://schemas.openxmlformats.org/drawingml/2006/main" noGrp="1"/>
+          </p:cNvSpPr>
+          <p:nvPr/>
+        </p:nvSpPr>
+        <p:spPr>
+          <a:xfrm xmlns:a="http://schemas.openxmlformats.org/drawingml/2006/main">
+            <a:off x="0" y="0"/>
+            <a:ext cx="171450" cy="6858000"/>
+          </a:xfrm>
+          <a:prstGeom xmlns:a="http://schemas.openxmlformats.org/drawingml/2006/main" prst="rect">
+            <a:avLst/>
+          </a:prstGeom>
+          <a:solidFill xmlns:a="http://schemas.openxmlformats.org/drawingml/2006/main">
+            <a:srgbClr val="2730B6"/>
+          </a:solidFill>
+          <a:ln xmlns:a="http://schemas.openxmlformats.org/drawingml/2006/main" w="0">
+            <a:solidFill>
+              <a:srgbClr val="2730B6"/>
+            </a:solidFill>
+            <a:prstDash val="solid"/>
+          </a:ln>
+        </p:spPr>
+      </p:sp>
+      <p:sp>
+        <p:nvSpPr>
+          <p:cNvPr id="3" name="">
+            <a:extLst xmlns:a="http://schemas.openxmlformats.org/drawingml/2006/main">
+              <a:ext uri="{FF2B5EF4-FFF2-40B4-BE49-F238E27FC236}">
+                <a16:creationId xmlns:a16="http://schemas.microsoft.com/office/drawing/2014/main" id="{5970A187-50D4-4494-918C-0E0490C837FB}"/>
+              </a:ext>
+            </a:extLst>
+          </p:cNvPr>
+          <p:cNvSpPr>
+            <a:spLocks xmlns:a="http://schemas.openxmlformats.org/drawingml/2006/main" noGrp="1"/>
+          </p:cNvSpPr>
+          <p:nvPr/>
+        </p:nvSpPr>
+        <p:spPr>
+          <a:xfrm xmlns:a="http://schemas.openxmlformats.org/drawingml/2006/main">
+            <a:off x="9810750" y="400050"/>
+            <a:ext cx="1428750" cy="228600"/>
+          </a:xfrm>
+          <a:prstGeom xmlns:a="http://schemas.openxmlformats.org/drawingml/2006/main" prst="rect">
+            <a:avLst/>
+          </a:prstGeom>
+          <a:noFill xmlns:a="http://schemas.openxmlformats.org/drawingml/2006/main"/>
+          <a:ln xmlns:a="http://schemas.openxmlformats.org/drawingml/2006/main" w="0">
+            <a:noFill/>
+            <a:prstDash val="solid"/>
+          </a:ln>
+        </p:spPr>
+        <p:txBody>
+          <a:bodyPr xmlns:a="http://schemas.openxmlformats.org/drawingml/2006/main"/>
+          <a:lstStyle xmlns:a="http://schemas.openxmlformats.org/drawingml/2006/main"/>
+          <a:p xmlns:a="http://schemas.openxmlformats.org/drawingml/2006/main">
+            <a:pPr algn="l">
+              <a:defRPr sz="975" b="1">
+                <a:solidFill>
+                  <a:srgbClr val="2730B6"/>
+                </a:solidFill>
+              </a:defRPr>
+            </a:pPr>
+            <a:r>
+              <a:rPr sz="975" b="1">
+                <a:solidFill>
+                  <a:srgbClr val="2730B6"/>
+                </a:solidFill>
+              </a:rPr>
+              <a:t>НИ ТГУ · ИДО</a:t>
+            </a:r>
+          </a:p>
+        </p:txBody>
+      </p:sp>
+      <p:sp>
+        <p:nvSpPr>
+          <p:cNvPr id="4" name="">
+            <a:extLst xmlns:a="http://schemas.openxmlformats.org/drawingml/2006/main">
+              <a:ext uri="{FF2B5EF4-FFF2-40B4-BE49-F238E27FC236}">
+                <a16:creationId xmlns:a16="http://schemas.microsoft.com/office/drawing/2014/main" id="{A4FEF7D7-5008-464B-BF5E-B31D4930F317}"/>
+              </a:ext>
+            </a:extLst>
+          </p:cNvPr>
+          <p:cNvSpPr>
+            <a:spLocks xmlns:a="http://schemas.openxmlformats.org/drawingml/2006/main" noGrp="1"/>
+          </p:cNvSpPr>
+          <p:nvPr/>
+        </p:nvSpPr>
+        <p:spPr>
+          <a:xfrm xmlns:a="http://schemas.openxmlformats.org/drawingml/2006/main">
+            <a:off x="11382375" y="400050"/>
+            <a:ext cx="361950" cy="228600"/>
+          </a:xfrm>
+          <a:prstGeom xmlns:a="http://schemas.openxmlformats.org/drawingml/2006/main" prst="rect">
+            <a:avLst/>
+          </a:prstGeom>
+          <a:noFill xmlns:a="http://schemas.openxmlformats.org/drawingml/2006/main"/>
+          <a:ln xmlns:a="http://schemas.openxmlformats.org/drawingml/2006/main" w="0">
+            <a:noFill/>
+            <a:prstDash val="solid"/>
+          </a:ln>
+        </p:spPr>
+        <p:txBody>
+          <a:bodyPr xmlns:a="http://schemas.openxmlformats.org/drawingml/2006/main"/>
+          <a:lstStyle xmlns:a="http://schemas.openxmlformats.org/drawingml/2006/main"/>
+          <a:p xmlns:a="http://schemas.openxmlformats.org/drawingml/2006/main">
+            <a:pPr algn="r">
+              <a:defRPr sz="975" b="0">
+                <a:solidFill>
+                  <a:srgbClr val="2730B6"/>
+                </a:solidFill>
+              </a:defRPr>
+            </a:pPr>
+            <a:r>
+              <a:rPr sz="975" b="0">
+                <a:solidFill>
+                  <a:srgbClr val="2730B6"/>
+                </a:solidFill>
+              </a:rPr>
+              <a:t>10</a:t>
+            </a:r>
+          </a:p>
+        </p:txBody>
+      </p:sp>
+      <p:sp>
+        <p:nvSpPr>
+          <p:cNvPr id="5" name="">
+            <a:extLst xmlns:a="http://schemas.openxmlformats.org/drawingml/2006/main">
+              <a:ext uri="{FF2B5EF4-FFF2-40B4-BE49-F238E27FC236}">
+                <a16:creationId xmlns:a16="http://schemas.microsoft.com/office/drawing/2014/main" id="{04516874-257D-41DD-999C-70E07749FB06}"/>
               </a:ext>
             </a:extLst>
           </p:cNvPr>
@@ -2301,10 +2764,10 @@
       </p:sp>
       <p:sp>
         <p:nvSpPr>
-          <p:cNvPr id="2" name="">
-            <a:extLst xmlns:a="http://schemas.openxmlformats.org/drawingml/2006/main">
-              <a:ext uri="{FF2B5EF4-FFF2-40B4-BE49-F238E27FC236}">
-                <a16:creationId xmlns:a16="http://schemas.microsoft.com/office/drawing/2014/main" id="{34030041-2CE7-42D6-B90F-0923FC87DFBF}"/>
+          <p:cNvPr id="6" name="">
+            <a:extLst xmlns:a="http://schemas.openxmlformats.org/drawingml/2006/main">
+              <a:ext uri="{FF2B5EF4-FFF2-40B4-BE49-F238E27FC236}">
+                <a16:creationId xmlns:a16="http://schemas.microsoft.com/office/drawing/2014/main" id="{E465EF18-FC41-4686-BE73-90A7BA5AFEE0}"/>
               </a:ext>
             </a:extLst>
           </p:cNvPr>
@@ -2322,11 +2785,11 @@
             <a:avLst/>
           </a:prstGeom>
           <a:solidFill xmlns:a="http://schemas.openxmlformats.org/drawingml/2006/main">
-            <a:srgbClr val="0F766E"/>
+            <a:srgbClr val="36D2CF"/>
           </a:solidFill>
           <a:ln xmlns:a="http://schemas.openxmlformats.org/drawingml/2006/main" w="0">
             <a:solidFill>
-              <a:srgbClr val="0F766E"/>
+              <a:srgbClr val="36D2CF"/>
             </a:solidFill>
             <a:prstDash val="solid"/>
           </a:ln>
@@ -2334,10 +2797,10 @@
       </p:sp>
       <p:sp>
         <p:nvSpPr>
-          <p:cNvPr id="3" name="">
-            <a:extLst xmlns:a="http://schemas.openxmlformats.org/drawingml/2006/main">
-              <a:ext uri="{FF2B5EF4-FFF2-40B4-BE49-F238E27FC236}">
-                <a16:creationId xmlns:a16="http://schemas.microsoft.com/office/drawing/2014/main" id="{3DFD93E4-E5FF-437C-9C38-940F1C18E045}"/>
+          <p:cNvPr id="7" name="">
+            <a:extLst xmlns:a="http://schemas.openxmlformats.org/drawingml/2006/main">
+              <a:ext uri="{FF2B5EF4-FFF2-40B4-BE49-F238E27FC236}">
+                <a16:creationId xmlns:a16="http://schemas.microsoft.com/office/drawing/2014/main" id="{424A5367-BBC6-4473-A74F-6692BDA74F0C}"/>
               </a:ext>
             </a:extLst>
           </p:cNvPr>
@@ -2407,10 +2870,10 @@
       </p:sp>
       <p:sp>
         <p:nvSpPr>
-          <p:cNvPr id="4" name="">
-            <a:extLst xmlns:a="http://schemas.openxmlformats.org/drawingml/2006/main">
-              <a:ext uri="{FF2B5EF4-FFF2-40B4-BE49-F238E27FC236}">
-                <a16:creationId xmlns:a16="http://schemas.microsoft.com/office/drawing/2014/main" id="{94B8A9B9-5F76-41C7-A90A-E40D8A0F3655}"/>
+          <p:cNvPr id="8" name="">
+            <a:extLst xmlns:a="http://schemas.openxmlformats.org/drawingml/2006/main">
+              <a:ext uri="{FF2B5EF4-FFF2-40B4-BE49-F238E27FC236}">
+                <a16:creationId xmlns:a16="http://schemas.microsoft.com/office/drawing/2014/main" id="{F909C4E5-8F06-4E41-91BC-73FEC82C3686}"/>
               </a:ext>
             </a:extLst>
           </p:cNvPr>
@@ -2480,10 +2943,10 @@
       </p:sp>
       <p:sp>
         <p:nvSpPr>
-          <p:cNvPr id="5" name="">
-            <a:extLst xmlns:a="http://schemas.openxmlformats.org/drawingml/2006/main">
-              <a:ext uri="{FF2B5EF4-FFF2-40B4-BE49-F238E27FC236}">
-                <a16:creationId xmlns:a16="http://schemas.microsoft.com/office/drawing/2014/main" id="{DAF08F52-ACA1-413C-AB03-BE450CCDCBF5}"/>
+          <p:cNvPr id="9" name="">
+            <a:extLst xmlns:a="http://schemas.openxmlformats.org/drawingml/2006/main">
+              <a:ext uri="{FF2B5EF4-FFF2-40B4-BE49-F238E27FC236}">
+                <a16:creationId xmlns:a16="http://schemas.microsoft.com/office/drawing/2014/main" id="{63D8CA0B-FA5D-4CF0-868F-1FDC7EC6A57F}"/>
               </a:ext>
             </a:extLst>
           </p:cNvPr>
@@ -2553,10 +3016,10 @@
       </p:sp>
       <p:sp>
         <p:nvSpPr>
-          <p:cNvPr id="6" name="">
-            <a:extLst xmlns:a="http://schemas.openxmlformats.org/drawingml/2006/main">
-              <a:ext uri="{FF2B5EF4-FFF2-40B4-BE49-F238E27FC236}">
-                <a16:creationId xmlns:a16="http://schemas.microsoft.com/office/drawing/2014/main" id="{D542A5F9-42A5-494C-8A06-3A0EC86C026B}"/>
+          <p:cNvPr id="10" name="">
+            <a:extLst xmlns:a="http://schemas.openxmlformats.org/drawingml/2006/main">
+              <a:ext uri="{FF2B5EF4-FFF2-40B4-BE49-F238E27FC236}">
+                <a16:creationId xmlns:a16="http://schemas.microsoft.com/office/drawing/2014/main" id="{94F37D9E-68C8-42CB-BCB4-152E74977093}"/>
               </a:ext>
             </a:extLst>
           </p:cNvPr>
@@ -2586,14 +3049,14 @@
             <a:pPr algn="l">
               <a:defRPr sz="1725" b="1">
                 <a:solidFill>
-                  <a:srgbClr val="0F766E"/>
+                  <a:srgbClr val="2730B6"/>
                 </a:solidFill>
               </a:defRPr>
             </a:pPr>
             <a:r>
               <a:rPr sz="1725" b="1">
                 <a:solidFill>
-                  <a:srgbClr val="0F766E"/>
+                  <a:srgbClr val="2730B6"/>
                 </a:solidFill>
               </a:rPr>
               <a:t>•</a:t>
@@ -2603,10 +3066,10 @@
       </p:sp>
       <p:sp>
         <p:nvSpPr>
-          <p:cNvPr id="7" name="">
-            <a:extLst xmlns:a="http://schemas.openxmlformats.org/drawingml/2006/main">
-              <a:ext uri="{FF2B5EF4-FFF2-40B4-BE49-F238E27FC236}">
-                <a16:creationId xmlns:a16="http://schemas.microsoft.com/office/drawing/2014/main" id="{9643F642-CA8E-41F2-A457-FA60D78D1BC5}"/>
+          <p:cNvPr id="11" name="">
+            <a:extLst xmlns:a="http://schemas.openxmlformats.org/drawingml/2006/main">
+              <a:ext uri="{FF2B5EF4-FFF2-40B4-BE49-F238E27FC236}">
+                <a16:creationId xmlns:a16="http://schemas.microsoft.com/office/drawing/2014/main" id="{0F6F5D41-ED1A-481D-94F4-27B5A4B009EC}"/>
               </a:ext>
             </a:extLst>
           </p:cNvPr>
@@ -2653,10 +3116,10 @@
       </p:sp>
       <p:sp>
         <p:nvSpPr>
-          <p:cNvPr id="8" name="">
-            <a:extLst xmlns:a="http://schemas.openxmlformats.org/drawingml/2006/main">
-              <a:ext uri="{FF2B5EF4-FFF2-40B4-BE49-F238E27FC236}">
-                <a16:creationId xmlns:a16="http://schemas.microsoft.com/office/drawing/2014/main" id="{84845478-27BA-4957-82E2-36941A215F0C}"/>
+          <p:cNvPr id="12" name="">
+            <a:extLst xmlns:a="http://schemas.openxmlformats.org/drawingml/2006/main">
+              <a:ext uri="{FF2B5EF4-FFF2-40B4-BE49-F238E27FC236}">
+                <a16:creationId xmlns:a16="http://schemas.microsoft.com/office/drawing/2014/main" id="{9041C964-D03D-4193-857C-55519C1EB76D}"/>
               </a:ext>
             </a:extLst>
           </p:cNvPr>
@@ -2686,14 +3149,14 @@
             <a:pPr algn="l">
               <a:defRPr sz="1725" b="1">
                 <a:solidFill>
-                  <a:srgbClr val="0F766E"/>
+                  <a:srgbClr val="2730B6"/>
                 </a:solidFill>
               </a:defRPr>
             </a:pPr>
             <a:r>
               <a:rPr sz="1725" b="1">
                 <a:solidFill>
-                  <a:srgbClr val="0F766E"/>
+                  <a:srgbClr val="2730B6"/>
                 </a:solidFill>
               </a:rPr>
               <a:t>•</a:t>
@@ -2703,10 +3166,10 @@
       </p:sp>
       <p:sp>
         <p:nvSpPr>
-          <p:cNvPr id="9" name="">
-            <a:extLst xmlns:a="http://schemas.openxmlformats.org/drawingml/2006/main">
-              <a:ext uri="{FF2B5EF4-FFF2-40B4-BE49-F238E27FC236}">
-                <a16:creationId xmlns:a16="http://schemas.microsoft.com/office/drawing/2014/main" id="{FB5A13D6-B3D2-4736-9E07-F74B4AB27AF6}"/>
+          <p:cNvPr id="13" name="">
+            <a:extLst xmlns:a="http://schemas.openxmlformats.org/drawingml/2006/main">
+              <a:ext uri="{FF2B5EF4-FFF2-40B4-BE49-F238E27FC236}">
+                <a16:creationId xmlns:a16="http://schemas.microsoft.com/office/drawing/2014/main" id="{8283AB71-F071-4926-BD50-54D1EC518957}"/>
               </a:ext>
             </a:extLst>
           </p:cNvPr>
@@ -2753,10 +3216,10 @@
       </p:sp>
       <p:sp>
         <p:nvSpPr>
-          <p:cNvPr id="10" name="">
-            <a:extLst xmlns:a="http://schemas.openxmlformats.org/drawingml/2006/main">
-              <a:ext uri="{FF2B5EF4-FFF2-40B4-BE49-F238E27FC236}">
-                <a16:creationId xmlns:a16="http://schemas.microsoft.com/office/drawing/2014/main" id="{E09AD5E6-9267-4AAB-B566-DB5C702D91D5}"/>
+          <p:cNvPr id="14" name="">
+            <a:extLst xmlns:a="http://schemas.openxmlformats.org/drawingml/2006/main">
+              <a:ext uri="{FF2B5EF4-FFF2-40B4-BE49-F238E27FC236}">
+                <a16:creationId xmlns:a16="http://schemas.microsoft.com/office/drawing/2014/main" id="{46C27831-BF07-4862-BCCC-0E75584E111D}"/>
               </a:ext>
             </a:extLst>
           </p:cNvPr>
@@ -2786,14 +3249,14 @@
             <a:pPr algn="l">
               <a:defRPr sz="1725" b="1">
                 <a:solidFill>
-                  <a:srgbClr val="0F766E"/>
+                  <a:srgbClr val="2730B6"/>
                 </a:solidFill>
               </a:defRPr>
             </a:pPr>
             <a:r>
               <a:rPr sz="1725" b="1">
                 <a:solidFill>
-                  <a:srgbClr val="0F766E"/>
+                  <a:srgbClr val="2730B6"/>
                 </a:solidFill>
               </a:rPr>
               <a:t>•</a:t>
@@ -2803,10 +3266,10 @@
       </p:sp>
       <p:sp>
         <p:nvSpPr>
-          <p:cNvPr id="11" name="">
-            <a:extLst xmlns:a="http://schemas.openxmlformats.org/drawingml/2006/main">
-              <a:ext uri="{FF2B5EF4-FFF2-40B4-BE49-F238E27FC236}">
-                <a16:creationId xmlns:a16="http://schemas.microsoft.com/office/drawing/2014/main" id="{33BB7496-CBD5-40FC-B05E-261FCF9A3B20}"/>
+          <p:cNvPr id="15" name="">
+            <a:extLst xmlns:a="http://schemas.openxmlformats.org/drawingml/2006/main">
+              <a:ext uri="{FF2B5EF4-FFF2-40B4-BE49-F238E27FC236}">
+                <a16:creationId xmlns:a16="http://schemas.microsoft.com/office/drawing/2014/main" id="{45AEDB4E-C7FC-4FAA-89DE-D726BE1C4D30}"/>
               </a:ext>
             </a:extLst>
           </p:cNvPr>
@@ -2853,10 +3316,10 @@
       </p:sp>
       <p:sp>
         <p:nvSpPr>
-          <p:cNvPr id="12" name="">
-            <a:extLst xmlns:a="http://schemas.openxmlformats.org/drawingml/2006/main">
-              <a:ext uri="{FF2B5EF4-FFF2-40B4-BE49-F238E27FC236}">
-                <a16:creationId xmlns:a16="http://schemas.microsoft.com/office/drawing/2014/main" id="{9F720B03-C102-4EBE-93B9-F74FABB501A5}"/>
+          <p:cNvPr id="16" name="">
+            <a:extLst xmlns:a="http://schemas.openxmlformats.org/drawingml/2006/main">
+              <a:ext uri="{FF2B5EF4-FFF2-40B4-BE49-F238E27FC236}">
+                <a16:creationId xmlns:a16="http://schemas.microsoft.com/office/drawing/2014/main" id="{837ED683-E4C0-47B0-B46E-6A869035D1BC}"/>
               </a:ext>
             </a:extLst>
           </p:cNvPr>
@@ -2886,14 +3349,14 @@
             <a:pPr algn="l">
               <a:defRPr sz="975" b="0">
                 <a:solidFill>
-                  <a:srgbClr val="64748B"/>
+                  <a:srgbClr val="2730B6"/>
                 </a:solidFill>
               </a:defRPr>
             </a:pPr>
             <a:r>
               <a:rPr sz="975" b="0">
                 <a:solidFill>
-                  <a:srgbClr val="64748B"/>
+                  <a:srgbClr val="2730B6"/>
                 </a:solidFill>
               </a:rPr>
               <a:t>ADAS ScenarioGuard · ВКР · 2026</a:t>
@@ -2903,10 +3366,10 @@
       </p:sp>
       <p:sp>
         <p:nvSpPr>
-          <p:cNvPr id="13" name="">
-            <a:extLst xmlns:a="http://schemas.openxmlformats.org/drawingml/2006/main">
-              <a:ext uri="{FF2B5EF4-FFF2-40B4-BE49-F238E27FC236}">
-                <a16:creationId xmlns:a16="http://schemas.microsoft.com/office/drawing/2014/main" id="{6415D2B7-4492-42A7-8910-310A7B81DED1}"/>
+          <p:cNvPr id="17" name="">
+            <a:extLst xmlns:a="http://schemas.openxmlformats.org/drawingml/2006/main">
+              <a:ext uri="{FF2B5EF4-FFF2-40B4-BE49-F238E27FC236}">
+                <a16:creationId xmlns:a16="http://schemas.microsoft.com/office/drawing/2014/main" id="{6D7B680D-33A7-4B19-BA02-43AF9628439A}"/>
               </a:ext>
             </a:extLst>
           </p:cNvPr>
@@ -2936,14 +3399,14 @@
             <a:pPr algn="r">
               <a:defRPr sz="975" b="0">
                 <a:solidFill>
-                  <a:srgbClr val="64748B"/>
+                  <a:srgbClr val="2730B6"/>
                 </a:solidFill>
               </a:defRPr>
             </a:pPr>
             <a:r>
               <a:rPr sz="975" b="0">
                 <a:solidFill>
-                  <a:srgbClr val="64748B"/>
+                  <a:srgbClr val="2730B6"/>
                 </a:solidFill>
               </a:rPr>
               <a:t>10</a:t>
@@ -2954,7 +3417,7 @@
     </p:spTree>
     <p:extLst>
       <p:ext uri="{BB962C8B-B14F-4D97-AF65-F5344CB8AC3E}">
-        <p14:creationId xmlns:p14="http://schemas.microsoft.com/office/powerpoint/2010/main" val="1831951638"/>
+        <p14:creationId xmlns:p14="http://schemas.microsoft.com/office/powerpoint/2010/main" val="1150759484"/>
       </p:ext>
     </p:extLst>
   </p:cSld>
@@ -2985,7 +3448,173 @@
           <p:cNvPr id="1" name="">
             <a:extLst xmlns:a="http://schemas.openxmlformats.org/drawingml/2006/main">
               <a:ext uri="{FF2B5EF4-FFF2-40B4-BE49-F238E27FC236}">
-                <a16:creationId xmlns:a16="http://schemas.microsoft.com/office/drawing/2014/main" id="{A92EBE72-2153-4E2B-8C3A-FB4B29C449F2}"/>
+                <a16:creationId xmlns:a16="http://schemas.microsoft.com/office/drawing/2014/main" id="{1C1A2BFA-3A7F-4820-A81B-CAAB90D5ACE4}"/>
+              </a:ext>
+            </a:extLst>
+          </p:cNvPr>
+          <p:cNvSpPr>
+            <a:spLocks xmlns:a="http://schemas.openxmlformats.org/drawingml/2006/main" noGrp="1"/>
+          </p:cNvSpPr>
+          <p:nvPr/>
+        </p:nvSpPr>
+        <p:spPr>
+          <a:xfrm xmlns:a="http://schemas.openxmlformats.org/drawingml/2006/main">
+            <a:off x="0" y="0"/>
+            <a:ext cx="12192000" cy="171450"/>
+          </a:xfrm>
+          <a:prstGeom xmlns:a="http://schemas.openxmlformats.org/drawingml/2006/main" prst="rect">
+            <a:avLst/>
+          </a:prstGeom>
+          <a:solidFill xmlns:a="http://schemas.openxmlformats.org/drawingml/2006/main">
+            <a:srgbClr val="2730B6"/>
+          </a:solidFill>
+          <a:ln xmlns:a="http://schemas.openxmlformats.org/drawingml/2006/main" w="0">
+            <a:solidFill>
+              <a:srgbClr val="2730B6"/>
+            </a:solidFill>
+            <a:prstDash val="solid"/>
+          </a:ln>
+        </p:spPr>
+      </p:sp>
+      <p:sp>
+        <p:nvSpPr>
+          <p:cNvPr id="2" name="">
+            <a:extLst xmlns:a="http://schemas.openxmlformats.org/drawingml/2006/main">
+              <a:ext uri="{FF2B5EF4-FFF2-40B4-BE49-F238E27FC236}">
+                <a16:creationId xmlns:a16="http://schemas.microsoft.com/office/drawing/2014/main" id="{42483C4C-E6C0-4CF6-9507-586D6AC5791C}"/>
+              </a:ext>
+            </a:extLst>
+          </p:cNvPr>
+          <p:cNvSpPr>
+            <a:spLocks xmlns:a="http://schemas.openxmlformats.org/drawingml/2006/main" noGrp="1"/>
+          </p:cNvSpPr>
+          <p:nvPr/>
+        </p:nvSpPr>
+        <p:spPr>
+          <a:xfrm xmlns:a="http://schemas.openxmlformats.org/drawingml/2006/main">
+            <a:off x="0" y="0"/>
+            <a:ext cx="171450" cy="6858000"/>
+          </a:xfrm>
+          <a:prstGeom xmlns:a="http://schemas.openxmlformats.org/drawingml/2006/main" prst="rect">
+            <a:avLst/>
+          </a:prstGeom>
+          <a:solidFill xmlns:a="http://schemas.openxmlformats.org/drawingml/2006/main">
+            <a:srgbClr val="2730B6"/>
+          </a:solidFill>
+          <a:ln xmlns:a="http://schemas.openxmlformats.org/drawingml/2006/main" w="0">
+            <a:solidFill>
+              <a:srgbClr val="2730B6"/>
+            </a:solidFill>
+            <a:prstDash val="solid"/>
+          </a:ln>
+        </p:spPr>
+      </p:sp>
+      <p:sp>
+        <p:nvSpPr>
+          <p:cNvPr id="3" name="">
+            <a:extLst xmlns:a="http://schemas.openxmlformats.org/drawingml/2006/main">
+              <a:ext uri="{FF2B5EF4-FFF2-40B4-BE49-F238E27FC236}">
+                <a16:creationId xmlns:a16="http://schemas.microsoft.com/office/drawing/2014/main" id="{9C7FE624-AEA5-4C1F-8B6E-4BB3AD571CE0}"/>
+              </a:ext>
+            </a:extLst>
+          </p:cNvPr>
+          <p:cNvSpPr>
+            <a:spLocks xmlns:a="http://schemas.openxmlformats.org/drawingml/2006/main" noGrp="1"/>
+          </p:cNvSpPr>
+          <p:nvPr/>
+        </p:nvSpPr>
+        <p:spPr>
+          <a:xfrm xmlns:a="http://schemas.openxmlformats.org/drawingml/2006/main">
+            <a:off x="9810750" y="400050"/>
+            <a:ext cx="1428750" cy="228600"/>
+          </a:xfrm>
+          <a:prstGeom xmlns:a="http://schemas.openxmlformats.org/drawingml/2006/main" prst="rect">
+            <a:avLst/>
+          </a:prstGeom>
+          <a:noFill xmlns:a="http://schemas.openxmlformats.org/drawingml/2006/main"/>
+          <a:ln xmlns:a="http://schemas.openxmlformats.org/drawingml/2006/main" w="0">
+            <a:noFill/>
+            <a:prstDash val="solid"/>
+          </a:ln>
+        </p:spPr>
+        <p:txBody>
+          <a:bodyPr xmlns:a="http://schemas.openxmlformats.org/drawingml/2006/main"/>
+          <a:lstStyle xmlns:a="http://schemas.openxmlformats.org/drawingml/2006/main"/>
+          <a:p xmlns:a="http://schemas.openxmlformats.org/drawingml/2006/main">
+            <a:pPr algn="l">
+              <a:defRPr sz="975" b="1">
+                <a:solidFill>
+                  <a:srgbClr val="2730B6"/>
+                </a:solidFill>
+              </a:defRPr>
+            </a:pPr>
+            <a:r>
+              <a:rPr sz="975" b="1">
+                <a:solidFill>
+                  <a:srgbClr val="2730B6"/>
+                </a:solidFill>
+              </a:rPr>
+              <a:t>НИ ТГУ · ИДО</a:t>
+            </a:r>
+          </a:p>
+        </p:txBody>
+      </p:sp>
+      <p:sp>
+        <p:nvSpPr>
+          <p:cNvPr id="4" name="">
+            <a:extLst xmlns:a="http://schemas.openxmlformats.org/drawingml/2006/main">
+              <a:ext uri="{FF2B5EF4-FFF2-40B4-BE49-F238E27FC236}">
+                <a16:creationId xmlns:a16="http://schemas.microsoft.com/office/drawing/2014/main" id="{F7407F5D-106B-4E1E-A3DC-5085B5B20707}"/>
+              </a:ext>
+            </a:extLst>
+          </p:cNvPr>
+          <p:cNvSpPr>
+            <a:spLocks xmlns:a="http://schemas.openxmlformats.org/drawingml/2006/main" noGrp="1"/>
+          </p:cNvSpPr>
+          <p:nvPr/>
+        </p:nvSpPr>
+        <p:spPr>
+          <a:xfrm xmlns:a="http://schemas.openxmlformats.org/drawingml/2006/main">
+            <a:off x="11382375" y="400050"/>
+            <a:ext cx="361950" cy="228600"/>
+          </a:xfrm>
+          <a:prstGeom xmlns:a="http://schemas.openxmlformats.org/drawingml/2006/main" prst="rect">
+            <a:avLst/>
+          </a:prstGeom>
+          <a:noFill xmlns:a="http://schemas.openxmlformats.org/drawingml/2006/main"/>
+          <a:ln xmlns:a="http://schemas.openxmlformats.org/drawingml/2006/main" w="0">
+            <a:noFill/>
+            <a:prstDash val="solid"/>
+          </a:ln>
+        </p:spPr>
+        <p:txBody>
+          <a:bodyPr xmlns:a="http://schemas.openxmlformats.org/drawingml/2006/main"/>
+          <a:lstStyle xmlns:a="http://schemas.openxmlformats.org/drawingml/2006/main"/>
+          <a:p xmlns:a="http://schemas.openxmlformats.org/drawingml/2006/main">
+            <a:pPr algn="r">
+              <a:defRPr sz="975" b="0">
+                <a:solidFill>
+                  <a:srgbClr val="2730B6"/>
+                </a:solidFill>
+              </a:defRPr>
+            </a:pPr>
+            <a:r>
+              <a:rPr sz="975" b="0">
+                <a:solidFill>
+                  <a:srgbClr val="2730B6"/>
+                </a:solidFill>
+              </a:rPr>
+              <a:t>2</a:t>
+            </a:r>
+          </a:p>
+        </p:txBody>
+      </p:sp>
+      <p:sp>
+        <p:nvSpPr>
+          <p:cNvPr id="5" name="">
+            <a:extLst xmlns:a="http://schemas.openxmlformats.org/drawingml/2006/main">
+              <a:ext uri="{FF2B5EF4-FFF2-40B4-BE49-F238E27FC236}">
+                <a16:creationId xmlns:a16="http://schemas.microsoft.com/office/drawing/2014/main" id="{6E43E40B-6237-4BAE-A387-43E6E5055226}"/>
               </a:ext>
             </a:extLst>
           </p:cNvPr>
@@ -3032,10 +3661,10 @@
       </p:sp>
       <p:sp>
         <p:nvSpPr>
-          <p:cNvPr id="2" name="">
-            <a:extLst xmlns:a="http://schemas.openxmlformats.org/drawingml/2006/main">
-              <a:ext uri="{FF2B5EF4-FFF2-40B4-BE49-F238E27FC236}">
-                <a16:creationId xmlns:a16="http://schemas.microsoft.com/office/drawing/2014/main" id="{91ED90D3-7BA4-4732-BEBD-F818605F9AEC}"/>
+          <p:cNvPr id="6" name="">
+            <a:extLst xmlns:a="http://schemas.openxmlformats.org/drawingml/2006/main">
+              <a:ext uri="{FF2B5EF4-FFF2-40B4-BE49-F238E27FC236}">
+                <a16:creationId xmlns:a16="http://schemas.microsoft.com/office/drawing/2014/main" id="{64179AB9-81D9-494D-8D8C-9B634DD4D4CD}"/>
               </a:ext>
             </a:extLst>
           </p:cNvPr>
@@ -3053,11 +3682,11 @@
             <a:avLst/>
           </a:prstGeom>
           <a:solidFill xmlns:a="http://schemas.openxmlformats.org/drawingml/2006/main">
-            <a:srgbClr val="0F766E"/>
+            <a:srgbClr val="36D2CF"/>
           </a:solidFill>
           <a:ln xmlns:a="http://schemas.openxmlformats.org/drawingml/2006/main" w="0">
             <a:solidFill>
-              <a:srgbClr val="0F766E"/>
+              <a:srgbClr val="36D2CF"/>
             </a:solidFill>
             <a:prstDash val="solid"/>
           </a:ln>
@@ -3065,10 +3694,10 @@
       </p:sp>
       <p:sp>
         <p:nvSpPr>
-          <p:cNvPr id="3" name="">
-            <a:extLst xmlns:a="http://schemas.openxmlformats.org/drawingml/2006/main">
-              <a:ext uri="{FF2B5EF4-FFF2-40B4-BE49-F238E27FC236}">
-                <a16:creationId xmlns:a16="http://schemas.microsoft.com/office/drawing/2014/main" id="{0759D149-CB45-48A1-A0A9-08BA8458CD2C}"/>
+          <p:cNvPr id="7" name="">
+            <a:extLst xmlns:a="http://schemas.openxmlformats.org/drawingml/2006/main">
+              <a:ext uri="{FF2B5EF4-FFF2-40B4-BE49-F238E27FC236}">
+                <a16:creationId xmlns:a16="http://schemas.microsoft.com/office/drawing/2014/main" id="{3D32DF74-6B93-4530-A5C7-3277D540C7A1}"/>
               </a:ext>
             </a:extLst>
           </p:cNvPr>
@@ -3098,14 +3727,14 @@
             <a:pPr algn="l">
               <a:defRPr sz="1800" b="1">
                 <a:solidFill>
-                  <a:srgbClr val="0F766E"/>
+                  <a:srgbClr val="2730B6"/>
                 </a:solidFill>
               </a:defRPr>
             </a:pPr>
             <a:r>
               <a:rPr sz="1800" b="1">
                 <a:solidFill>
-                  <a:srgbClr val="0F766E"/>
+                  <a:srgbClr val="2730B6"/>
                 </a:solidFill>
               </a:rPr>
               <a:t>•</a:t>
@@ -3115,10 +3744,10 @@
       </p:sp>
       <p:sp>
         <p:nvSpPr>
-          <p:cNvPr id="4" name="">
-            <a:extLst xmlns:a="http://schemas.openxmlformats.org/drawingml/2006/main">
-              <a:ext uri="{FF2B5EF4-FFF2-40B4-BE49-F238E27FC236}">
-                <a16:creationId xmlns:a16="http://schemas.microsoft.com/office/drawing/2014/main" id="{537589C9-D833-4B35-A76C-7C2257E8D8A7}"/>
+          <p:cNvPr id="8" name="">
+            <a:extLst xmlns:a="http://schemas.openxmlformats.org/drawingml/2006/main">
+              <a:ext uri="{FF2B5EF4-FFF2-40B4-BE49-F238E27FC236}">
+                <a16:creationId xmlns:a16="http://schemas.microsoft.com/office/drawing/2014/main" id="{20486FF1-B08E-4640-AE67-22B3E552EFA2}"/>
               </a:ext>
             </a:extLst>
           </p:cNvPr>
@@ -3165,10 +3794,10 @@
       </p:sp>
       <p:sp>
         <p:nvSpPr>
-          <p:cNvPr id="5" name="">
-            <a:extLst xmlns:a="http://schemas.openxmlformats.org/drawingml/2006/main">
-              <a:ext uri="{FF2B5EF4-FFF2-40B4-BE49-F238E27FC236}">
-                <a16:creationId xmlns:a16="http://schemas.microsoft.com/office/drawing/2014/main" id="{7FA6E147-0735-4A13-B8A2-54E0ADC1371E}"/>
+          <p:cNvPr id="9" name="">
+            <a:extLst xmlns:a="http://schemas.openxmlformats.org/drawingml/2006/main">
+              <a:ext uri="{FF2B5EF4-FFF2-40B4-BE49-F238E27FC236}">
+                <a16:creationId xmlns:a16="http://schemas.microsoft.com/office/drawing/2014/main" id="{BD49BA8E-AD54-4A67-A270-5A508AE72DD9}"/>
               </a:ext>
             </a:extLst>
           </p:cNvPr>
@@ -3198,14 +3827,14 @@
             <a:pPr algn="l">
               <a:defRPr sz="1800" b="1">
                 <a:solidFill>
-                  <a:srgbClr val="0F766E"/>
+                  <a:srgbClr val="2730B6"/>
                 </a:solidFill>
               </a:defRPr>
             </a:pPr>
             <a:r>
               <a:rPr sz="1800" b="1">
                 <a:solidFill>
-                  <a:srgbClr val="0F766E"/>
+                  <a:srgbClr val="2730B6"/>
                 </a:solidFill>
               </a:rPr>
               <a:t>•</a:t>
@@ -3215,10 +3844,10 @@
       </p:sp>
       <p:sp>
         <p:nvSpPr>
-          <p:cNvPr id="6" name="">
-            <a:extLst xmlns:a="http://schemas.openxmlformats.org/drawingml/2006/main">
-              <a:ext uri="{FF2B5EF4-FFF2-40B4-BE49-F238E27FC236}">
-                <a16:creationId xmlns:a16="http://schemas.microsoft.com/office/drawing/2014/main" id="{2BF7A30B-774A-469E-A96C-E5D1F4DB034F}"/>
+          <p:cNvPr id="10" name="">
+            <a:extLst xmlns:a="http://schemas.openxmlformats.org/drawingml/2006/main">
+              <a:ext uri="{FF2B5EF4-FFF2-40B4-BE49-F238E27FC236}">
+                <a16:creationId xmlns:a16="http://schemas.microsoft.com/office/drawing/2014/main" id="{71B9212E-AB95-4542-B6A8-57F7E8EA9CB8}"/>
               </a:ext>
             </a:extLst>
           </p:cNvPr>
@@ -3265,10 +3894,10 @@
       </p:sp>
       <p:sp>
         <p:nvSpPr>
-          <p:cNvPr id="7" name="">
-            <a:extLst xmlns:a="http://schemas.openxmlformats.org/drawingml/2006/main">
-              <a:ext uri="{FF2B5EF4-FFF2-40B4-BE49-F238E27FC236}">
-                <a16:creationId xmlns:a16="http://schemas.microsoft.com/office/drawing/2014/main" id="{5DAD46CD-1BA4-450D-8D26-B7F6DF83497B}"/>
+          <p:cNvPr id="11" name="">
+            <a:extLst xmlns:a="http://schemas.openxmlformats.org/drawingml/2006/main">
+              <a:ext uri="{FF2B5EF4-FFF2-40B4-BE49-F238E27FC236}">
+                <a16:creationId xmlns:a16="http://schemas.microsoft.com/office/drawing/2014/main" id="{57FCAD9B-1AC4-44DD-A0F1-D57DF7975236}"/>
               </a:ext>
             </a:extLst>
           </p:cNvPr>
@@ -3298,14 +3927,14 @@
             <a:pPr algn="l">
               <a:defRPr sz="1800" b="1">
                 <a:solidFill>
-                  <a:srgbClr val="0F766E"/>
+                  <a:srgbClr val="2730B6"/>
                 </a:solidFill>
               </a:defRPr>
             </a:pPr>
             <a:r>
               <a:rPr sz="1800" b="1">
                 <a:solidFill>
-                  <a:srgbClr val="0F766E"/>
+                  <a:srgbClr val="2730B6"/>
                 </a:solidFill>
               </a:rPr>
               <a:t>•</a:t>
@@ -3315,10 +3944,10 @@
       </p:sp>
       <p:sp>
         <p:nvSpPr>
-          <p:cNvPr id="8" name="">
-            <a:extLst xmlns:a="http://schemas.openxmlformats.org/drawingml/2006/main">
-              <a:ext uri="{FF2B5EF4-FFF2-40B4-BE49-F238E27FC236}">
-                <a16:creationId xmlns:a16="http://schemas.microsoft.com/office/drawing/2014/main" id="{C6948189-E7DB-4231-A315-CF8E37846497}"/>
+          <p:cNvPr id="12" name="">
+            <a:extLst xmlns:a="http://schemas.openxmlformats.org/drawingml/2006/main">
+              <a:ext uri="{FF2B5EF4-FFF2-40B4-BE49-F238E27FC236}">
+                <a16:creationId xmlns:a16="http://schemas.microsoft.com/office/drawing/2014/main" id="{3F9771A8-6FC3-4309-88EE-03564F50B0C1}"/>
               </a:ext>
             </a:extLst>
           </p:cNvPr>
@@ -3365,10 +3994,10 @@
       </p:sp>
       <p:sp>
         <p:nvSpPr>
-          <p:cNvPr id="9" name="">
-            <a:extLst xmlns:a="http://schemas.openxmlformats.org/drawingml/2006/main">
-              <a:ext uri="{FF2B5EF4-FFF2-40B4-BE49-F238E27FC236}">
-                <a16:creationId xmlns:a16="http://schemas.microsoft.com/office/drawing/2014/main" id="{0E60E002-5E2E-460B-BE0B-2F187D1B0398}"/>
+          <p:cNvPr id="13" name="">
+            <a:extLst xmlns:a="http://schemas.openxmlformats.org/drawingml/2006/main">
+              <a:ext uri="{FF2B5EF4-FFF2-40B4-BE49-F238E27FC236}">
+                <a16:creationId xmlns:a16="http://schemas.microsoft.com/office/drawing/2014/main" id="{C64A502F-80EF-4581-80AD-4ED7D9031B16}"/>
               </a:ext>
             </a:extLst>
           </p:cNvPr>
@@ -3438,10 +4067,10 @@
       </p:sp>
       <p:sp>
         <p:nvSpPr>
-          <p:cNvPr id="10" name="">
-            <a:extLst xmlns:a="http://schemas.openxmlformats.org/drawingml/2006/main">
-              <a:ext uri="{FF2B5EF4-FFF2-40B4-BE49-F238E27FC236}">
-                <a16:creationId xmlns:a16="http://schemas.microsoft.com/office/drawing/2014/main" id="{242B1882-362A-48C5-9ED2-DB6D2A6756ED}"/>
+          <p:cNvPr id="14" name="">
+            <a:extLst xmlns:a="http://schemas.openxmlformats.org/drawingml/2006/main">
+              <a:ext uri="{FF2B5EF4-FFF2-40B4-BE49-F238E27FC236}">
+                <a16:creationId xmlns:a16="http://schemas.microsoft.com/office/drawing/2014/main" id="{C9738A64-191A-41F3-A7B1-DDFBA67CA9C6}"/>
               </a:ext>
             </a:extLst>
           </p:cNvPr>
@@ -3511,10 +4140,10 @@
       </p:sp>
       <p:sp>
         <p:nvSpPr>
-          <p:cNvPr id="11" name="">
-            <a:extLst xmlns:a="http://schemas.openxmlformats.org/drawingml/2006/main">
-              <a:ext uri="{FF2B5EF4-FFF2-40B4-BE49-F238E27FC236}">
-                <a16:creationId xmlns:a16="http://schemas.microsoft.com/office/drawing/2014/main" id="{5A23EA04-D3BB-43D3-A546-24B3F13D83B0}"/>
+          <p:cNvPr id="15" name="">
+            <a:extLst xmlns:a="http://schemas.openxmlformats.org/drawingml/2006/main">
+              <a:ext uri="{FF2B5EF4-FFF2-40B4-BE49-F238E27FC236}">
+                <a16:creationId xmlns:a16="http://schemas.microsoft.com/office/drawing/2014/main" id="{CAB0D732-6319-40F1-B2B2-5189F8A4561C}"/>
               </a:ext>
             </a:extLst>
           </p:cNvPr>
@@ -3584,10 +4213,10 @@
       </p:sp>
       <p:sp>
         <p:nvSpPr>
-          <p:cNvPr id="12" name="">
-            <a:extLst xmlns:a="http://schemas.openxmlformats.org/drawingml/2006/main">
-              <a:ext uri="{FF2B5EF4-FFF2-40B4-BE49-F238E27FC236}">
-                <a16:creationId xmlns:a16="http://schemas.microsoft.com/office/drawing/2014/main" id="{268EB1A5-B53C-4829-B75F-F57FF6D3DF74}"/>
+          <p:cNvPr id="16" name="">
+            <a:extLst xmlns:a="http://schemas.openxmlformats.org/drawingml/2006/main">
+              <a:ext uri="{FF2B5EF4-FFF2-40B4-BE49-F238E27FC236}">
+                <a16:creationId xmlns:a16="http://schemas.microsoft.com/office/drawing/2014/main" id="{D833DB80-D47D-4A5F-A8D4-2CD08A20B071}"/>
               </a:ext>
             </a:extLst>
           </p:cNvPr>
@@ -3617,14 +4246,14 @@
             <a:pPr algn="l">
               <a:defRPr sz="975" b="0">
                 <a:solidFill>
-                  <a:srgbClr val="64748B"/>
+                  <a:srgbClr val="2730B6"/>
                 </a:solidFill>
               </a:defRPr>
             </a:pPr>
             <a:r>
               <a:rPr sz="975" b="0">
                 <a:solidFill>
-                  <a:srgbClr val="64748B"/>
+                  <a:srgbClr val="2730B6"/>
                 </a:solidFill>
               </a:rPr>
               <a:t>ADAS ScenarioGuard · ВКР · 2026</a:t>
@@ -3634,10 +4263,10 @@
       </p:sp>
       <p:sp>
         <p:nvSpPr>
-          <p:cNvPr id="13" name="">
-            <a:extLst xmlns:a="http://schemas.openxmlformats.org/drawingml/2006/main">
-              <a:ext uri="{FF2B5EF4-FFF2-40B4-BE49-F238E27FC236}">
-                <a16:creationId xmlns:a16="http://schemas.microsoft.com/office/drawing/2014/main" id="{FF52DD74-4C7E-4E84-9CDC-1B1CB48E6751}"/>
+          <p:cNvPr id="17" name="">
+            <a:extLst xmlns:a="http://schemas.openxmlformats.org/drawingml/2006/main">
+              <a:ext uri="{FF2B5EF4-FFF2-40B4-BE49-F238E27FC236}">
+                <a16:creationId xmlns:a16="http://schemas.microsoft.com/office/drawing/2014/main" id="{2E798899-C9C9-4E39-AA62-DB99BC12F980}"/>
               </a:ext>
             </a:extLst>
           </p:cNvPr>
@@ -3667,14 +4296,14 @@
             <a:pPr algn="r">
               <a:defRPr sz="975" b="0">
                 <a:solidFill>
-                  <a:srgbClr val="64748B"/>
+                  <a:srgbClr val="2730B6"/>
                 </a:solidFill>
               </a:defRPr>
             </a:pPr>
             <a:r>
               <a:rPr sz="975" b="0">
                 <a:solidFill>
-                  <a:srgbClr val="64748B"/>
+                  <a:srgbClr val="2730B6"/>
                 </a:solidFill>
               </a:rPr>
               <a:t>2</a:t>
@@ -3685,7 +4314,7 @@
     </p:spTree>
     <p:extLst>
       <p:ext uri="{BB962C8B-B14F-4D97-AF65-F5344CB8AC3E}">
-        <p14:creationId xmlns:p14="http://schemas.microsoft.com/office/powerpoint/2010/main" val="2066722136"/>
+        <p14:creationId xmlns:p14="http://schemas.microsoft.com/office/powerpoint/2010/main" val="162725665"/>
       </p:ext>
     </p:extLst>
   </p:cSld>
@@ -3716,7 +4345,173 @@
           <p:cNvPr id="1" name="">
             <a:extLst xmlns:a="http://schemas.openxmlformats.org/drawingml/2006/main">
               <a:ext uri="{FF2B5EF4-FFF2-40B4-BE49-F238E27FC236}">
-                <a16:creationId xmlns:a16="http://schemas.microsoft.com/office/drawing/2014/main" id="{910BFB2C-0DF7-483A-9EBC-4D3B51B0C247}"/>
+                <a16:creationId xmlns:a16="http://schemas.microsoft.com/office/drawing/2014/main" id="{7F544B8B-E141-4F4F-A107-37986E05F81E}"/>
+              </a:ext>
+            </a:extLst>
+          </p:cNvPr>
+          <p:cNvSpPr>
+            <a:spLocks xmlns:a="http://schemas.openxmlformats.org/drawingml/2006/main" noGrp="1"/>
+          </p:cNvSpPr>
+          <p:nvPr/>
+        </p:nvSpPr>
+        <p:spPr>
+          <a:xfrm xmlns:a="http://schemas.openxmlformats.org/drawingml/2006/main">
+            <a:off x="0" y="0"/>
+            <a:ext cx="12192000" cy="171450"/>
+          </a:xfrm>
+          <a:prstGeom xmlns:a="http://schemas.openxmlformats.org/drawingml/2006/main" prst="rect">
+            <a:avLst/>
+          </a:prstGeom>
+          <a:solidFill xmlns:a="http://schemas.openxmlformats.org/drawingml/2006/main">
+            <a:srgbClr val="2730B6"/>
+          </a:solidFill>
+          <a:ln xmlns:a="http://schemas.openxmlformats.org/drawingml/2006/main" w="0">
+            <a:solidFill>
+              <a:srgbClr val="2730B6"/>
+            </a:solidFill>
+            <a:prstDash val="solid"/>
+          </a:ln>
+        </p:spPr>
+      </p:sp>
+      <p:sp>
+        <p:nvSpPr>
+          <p:cNvPr id="2" name="">
+            <a:extLst xmlns:a="http://schemas.openxmlformats.org/drawingml/2006/main">
+              <a:ext uri="{FF2B5EF4-FFF2-40B4-BE49-F238E27FC236}">
+                <a16:creationId xmlns:a16="http://schemas.microsoft.com/office/drawing/2014/main" id="{3EDAF137-395D-49A2-88DC-2F923DD82129}"/>
+              </a:ext>
+            </a:extLst>
+          </p:cNvPr>
+          <p:cNvSpPr>
+            <a:spLocks xmlns:a="http://schemas.openxmlformats.org/drawingml/2006/main" noGrp="1"/>
+          </p:cNvSpPr>
+          <p:nvPr/>
+        </p:nvSpPr>
+        <p:spPr>
+          <a:xfrm xmlns:a="http://schemas.openxmlformats.org/drawingml/2006/main">
+            <a:off x="0" y="0"/>
+            <a:ext cx="171450" cy="6858000"/>
+          </a:xfrm>
+          <a:prstGeom xmlns:a="http://schemas.openxmlformats.org/drawingml/2006/main" prst="rect">
+            <a:avLst/>
+          </a:prstGeom>
+          <a:solidFill xmlns:a="http://schemas.openxmlformats.org/drawingml/2006/main">
+            <a:srgbClr val="2730B6"/>
+          </a:solidFill>
+          <a:ln xmlns:a="http://schemas.openxmlformats.org/drawingml/2006/main" w="0">
+            <a:solidFill>
+              <a:srgbClr val="2730B6"/>
+            </a:solidFill>
+            <a:prstDash val="solid"/>
+          </a:ln>
+        </p:spPr>
+      </p:sp>
+      <p:sp>
+        <p:nvSpPr>
+          <p:cNvPr id="3" name="">
+            <a:extLst xmlns:a="http://schemas.openxmlformats.org/drawingml/2006/main">
+              <a:ext uri="{FF2B5EF4-FFF2-40B4-BE49-F238E27FC236}">
+                <a16:creationId xmlns:a16="http://schemas.microsoft.com/office/drawing/2014/main" id="{3983A7B5-B939-4D83-8AAF-012C6EF71D2D}"/>
+              </a:ext>
+            </a:extLst>
+          </p:cNvPr>
+          <p:cNvSpPr>
+            <a:spLocks xmlns:a="http://schemas.openxmlformats.org/drawingml/2006/main" noGrp="1"/>
+          </p:cNvSpPr>
+          <p:nvPr/>
+        </p:nvSpPr>
+        <p:spPr>
+          <a:xfrm xmlns:a="http://schemas.openxmlformats.org/drawingml/2006/main">
+            <a:off x="9810750" y="400050"/>
+            <a:ext cx="1428750" cy="228600"/>
+          </a:xfrm>
+          <a:prstGeom xmlns:a="http://schemas.openxmlformats.org/drawingml/2006/main" prst="rect">
+            <a:avLst/>
+          </a:prstGeom>
+          <a:noFill xmlns:a="http://schemas.openxmlformats.org/drawingml/2006/main"/>
+          <a:ln xmlns:a="http://schemas.openxmlformats.org/drawingml/2006/main" w="0">
+            <a:noFill/>
+            <a:prstDash val="solid"/>
+          </a:ln>
+        </p:spPr>
+        <p:txBody>
+          <a:bodyPr xmlns:a="http://schemas.openxmlformats.org/drawingml/2006/main"/>
+          <a:lstStyle xmlns:a="http://schemas.openxmlformats.org/drawingml/2006/main"/>
+          <a:p xmlns:a="http://schemas.openxmlformats.org/drawingml/2006/main">
+            <a:pPr algn="l">
+              <a:defRPr sz="975" b="1">
+                <a:solidFill>
+                  <a:srgbClr val="2730B6"/>
+                </a:solidFill>
+              </a:defRPr>
+            </a:pPr>
+            <a:r>
+              <a:rPr sz="975" b="1">
+                <a:solidFill>
+                  <a:srgbClr val="2730B6"/>
+                </a:solidFill>
+              </a:rPr>
+              <a:t>НИ ТГУ · ИДО</a:t>
+            </a:r>
+          </a:p>
+        </p:txBody>
+      </p:sp>
+      <p:sp>
+        <p:nvSpPr>
+          <p:cNvPr id="4" name="">
+            <a:extLst xmlns:a="http://schemas.openxmlformats.org/drawingml/2006/main">
+              <a:ext uri="{FF2B5EF4-FFF2-40B4-BE49-F238E27FC236}">
+                <a16:creationId xmlns:a16="http://schemas.microsoft.com/office/drawing/2014/main" id="{D06254B1-71A0-4623-AC3C-52C5E9597987}"/>
+              </a:ext>
+            </a:extLst>
+          </p:cNvPr>
+          <p:cNvSpPr>
+            <a:spLocks xmlns:a="http://schemas.openxmlformats.org/drawingml/2006/main" noGrp="1"/>
+          </p:cNvSpPr>
+          <p:nvPr/>
+        </p:nvSpPr>
+        <p:spPr>
+          <a:xfrm xmlns:a="http://schemas.openxmlformats.org/drawingml/2006/main">
+            <a:off x="11382375" y="400050"/>
+            <a:ext cx="361950" cy="228600"/>
+          </a:xfrm>
+          <a:prstGeom xmlns:a="http://schemas.openxmlformats.org/drawingml/2006/main" prst="rect">
+            <a:avLst/>
+          </a:prstGeom>
+          <a:noFill xmlns:a="http://schemas.openxmlformats.org/drawingml/2006/main"/>
+          <a:ln xmlns:a="http://schemas.openxmlformats.org/drawingml/2006/main" w="0">
+            <a:noFill/>
+            <a:prstDash val="solid"/>
+          </a:ln>
+        </p:spPr>
+        <p:txBody>
+          <a:bodyPr xmlns:a="http://schemas.openxmlformats.org/drawingml/2006/main"/>
+          <a:lstStyle xmlns:a="http://schemas.openxmlformats.org/drawingml/2006/main"/>
+          <a:p xmlns:a="http://schemas.openxmlformats.org/drawingml/2006/main">
+            <a:pPr algn="r">
+              <a:defRPr sz="975" b="0">
+                <a:solidFill>
+                  <a:srgbClr val="2730B6"/>
+                </a:solidFill>
+              </a:defRPr>
+            </a:pPr>
+            <a:r>
+              <a:rPr sz="975" b="0">
+                <a:solidFill>
+                  <a:srgbClr val="2730B6"/>
+                </a:solidFill>
+              </a:rPr>
+              <a:t>3</a:t>
+            </a:r>
+          </a:p>
+        </p:txBody>
+      </p:sp>
+      <p:sp>
+        <p:nvSpPr>
+          <p:cNvPr id="5" name="">
+            <a:extLst xmlns:a="http://schemas.openxmlformats.org/drawingml/2006/main">
+              <a:ext uri="{FF2B5EF4-FFF2-40B4-BE49-F238E27FC236}">
+                <a16:creationId xmlns:a16="http://schemas.microsoft.com/office/drawing/2014/main" id="{EE9C5703-2B22-46A3-8796-5ECCD2B5741F}"/>
               </a:ext>
             </a:extLst>
           </p:cNvPr>
@@ -3763,10 +4558,10 @@
       </p:sp>
       <p:sp>
         <p:nvSpPr>
-          <p:cNvPr id="2" name="">
-            <a:extLst xmlns:a="http://schemas.openxmlformats.org/drawingml/2006/main">
-              <a:ext uri="{FF2B5EF4-FFF2-40B4-BE49-F238E27FC236}">
-                <a16:creationId xmlns:a16="http://schemas.microsoft.com/office/drawing/2014/main" id="{D802F32E-40ED-439D-A9AE-8EAC7C1B47E6}"/>
+          <p:cNvPr id="6" name="">
+            <a:extLst xmlns:a="http://schemas.openxmlformats.org/drawingml/2006/main">
+              <a:ext uri="{FF2B5EF4-FFF2-40B4-BE49-F238E27FC236}">
+                <a16:creationId xmlns:a16="http://schemas.microsoft.com/office/drawing/2014/main" id="{2414C65B-BFA0-4608-BBB6-CD42CBA54947}"/>
               </a:ext>
             </a:extLst>
           </p:cNvPr>
@@ -3784,11 +4579,11 @@
             <a:avLst/>
           </a:prstGeom>
           <a:solidFill xmlns:a="http://schemas.openxmlformats.org/drawingml/2006/main">
-            <a:srgbClr val="0F766E"/>
+            <a:srgbClr val="36D2CF"/>
           </a:solidFill>
           <a:ln xmlns:a="http://schemas.openxmlformats.org/drawingml/2006/main" w="0">
             <a:solidFill>
-              <a:srgbClr val="0F766E"/>
+              <a:srgbClr val="36D2CF"/>
             </a:solidFill>
             <a:prstDash val="solid"/>
           </a:ln>
@@ -3796,10 +4591,10 @@
       </p:sp>
       <p:sp>
         <p:nvSpPr>
-          <p:cNvPr id="3" name="">
-            <a:extLst xmlns:a="http://schemas.openxmlformats.org/drawingml/2006/main">
-              <a:ext uri="{FF2B5EF4-FFF2-40B4-BE49-F238E27FC236}">
-                <a16:creationId xmlns:a16="http://schemas.microsoft.com/office/drawing/2014/main" id="{3F884D0A-2CF1-4A2B-8C3A-9CE00CAB1CB2}"/>
+          <p:cNvPr id="7" name="">
+            <a:extLst xmlns:a="http://schemas.openxmlformats.org/drawingml/2006/main">
+              <a:ext uri="{FF2B5EF4-FFF2-40B4-BE49-F238E27FC236}">
+                <a16:creationId xmlns:a16="http://schemas.microsoft.com/office/drawing/2014/main" id="{0CAC98D5-B3D4-44EA-945C-91340271295F}"/>
               </a:ext>
             </a:extLst>
           </p:cNvPr>
@@ -3869,10 +4664,10 @@
       </p:sp>
       <p:sp>
         <p:nvSpPr>
-          <p:cNvPr id="4" name="">
-            <a:extLst xmlns:a="http://schemas.openxmlformats.org/drawingml/2006/main">
-              <a:ext uri="{FF2B5EF4-FFF2-40B4-BE49-F238E27FC236}">
-                <a16:creationId xmlns:a16="http://schemas.microsoft.com/office/drawing/2014/main" id="{AE81F514-8EE7-450D-8427-ED0F800CD558}"/>
+          <p:cNvPr id="8" name="">
+            <a:extLst xmlns:a="http://schemas.openxmlformats.org/drawingml/2006/main">
+              <a:ext uri="{FF2B5EF4-FFF2-40B4-BE49-F238E27FC236}">
+                <a16:creationId xmlns:a16="http://schemas.microsoft.com/office/drawing/2014/main" id="{6307A6A4-7A2F-44A6-846A-B932092190BD}"/>
               </a:ext>
             </a:extLst>
           </p:cNvPr>
@@ -3942,10 +4737,10 @@
       </p:sp>
       <p:sp>
         <p:nvSpPr>
-          <p:cNvPr id="5" name="">
-            <a:extLst xmlns:a="http://schemas.openxmlformats.org/drawingml/2006/main">
-              <a:ext uri="{FF2B5EF4-FFF2-40B4-BE49-F238E27FC236}">
-                <a16:creationId xmlns:a16="http://schemas.microsoft.com/office/drawing/2014/main" id="{64D22FD5-967C-4CCD-90E8-DABD848AF332}"/>
+          <p:cNvPr id="9" name="">
+            <a:extLst xmlns:a="http://schemas.openxmlformats.org/drawingml/2006/main">
+              <a:ext uri="{FF2B5EF4-FFF2-40B4-BE49-F238E27FC236}">
+                <a16:creationId xmlns:a16="http://schemas.microsoft.com/office/drawing/2014/main" id="{382AABC6-C73B-4839-B7BB-7F319C4F53B3}"/>
               </a:ext>
             </a:extLst>
           </p:cNvPr>
@@ -4015,10 +4810,10 @@
       </p:sp>
       <p:sp>
         <p:nvSpPr>
-          <p:cNvPr id="6" name="">
-            <a:extLst xmlns:a="http://schemas.openxmlformats.org/drawingml/2006/main">
-              <a:ext uri="{FF2B5EF4-FFF2-40B4-BE49-F238E27FC236}">
-                <a16:creationId xmlns:a16="http://schemas.microsoft.com/office/drawing/2014/main" id="{17BAFD90-7610-4698-8A61-713B5B70265C}"/>
+          <p:cNvPr id="10" name="">
+            <a:extLst xmlns:a="http://schemas.openxmlformats.org/drawingml/2006/main">
+              <a:ext uri="{FF2B5EF4-FFF2-40B4-BE49-F238E27FC236}">
+                <a16:creationId xmlns:a16="http://schemas.microsoft.com/office/drawing/2014/main" id="{2B1C7F0A-BB69-4B75-AC75-FD48AFF4CEB3}"/>
               </a:ext>
             </a:extLst>
           </p:cNvPr>
@@ -4048,14 +4843,14 @@
             <a:pPr algn="l">
               <a:defRPr sz="1725" b="1">
                 <a:solidFill>
-                  <a:srgbClr val="0F766E"/>
+                  <a:srgbClr val="2730B6"/>
                 </a:solidFill>
               </a:defRPr>
             </a:pPr>
             <a:r>
               <a:rPr sz="1725" b="1">
                 <a:solidFill>
-                  <a:srgbClr val="0F766E"/>
+                  <a:srgbClr val="2730B6"/>
                 </a:solidFill>
               </a:rPr>
               <a:t>•</a:t>
@@ -4065,10 +4860,10 @@
       </p:sp>
       <p:sp>
         <p:nvSpPr>
-          <p:cNvPr id="7" name="">
-            <a:extLst xmlns:a="http://schemas.openxmlformats.org/drawingml/2006/main">
-              <a:ext uri="{FF2B5EF4-FFF2-40B4-BE49-F238E27FC236}">
-                <a16:creationId xmlns:a16="http://schemas.microsoft.com/office/drawing/2014/main" id="{8923D803-917F-445B-AA5D-117D560690DF}"/>
+          <p:cNvPr id="11" name="">
+            <a:extLst xmlns:a="http://schemas.openxmlformats.org/drawingml/2006/main">
+              <a:ext uri="{FF2B5EF4-FFF2-40B4-BE49-F238E27FC236}">
+                <a16:creationId xmlns:a16="http://schemas.microsoft.com/office/drawing/2014/main" id="{96576173-C8BE-4CE3-B698-7D9DF555EA5B}"/>
               </a:ext>
             </a:extLst>
           </p:cNvPr>
@@ -4115,10 +4910,10 @@
       </p:sp>
       <p:sp>
         <p:nvSpPr>
-          <p:cNvPr id="8" name="">
-            <a:extLst xmlns:a="http://schemas.openxmlformats.org/drawingml/2006/main">
-              <a:ext uri="{FF2B5EF4-FFF2-40B4-BE49-F238E27FC236}">
-                <a16:creationId xmlns:a16="http://schemas.microsoft.com/office/drawing/2014/main" id="{294EE033-9267-45F8-A00C-9363A1C07066}"/>
+          <p:cNvPr id="12" name="">
+            <a:extLst xmlns:a="http://schemas.openxmlformats.org/drawingml/2006/main">
+              <a:ext uri="{FF2B5EF4-FFF2-40B4-BE49-F238E27FC236}">
+                <a16:creationId xmlns:a16="http://schemas.microsoft.com/office/drawing/2014/main" id="{EB51F922-6E2F-499F-B15C-3C70B4715078}"/>
               </a:ext>
             </a:extLst>
           </p:cNvPr>
@@ -4148,14 +4943,14 @@
             <a:pPr algn="l">
               <a:defRPr sz="1725" b="1">
                 <a:solidFill>
-                  <a:srgbClr val="0F766E"/>
+                  <a:srgbClr val="2730B6"/>
                 </a:solidFill>
               </a:defRPr>
             </a:pPr>
             <a:r>
               <a:rPr sz="1725" b="1">
                 <a:solidFill>
-                  <a:srgbClr val="0F766E"/>
+                  <a:srgbClr val="2730B6"/>
                 </a:solidFill>
               </a:rPr>
               <a:t>•</a:t>
@@ -4165,10 +4960,10 @@
       </p:sp>
       <p:sp>
         <p:nvSpPr>
-          <p:cNvPr id="9" name="">
-            <a:extLst xmlns:a="http://schemas.openxmlformats.org/drawingml/2006/main">
-              <a:ext uri="{FF2B5EF4-FFF2-40B4-BE49-F238E27FC236}">
-                <a16:creationId xmlns:a16="http://schemas.microsoft.com/office/drawing/2014/main" id="{7F17C163-60A5-41C8-AD58-484802DEFFB4}"/>
+          <p:cNvPr id="13" name="">
+            <a:extLst xmlns:a="http://schemas.openxmlformats.org/drawingml/2006/main">
+              <a:ext uri="{FF2B5EF4-FFF2-40B4-BE49-F238E27FC236}">
+                <a16:creationId xmlns:a16="http://schemas.microsoft.com/office/drawing/2014/main" id="{50F8D85F-6592-4EFD-9804-9AACF785BDE9}"/>
               </a:ext>
             </a:extLst>
           </p:cNvPr>
@@ -4215,10 +5010,10 @@
       </p:sp>
       <p:sp>
         <p:nvSpPr>
-          <p:cNvPr id="10" name="">
-            <a:extLst xmlns:a="http://schemas.openxmlformats.org/drawingml/2006/main">
-              <a:ext uri="{FF2B5EF4-FFF2-40B4-BE49-F238E27FC236}">
-                <a16:creationId xmlns:a16="http://schemas.microsoft.com/office/drawing/2014/main" id="{BCDE96B7-736C-4257-B33C-029756C21BC5}"/>
+          <p:cNvPr id="14" name="">
+            <a:extLst xmlns:a="http://schemas.openxmlformats.org/drawingml/2006/main">
+              <a:ext uri="{FF2B5EF4-FFF2-40B4-BE49-F238E27FC236}">
+                <a16:creationId xmlns:a16="http://schemas.microsoft.com/office/drawing/2014/main" id="{685EB775-4CCC-44BC-A885-F990B8CD1F67}"/>
               </a:ext>
             </a:extLst>
           </p:cNvPr>
@@ -4248,14 +5043,14 @@
             <a:pPr algn="l">
               <a:defRPr sz="1725" b="1">
                 <a:solidFill>
-                  <a:srgbClr val="0F766E"/>
+                  <a:srgbClr val="2730B6"/>
                 </a:solidFill>
               </a:defRPr>
             </a:pPr>
             <a:r>
               <a:rPr sz="1725" b="1">
                 <a:solidFill>
-                  <a:srgbClr val="0F766E"/>
+                  <a:srgbClr val="2730B6"/>
                 </a:solidFill>
               </a:rPr>
               <a:t>•</a:t>
@@ -4265,10 +5060,10 @@
       </p:sp>
       <p:sp>
         <p:nvSpPr>
-          <p:cNvPr id="11" name="">
-            <a:extLst xmlns:a="http://schemas.openxmlformats.org/drawingml/2006/main">
-              <a:ext uri="{FF2B5EF4-FFF2-40B4-BE49-F238E27FC236}">
-                <a16:creationId xmlns:a16="http://schemas.microsoft.com/office/drawing/2014/main" id="{CF1876A1-52B5-4CE6-8AA9-63636A821B69}"/>
+          <p:cNvPr id="15" name="">
+            <a:extLst xmlns:a="http://schemas.openxmlformats.org/drawingml/2006/main">
+              <a:ext uri="{FF2B5EF4-FFF2-40B4-BE49-F238E27FC236}">
+                <a16:creationId xmlns:a16="http://schemas.microsoft.com/office/drawing/2014/main" id="{F291F3A3-6525-4750-835C-84C815DDDE25}"/>
               </a:ext>
             </a:extLst>
           </p:cNvPr>
@@ -4315,10 +5110,10 @@
       </p:sp>
       <p:sp>
         <p:nvSpPr>
-          <p:cNvPr id="12" name="">
-            <a:extLst xmlns:a="http://schemas.openxmlformats.org/drawingml/2006/main">
-              <a:ext uri="{FF2B5EF4-FFF2-40B4-BE49-F238E27FC236}">
-                <a16:creationId xmlns:a16="http://schemas.microsoft.com/office/drawing/2014/main" id="{1422C68B-374C-4282-9178-F3619258F943}"/>
+          <p:cNvPr id="16" name="">
+            <a:extLst xmlns:a="http://schemas.openxmlformats.org/drawingml/2006/main">
+              <a:ext uri="{FF2B5EF4-FFF2-40B4-BE49-F238E27FC236}">
+                <a16:creationId xmlns:a16="http://schemas.microsoft.com/office/drawing/2014/main" id="{8FA1C75D-B139-45A1-9B7D-F5DE9DA12F7E}"/>
               </a:ext>
             </a:extLst>
           </p:cNvPr>
@@ -4348,14 +5143,14 @@
             <a:pPr algn="l">
               <a:defRPr sz="975" b="0">
                 <a:solidFill>
-                  <a:srgbClr val="64748B"/>
+                  <a:srgbClr val="2730B6"/>
                 </a:solidFill>
               </a:defRPr>
             </a:pPr>
             <a:r>
               <a:rPr sz="975" b="0">
                 <a:solidFill>
-                  <a:srgbClr val="64748B"/>
+                  <a:srgbClr val="2730B6"/>
                 </a:solidFill>
               </a:rPr>
               <a:t>ADAS ScenarioGuard · ВКР · 2026</a:t>
@@ -4365,10 +5160,10 @@
       </p:sp>
       <p:sp>
         <p:nvSpPr>
-          <p:cNvPr id="13" name="">
-            <a:extLst xmlns:a="http://schemas.openxmlformats.org/drawingml/2006/main">
-              <a:ext uri="{FF2B5EF4-FFF2-40B4-BE49-F238E27FC236}">
-                <a16:creationId xmlns:a16="http://schemas.microsoft.com/office/drawing/2014/main" id="{CB5AFCA1-E34E-41D6-A64D-FA33AAFDB964}"/>
+          <p:cNvPr id="17" name="">
+            <a:extLst xmlns:a="http://schemas.openxmlformats.org/drawingml/2006/main">
+              <a:ext uri="{FF2B5EF4-FFF2-40B4-BE49-F238E27FC236}">
+                <a16:creationId xmlns:a16="http://schemas.microsoft.com/office/drawing/2014/main" id="{E72CE993-C10C-4A32-8AA6-8515F4D627CB}"/>
               </a:ext>
             </a:extLst>
           </p:cNvPr>
@@ -4398,14 +5193,14 @@
             <a:pPr algn="r">
               <a:defRPr sz="975" b="0">
                 <a:solidFill>
-                  <a:srgbClr val="64748B"/>
+                  <a:srgbClr val="2730B6"/>
                 </a:solidFill>
               </a:defRPr>
             </a:pPr>
             <a:r>
               <a:rPr sz="975" b="0">
                 <a:solidFill>
-                  <a:srgbClr val="64748B"/>
+                  <a:srgbClr val="2730B6"/>
                 </a:solidFill>
               </a:rPr>
               <a:t>3</a:t>
@@ -4416,7 +5211,7 @@
     </p:spTree>
     <p:extLst>
       <p:ext uri="{BB962C8B-B14F-4D97-AF65-F5344CB8AC3E}">
-        <p14:creationId xmlns:p14="http://schemas.microsoft.com/office/powerpoint/2010/main" val="1500008563"/>
+        <p14:creationId xmlns:p14="http://schemas.microsoft.com/office/powerpoint/2010/main" val="1732213059"/>
       </p:ext>
     </p:extLst>
   </p:cSld>
@@ -4447,7 +5242,173 @@
           <p:cNvPr id="1" name="">
             <a:extLst xmlns:a="http://schemas.openxmlformats.org/drawingml/2006/main">
               <a:ext uri="{FF2B5EF4-FFF2-40B4-BE49-F238E27FC236}">
-                <a16:creationId xmlns:a16="http://schemas.microsoft.com/office/drawing/2014/main" id="{7DA47947-B0C2-4298-9CC7-184FA85617C1}"/>
+                <a16:creationId xmlns:a16="http://schemas.microsoft.com/office/drawing/2014/main" id="{658D3A8A-9D9D-43EF-9966-9B34A3F3910D}"/>
+              </a:ext>
+            </a:extLst>
+          </p:cNvPr>
+          <p:cNvSpPr>
+            <a:spLocks xmlns:a="http://schemas.openxmlformats.org/drawingml/2006/main" noGrp="1"/>
+          </p:cNvSpPr>
+          <p:nvPr/>
+        </p:nvSpPr>
+        <p:spPr>
+          <a:xfrm xmlns:a="http://schemas.openxmlformats.org/drawingml/2006/main">
+            <a:off x="0" y="0"/>
+            <a:ext cx="12192000" cy="171450"/>
+          </a:xfrm>
+          <a:prstGeom xmlns:a="http://schemas.openxmlformats.org/drawingml/2006/main" prst="rect">
+            <a:avLst/>
+          </a:prstGeom>
+          <a:solidFill xmlns:a="http://schemas.openxmlformats.org/drawingml/2006/main">
+            <a:srgbClr val="2730B6"/>
+          </a:solidFill>
+          <a:ln xmlns:a="http://schemas.openxmlformats.org/drawingml/2006/main" w="0">
+            <a:solidFill>
+              <a:srgbClr val="2730B6"/>
+            </a:solidFill>
+            <a:prstDash val="solid"/>
+          </a:ln>
+        </p:spPr>
+      </p:sp>
+      <p:sp>
+        <p:nvSpPr>
+          <p:cNvPr id="2" name="">
+            <a:extLst xmlns:a="http://schemas.openxmlformats.org/drawingml/2006/main">
+              <a:ext uri="{FF2B5EF4-FFF2-40B4-BE49-F238E27FC236}">
+                <a16:creationId xmlns:a16="http://schemas.microsoft.com/office/drawing/2014/main" id="{96E7C136-7478-4223-A596-1CE7D8247167}"/>
+              </a:ext>
+            </a:extLst>
+          </p:cNvPr>
+          <p:cNvSpPr>
+            <a:spLocks xmlns:a="http://schemas.openxmlformats.org/drawingml/2006/main" noGrp="1"/>
+          </p:cNvSpPr>
+          <p:nvPr/>
+        </p:nvSpPr>
+        <p:spPr>
+          <a:xfrm xmlns:a="http://schemas.openxmlformats.org/drawingml/2006/main">
+            <a:off x="0" y="0"/>
+            <a:ext cx="171450" cy="6858000"/>
+          </a:xfrm>
+          <a:prstGeom xmlns:a="http://schemas.openxmlformats.org/drawingml/2006/main" prst="rect">
+            <a:avLst/>
+          </a:prstGeom>
+          <a:solidFill xmlns:a="http://schemas.openxmlformats.org/drawingml/2006/main">
+            <a:srgbClr val="2730B6"/>
+          </a:solidFill>
+          <a:ln xmlns:a="http://schemas.openxmlformats.org/drawingml/2006/main" w="0">
+            <a:solidFill>
+              <a:srgbClr val="2730B6"/>
+            </a:solidFill>
+            <a:prstDash val="solid"/>
+          </a:ln>
+        </p:spPr>
+      </p:sp>
+      <p:sp>
+        <p:nvSpPr>
+          <p:cNvPr id="3" name="">
+            <a:extLst xmlns:a="http://schemas.openxmlformats.org/drawingml/2006/main">
+              <a:ext uri="{FF2B5EF4-FFF2-40B4-BE49-F238E27FC236}">
+                <a16:creationId xmlns:a16="http://schemas.microsoft.com/office/drawing/2014/main" id="{A4260971-9334-4FB1-9F0F-3185EE1C58F6}"/>
+              </a:ext>
+            </a:extLst>
+          </p:cNvPr>
+          <p:cNvSpPr>
+            <a:spLocks xmlns:a="http://schemas.openxmlformats.org/drawingml/2006/main" noGrp="1"/>
+          </p:cNvSpPr>
+          <p:nvPr/>
+        </p:nvSpPr>
+        <p:spPr>
+          <a:xfrm xmlns:a="http://schemas.openxmlformats.org/drawingml/2006/main">
+            <a:off x="9810750" y="400050"/>
+            <a:ext cx="1428750" cy="228600"/>
+          </a:xfrm>
+          <a:prstGeom xmlns:a="http://schemas.openxmlformats.org/drawingml/2006/main" prst="rect">
+            <a:avLst/>
+          </a:prstGeom>
+          <a:noFill xmlns:a="http://schemas.openxmlformats.org/drawingml/2006/main"/>
+          <a:ln xmlns:a="http://schemas.openxmlformats.org/drawingml/2006/main" w="0">
+            <a:noFill/>
+            <a:prstDash val="solid"/>
+          </a:ln>
+        </p:spPr>
+        <p:txBody>
+          <a:bodyPr xmlns:a="http://schemas.openxmlformats.org/drawingml/2006/main"/>
+          <a:lstStyle xmlns:a="http://schemas.openxmlformats.org/drawingml/2006/main"/>
+          <a:p xmlns:a="http://schemas.openxmlformats.org/drawingml/2006/main">
+            <a:pPr algn="l">
+              <a:defRPr sz="975" b="1">
+                <a:solidFill>
+                  <a:srgbClr val="2730B6"/>
+                </a:solidFill>
+              </a:defRPr>
+            </a:pPr>
+            <a:r>
+              <a:rPr sz="975" b="1">
+                <a:solidFill>
+                  <a:srgbClr val="2730B6"/>
+                </a:solidFill>
+              </a:rPr>
+              <a:t>НИ ТГУ · ИДО</a:t>
+            </a:r>
+          </a:p>
+        </p:txBody>
+      </p:sp>
+      <p:sp>
+        <p:nvSpPr>
+          <p:cNvPr id="4" name="">
+            <a:extLst xmlns:a="http://schemas.openxmlformats.org/drawingml/2006/main">
+              <a:ext uri="{FF2B5EF4-FFF2-40B4-BE49-F238E27FC236}">
+                <a16:creationId xmlns:a16="http://schemas.microsoft.com/office/drawing/2014/main" id="{293E8F10-7FA2-42CC-9DF1-12FB2314D979}"/>
+              </a:ext>
+            </a:extLst>
+          </p:cNvPr>
+          <p:cNvSpPr>
+            <a:spLocks xmlns:a="http://schemas.openxmlformats.org/drawingml/2006/main" noGrp="1"/>
+          </p:cNvSpPr>
+          <p:nvPr/>
+        </p:nvSpPr>
+        <p:spPr>
+          <a:xfrm xmlns:a="http://schemas.openxmlformats.org/drawingml/2006/main">
+            <a:off x="11382375" y="400050"/>
+            <a:ext cx="361950" cy="228600"/>
+          </a:xfrm>
+          <a:prstGeom xmlns:a="http://schemas.openxmlformats.org/drawingml/2006/main" prst="rect">
+            <a:avLst/>
+          </a:prstGeom>
+          <a:noFill xmlns:a="http://schemas.openxmlformats.org/drawingml/2006/main"/>
+          <a:ln xmlns:a="http://schemas.openxmlformats.org/drawingml/2006/main" w="0">
+            <a:noFill/>
+            <a:prstDash val="solid"/>
+          </a:ln>
+        </p:spPr>
+        <p:txBody>
+          <a:bodyPr xmlns:a="http://schemas.openxmlformats.org/drawingml/2006/main"/>
+          <a:lstStyle xmlns:a="http://schemas.openxmlformats.org/drawingml/2006/main"/>
+          <a:p xmlns:a="http://schemas.openxmlformats.org/drawingml/2006/main">
+            <a:pPr algn="r">
+              <a:defRPr sz="975" b="0">
+                <a:solidFill>
+                  <a:srgbClr val="2730B6"/>
+                </a:solidFill>
+              </a:defRPr>
+            </a:pPr>
+            <a:r>
+              <a:rPr sz="975" b="0">
+                <a:solidFill>
+                  <a:srgbClr val="2730B6"/>
+                </a:solidFill>
+              </a:rPr>
+              <a:t>4</a:t>
+            </a:r>
+          </a:p>
+        </p:txBody>
+      </p:sp>
+      <p:sp>
+        <p:nvSpPr>
+          <p:cNvPr id="5" name="">
+            <a:extLst xmlns:a="http://schemas.openxmlformats.org/drawingml/2006/main">
+              <a:ext uri="{FF2B5EF4-FFF2-40B4-BE49-F238E27FC236}">
+                <a16:creationId xmlns:a16="http://schemas.microsoft.com/office/drawing/2014/main" id="{D47CD955-945D-4D83-A781-694F5B8A9744}"/>
               </a:ext>
             </a:extLst>
           </p:cNvPr>
@@ -4494,10 +5455,10 @@
       </p:sp>
       <p:sp>
         <p:nvSpPr>
-          <p:cNvPr id="2" name="">
-            <a:extLst xmlns:a="http://schemas.openxmlformats.org/drawingml/2006/main">
-              <a:ext uri="{FF2B5EF4-FFF2-40B4-BE49-F238E27FC236}">
-                <a16:creationId xmlns:a16="http://schemas.microsoft.com/office/drawing/2014/main" id="{F2602633-DFEB-4829-A329-A4268525CCED}"/>
+          <p:cNvPr id="6" name="">
+            <a:extLst xmlns:a="http://schemas.openxmlformats.org/drawingml/2006/main">
+              <a:ext uri="{FF2B5EF4-FFF2-40B4-BE49-F238E27FC236}">
+                <a16:creationId xmlns:a16="http://schemas.microsoft.com/office/drawing/2014/main" id="{CA880A7A-DE97-4BBE-A17A-83E0E9FB1A06}"/>
               </a:ext>
             </a:extLst>
           </p:cNvPr>
@@ -4515,11 +5476,11 @@
             <a:avLst/>
           </a:prstGeom>
           <a:solidFill xmlns:a="http://schemas.openxmlformats.org/drawingml/2006/main">
-            <a:srgbClr val="0F766E"/>
+            <a:srgbClr val="36D2CF"/>
           </a:solidFill>
           <a:ln xmlns:a="http://schemas.openxmlformats.org/drawingml/2006/main" w="0">
             <a:solidFill>
-              <a:srgbClr val="0F766E"/>
+              <a:srgbClr val="36D2CF"/>
             </a:solidFill>
             <a:prstDash val="solid"/>
           </a:ln>
@@ -4527,14 +5488,14 @@
       </p:sp>
       <p:pic>
         <p:nvPicPr>
-          <p:cNvPr id="16" name=""/>
+          <p:cNvPr id="24" name=""/>
           <p:cNvPicPr>
             <a:picLocks xmlns:a="http://schemas.openxmlformats.org/drawingml/2006/main" noChangeAspect="1"/>
           </p:cNvPicPr>
           <p:nvPr/>
         </p:nvPicPr>
         <p:blipFill>
-          <a:blip xmlns:r="http://schemas.openxmlformats.org/officeDocument/2006/relationships" xmlns:a="http://schemas.openxmlformats.org/drawingml/2006/main" r:embed="R099cf43014834c3f"/>
+          <a:blip xmlns:r="http://schemas.openxmlformats.org/officeDocument/2006/relationships" xmlns:a="http://schemas.openxmlformats.org/drawingml/2006/main" r:embed="R0aefd2a0a04b46e8"/>
           <a:stretch xmlns:a="http://schemas.openxmlformats.org/drawingml/2006/main"/>
         </p:blipFill>
         <p:spPr>
@@ -4549,10 +5510,10 @@
       </p:pic>
       <p:sp>
         <p:nvSpPr>
-          <p:cNvPr id="4" name="">
-            <a:extLst xmlns:a="http://schemas.openxmlformats.org/drawingml/2006/main">
-              <a:ext uri="{FF2B5EF4-FFF2-40B4-BE49-F238E27FC236}">
-                <a16:creationId xmlns:a16="http://schemas.microsoft.com/office/drawing/2014/main" id="{D994D23E-C45F-43B3-B9B5-F99A6C9C8B48}"/>
+          <p:cNvPr id="8" name="">
+            <a:extLst xmlns:a="http://schemas.openxmlformats.org/drawingml/2006/main">
+              <a:ext uri="{FF2B5EF4-FFF2-40B4-BE49-F238E27FC236}">
+                <a16:creationId xmlns:a16="http://schemas.microsoft.com/office/drawing/2014/main" id="{CE78B43D-093D-46D9-9F5F-72CDF09DABA3}"/>
               </a:ext>
             </a:extLst>
           </p:cNvPr>
@@ -4582,14 +5543,14 @@
             <a:pPr algn="l">
               <a:defRPr sz="1575" b="1">
                 <a:solidFill>
-                  <a:srgbClr val="0F766E"/>
+                  <a:srgbClr val="2730B6"/>
                 </a:solidFill>
               </a:defRPr>
             </a:pPr>
             <a:r>
               <a:rPr sz="1575" b="1">
                 <a:solidFill>
-                  <a:srgbClr val="0F766E"/>
+                  <a:srgbClr val="2730B6"/>
                 </a:solidFill>
               </a:rPr>
               <a:t>•</a:t>
@@ -4599,10 +5560,10 @@
       </p:sp>
       <p:sp>
         <p:nvSpPr>
-          <p:cNvPr id="5" name="">
-            <a:extLst xmlns:a="http://schemas.openxmlformats.org/drawingml/2006/main">
-              <a:ext uri="{FF2B5EF4-FFF2-40B4-BE49-F238E27FC236}">
-                <a16:creationId xmlns:a16="http://schemas.microsoft.com/office/drawing/2014/main" id="{0CB672C9-6C27-46F4-A1CB-EF2670D8614C}"/>
+          <p:cNvPr id="9" name="">
+            <a:extLst xmlns:a="http://schemas.openxmlformats.org/drawingml/2006/main">
+              <a:ext uri="{FF2B5EF4-FFF2-40B4-BE49-F238E27FC236}">
+                <a16:creationId xmlns:a16="http://schemas.microsoft.com/office/drawing/2014/main" id="{9A22EDB4-925D-4AE9-8741-7F6357632E4C}"/>
               </a:ext>
             </a:extLst>
           </p:cNvPr>
@@ -4649,10 +5610,10 @@
       </p:sp>
       <p:sp>
         <p:nvSpPr>
-          <p:cNvPr id="6" name="">
-            <a:extLst xmlns:a="http://schemas.openxmlformats.org/drawingml/2006/main">
-              <a:ext uri="{FF2B5EF4-FFF2-40B4-BE49-F238E27FC236}">
-                <a16:creationId xmlns:a16="http://schemas.microsoft.com/office/drawing/2014/main" id="{997654EC-609B-4BED-B598-938DCA17F27D}"/>
+          <p:cNvPr id="10" name="">
+            <a:extLst xmlns:a="http://schemas.openxmlformats.org/drawingml/2006/main">
+              <a:ext uri="{FF2B5EF4-FFF2-40B4-BE49-F238E27FC236}">
+                <a16:creationId xmlns:a16="http://schemas.microsoft.com/office/drawing/2014/main" id="{ADE5391C-5089-40A7-BC39-157C906D4258}"/>
               </a:ext>
             </a:extLst>
           </p:cNvPr>
@@ -4682,14 +5643,14 @@
             <a:pPr algn="l">
               <a:defRPr sz="1575" b="1">
                 <a:solidFill>
-                  <a:srgbClr val="0F766E"/>
+                  <a:srgbClr val="2730B6"/>
                 </a:solidFill>
               </a:defRPr>
             </a:pPr>
             <a:r>
               <a:rPr sz="1575" b="1">
                 <a:solidFill>
-                  <a:srgbClr val="0F766E"/>
+                  <a:srgbClr val="2730B6"/>
                 </a:solidFill>
               </a:rPr>
               <a:t>•</a:t>
@@ -4699,10 +5660,10 @@
       </p:sp>
       <p:sp>
         <p:nvSpPr>
-          <p:cNvPr id="7" name="">
-            <a:extLst xmlns:a="http://schemas.openxmlformats.org/drawingml/2006/main">
-              <a:ext uri="{FF2B5EF4-FFF2-40B4-BE49-F238E27FC236}">
-                <a16:creationId xmlns:a16="http://schemas.microsoft.com/office/drawing/2014/main" id="{800AA3FF-F1F0-4A6F-AA56-467A090E6E36}"/>
+          <p:cNvPr id="11" name="">
+            <a:extLst xmlns:a="http://schemas.openxmlformats.org/drawingml/2006/main">
+              <a:ext uri="{FF2B5EF4-FFF2-40B4-BE49-F238E27FC236}">
+                <a16:creationId xmlns:a16="http://schemas.microsoft.com/office/drawing/2014/main" id="{E7015E56-22DF-4C57-AF66-48FAB81A59B4}"/>
               </a:ext>
             </a:extLst>
           </p:cNvPr>
@@ -4749,10 +5710,10 @@
       </p:sp>
       <p:sp>
         <p:nvSpPr>
-          <p:cNvPr id="8" name="">
-            <a:extLst xmlns:a="http://schemas.openxmlformats.org/drawingml/2006/main">
-              <a:ext uri="{FF2B5EF4-FFF2-40B4-BE49-F238E27FC236}">
-                <a16:creationId xmlns:a16="http://schemas.microsoft.com/office/drawing/2014/main" id="{084F1AE8-2CA5-42E6-B066-0BA3F1A2AC1E}"/>
+          <p:cNvPr id="12" name="">
+            <a:extLst xmlns:a="http://schemas.openxmlformats.org/drawingml/2006/main">
+              <a:ext uri="{FF2B5EF4-FFF2-40B4-BE49-F238E27FC236}">
+                <a16:creationId xmlns:a16="http://schemas.microsoft.com/office/drawing/2014/main" id="{FB82A92F-9FF2-4787-BDF8-F70A683B5581}"/>
               </a:ext>
             </a:extLst>
           </p:cNvPr>
@@ -4782,14 +5743,14 @@
             <a:pPr algn="l">
               <a:defRPr sz="1575" b="1">
                 <a:solidFill>
-                  <a:srgbClr val="0F766E"/>
+                  <a:srgbClr val="2730B6"/>
                 </a:solidFill>
               </a:defRPr>
             </a:pPr>
             <a:r>
               <a:rPr sz="1575" b="1">
                 <a:solidFill>
-                  <a:srgbClr val="0F766E"/>
+                  <a:srgbClr val="2730B6"/>
                 </a:solidFill>
               </a:rPr>
               <a:t>•</a:t>
@@ -4799,10 +5760,10 @@
       </p:sp>
       <p:sp>
         <p:nvSpPr>
-          <p:cNvPr id="9" name="">
-            <a:extLst xmlns:a="http://schemas.openxmlformats.org/drawingml/2006/main">
-              <a:ext uri="{FF2B5EF4-FFF2-40B4-BE49-F238E27FC236}">
-                <a16:creationId xmlns:a16="http://schemas.microsoft.com/office/drawing/2014/main" id="{B98F7383-B349-47CD-B9F4-2CBF68281EE9}"/>
+          <p:cNvPr id="13" name="">
+            <a:extLst xmlns:a="http://schemas.openxmlformats.org/drawingml/2006/main">
+              <a:ext uri="{FF2B5EF4-FFF2-40B4-BE49-F238E27FC236}">
+                <a16:creationId xmlns:a16="http://schemas.microsoft.com/office/drawing/2014/main" id="{D6A1B55D-EF36-44AF-B63A-9EE223FE7A42}"/>
               </a:ext>
             </a:extLst>
           </p:cNvPr>
@@ -4849,10 +5810,10 @@
       </p:sp>
       <p:sp>
         <p:nvSpPr>
-          <p:cNvPr id="10" name="">
-            <a:extLst xmlns:a="http://schemas.openxmlformats.org/drawingml/2006/main">
-              <a:ext uri="{FF2B5EF4-FFF2-40B4-BE49-F238E27FC236}">
-                <a16:creationId xmlns:a16="http://schemas.microsoft.com/office/drawing/2014/main" id="{1504647C-2E5F-4220-9141-C224722385A3}"/>
+          <p:cNvPr id="14" name="">
+            <a:extLst xmlns:a="http://schemas.openxmlformats.org/drawingml/2006/main">
+              <a:ext uri="{FF2B5EF4-FFF2-40B4-BE49-F238E27FC236}">
+                <a16:creationId xmlns:a16="http://schemas.microsoft.com/office/drawing/2014/main" id="{BB5B478C-6CE8-4539-98D1-E3CC389ECF01}"/>
               </a:ext>
             </a:extLst>
           </p:cNvPr>
@@ -4882,14 +5843,14 @@
             <a:pPr algn="l">
               <a:defRPr sz="1575" b="1">
                 <a:solidFill>
-                  <a:srgbClr val="0F766E"/>
+                  <a:srgbClr val="2730B6"/>
                 </a:solidFill>
               </a:defRPr>
             </a:pPr>
             <a:r>
               <a:rPr sz="1575" b="1">
                 <a:solidFill>
-                  <a:srgbClr val="0F766E"/>
+                  <a:srgbClr val="2730B6"/>
                 </a:solidFill>
               </a:rPr>
               <a:t>•</a:t>
@@ -4899,10 +5860,10 @@
       </p:sp>
       <p:sp>
         <p:nvSpPr>
-          <p:cNvPr id="11" name="">
-            <a:extLst xmlns:a="http://schemas.openxmlformats.org/drawingml/2006/main">
-              <a:ext uri="{FF2B5EF4-FFF2-40B4-BE49-F238E27FC236}">
-                <a16:creationId xmlns:a16="http://schemas.microsoft.com/office/drawing/2014/main" id="{465915C5-060B-415D-8FCD-EA780FF9E4B8}"/>
+          <p:cNvPr id="15" name="">
+            <a:extLst xmlns:a="http://schemas.openxmlformats.org/drawingml/2006/main">
+              <a:ext uri="{FF2B5EF4-FFF2-40B4-BE49-F238E27FC236}">
+                <a16:creationId xmlns:a16="http://schemas.microsoft.com/office/drawing/2014/main" id="{BD785FC9-6706-4D78-B96E-1D7D63916664}"/>
               </a:ext>
             </a:extLst>
           </p:cNvPr>
@@ -4949,10 +5910,10 @@
       </p:sp>
       <p:sp>
         <p:nvSpPr>
-          <p:cNvPr id="12" name="">
-            <a:extLst xmlns:a="http://schemas.openxmlformats.org/drawingml/2006/main">
-              <a:ext uri="{FF2B5EF4-FFF2-40B4-BE49-F238E27FC236}">
-                <a16:creationId xmlns:a16="http://schemas.microsoft.com/office/drawing/2014/main" id="{0FD85472-723D-46B1-9A82-34EDF992E39F}"/>
+          <p:cNvPr id="16" name="">
+            <a:extLst xmlns:a="http://schemas.openxmlformats.org/drawingml/2006/main">
+              <a:ext uri="{FF2B5EF4-FFF2-40B4-BE49-F238E27FC236}">
+                <a16:creationId xmlns:a16="http://schemas.microsoft.com/office/drawing/2014/main" id="{1ABDBEE8-CA82-43DE-A2EA-79435D70FF3F}"/>
               </a:ext>
             </a:extLst>
           </p:cNvPr>
@@ -4982,14 +5943,14 @@
             <a:pPr algn="l">
               <a:defRPr sz="975" b="0">
                 <a:solidFill>
-                  <a:srgbClr val="64748B"/>
+                  <a:srgbClr val="2730B6"/>
                 </a:solidFill>
               </a:defRPr>
             </a:pPr>
             <a:r>
               <a:rPr sz="975" b="0">
                 <a:solidFill>
-                  <a:srgbClr val="64748B"/>
+                  <a:srgbClr val="2730B6"/>
                 </a:solidFill>
               </a:rPr>
               <a:t>ADAS ScenarioGuard · ВКР · 2026</a:t>
@@ -4999,10 +5960,10 @@
       </p:sp>
       <p:sp>
         <p:nvSpPr>
-          <p:cNvPr id="13" name="">
-            <a:extLst xmlns:a="http://schemas.openxmlformats.org/drawingml/2006/main">
-              <a:ext uri="{FF2B5EF4-FFF2-40B4-BE49-F238E27FC236}">
-                <a16:creationId xmlns:a16="http://schemas.microsoft.com/office/drawing/2014/main" id="{200D8C23-AB27-4F4B-AAE1-E99AEC5D6B3B}"/>
+          <p:cNvPr id="17" name="">
+            <a:extLst xmlns:a="http://schemas.openxmlformats.org/drawingml/2006/main">
+              <a:ext uri="{FF2B5EF4-FFF2-40B4-BE49-F238E27FC236}">
+                <a16:creationId xmlns:a16="http://schemas.microsoft.com/office/drawing/2014/main" id="{A6B8210B-66F2-4CB7-8D83-EA7915509AB2}"/>
               </a:ext>
             </a:extLst>
           </p:cNvPr>
@@ -5032,14 +5993,14 @@
             <a:pPr algn="r">
               <a:defRPr sz="975" b="0">
                 <a:solidFill>
-                  <a:srgbClr val="64748B"/>
+                  <a:srgbClr val="2730B6"/>
                 </a:solidFill>
               </a:defRPr>
             </a:pPr>
             <a:r>
               <a:rPr sz="975" b="0">
                 <a:solidFill>
-                  <a:srgbClr val="64748B"/>
+                  <a:srgbClr val="2730B6"/>
                 </a:solidFill>
               </a:rPr>
               <a:t>4</a:t>
@@ -5050,7 +6011,7 @@
     </p:spTree>
     <p:extLst>
       <p:ext uri="{BB962C8B-B14F-4D97-AF65-F5344CB8AC3E}">
-        <p14:creationId xmlns:p14="http://schemas.microsoft.com/office/powerpoint/2010/main" val="1295892190"/>
+        <p14:creationId xmlns:p14="http://schemas.microsoft.com/office/powerpoint/2010/main" val="1657373207"/>
       </p:ext>
     </p:extLst>
   </p:cSld>
@@ -5081,7 +6042,173 @@
           <p:cNvPr id="1" name="">
             <a:extLst xmlns:a="http://schemas.openxmlformats.org/drawingml/2006/main">
               <a:ext uri="{FF2B5EF4-FFF2-40B4-BE49-F238E27FC236}">
-                <a16:creationId xmlns:a16="http://schemas.microsoft.com/office/drawing/2014/main" id="{23A6707C-63CA-4660-AF42-AC287E0086F2}"/>
+                <a16:creationId xmlns:a16="http://schemas.microsoft.com/office/drawing/2014/main" id="{590EA87D-AA3C-4134-9199-44E159532397}"/>
+              </a:ext>
+            </a:extLst>
+          </p:cNvPr>
+          <p:cNvSpPr>
+            <a:spLocks xmlns:a="http://schemas.openxmlformats.org/drawingml/2006/main" noGrp="1"/>
+          </p:cNvSpPr>
+          <p:nvPr/>
+        </p:nvSpPr>
+        <p:spPr>
+          <a:xfrm xmlns:a="http://schemas.openxmlformats.org/drawingml/2006/main">
+            <a:off x="0" y="0"/>
+            <a:ext cx="12192000" cy="171450"/>
+          </a:xfrm>
+          <a:prstGeom xmlns:a="http://schemas.openxmlformats.org/drawingml/2006/main" prst="rect">
+            <a:avLst/>
+          </a:prstGeom>
+          <a:solidFill xmlns:a="http://schemas.openxmlformats.org/drawingml/2006/main">
+            <a:srgbClr val="2730B6"/>
+          </a:solidFill>
+          <a:ln xmlns:a="http://schemas.openxmlformats.org/drawingml/2006/main" w="0">
+            <a:solidFill>
+              <a:srgbClr val="2730B6"/>
+            </a:solidFill>
+            <a:prstDash val="solid"/>
+          </a:ln>
+        </p:spPr>
+      </p:sp>
+      <p:sp>
+        <p:nvSpPr>
+          <p:cNvPr id="2" name="">
+            <a:extLst xmlns:a="http://schemas.openxmlformats.org/drawingml/2006/main">
+              <a:ext uri="{FF2B5EF4-FFF2-40B4-BE49-F238E27FC236}">
+                <a16:creationId xmlns:a16="http://schemas.microsoft.com/office/drawing/2014/main" id="{B5C3C527-5AE6-4776-9AAD-6A762C1B0981}"/>
+              </a:ext>
+            </a:extLst>
+          </p:cNvPr>
+          <p:cNvSpPr>
+            <a:spLocks xmlns:a="http://schemas.openxmlformats.org/drawingml/2006/main" noGrp="1"/>
+          </p:cNvSpPr>
+          <p:nvPr/>
+        </p:nvSpPr>
+        <p:spPr>
+          <a:xfrm xmlns:a="http://schemas.openxmlformats.org/drawingml/2006/main">
+            <a:off x="0" y="0"/>
+            <a:ext cx="171450" cy="6858000"/>
+          </a:xfrm>
+          <a:prstGeom xmlns:a="http://schemas.openxmlformats.org/drawingml/2006/main" prst="rect">
+            <a:avLst/>
+          </a:prstGeom>
+          <a:solidFill xmlns:a="http://schemas.openxmlformats.org/drawingml/2006/main">
+            <a:srgbClr val="2730B6"/>
+          </a:solidFill>
+          <a:ln xmlns:a="http://schemas.openxmlformats.org/drawingml/2006/main" w="0">
+            <a:solidFill>
+              <a:srgbClr val="2730B6"/>
+            </a:solidFill>
+            <a:prstDash val="solid"/>
+          </a:ln>
+        </p:spPr>
+      </p:sp>
+      <p:sp>
+        <p:nvSpPr>
+          <p:cNvPr id="3" name="">
+            <a:extLst xmlns:a="http://schemas.openxmlformats.org/drawingml/2006/main">
+              <a:ext uri="{FF2B5EF4-FFF2-40B4-BE49-F238E27FC236}">
+                <a16:creationId xmlns:a16="http://schemas.microsoft.com/office/drawing/2014/main" id="{6F6F6AFE-9EE1-4A95-9603-D12F420B2506}"/>
+              </a:ext>
+            </a:extLst>
+          </p:cNvPr>
+          <p:cNvSpPr>
+            <a:spLocks xmlns:a="http://schemas.openxmlformats.org/drawingml/2006/main" noGrp="1"/>
+          </p:cNvSpPr>
+          <p:nvPr/>
+        </p:nvSpPr>
+        <p:spPr>
+          <a:xfrm xmlns:a="http://schemas.openxmlformats.org/drawingml/2006/main">
+            <a:off x="9810750" y="400050"/>
+            <a:ext cx="1428750" cy="228600"/>
+          </a:xfrm>
+          <a:prstGeom xmlns:a="http://schemas.openxmlformats.org/drawingml/2006/main" prst="rect">
+            <a:avLst/>
+          </a:prstGeom>
+          <a:noFill xmlns:a="http://schemas.openxmlformats.org/drawingml/2006/main"/>
+          <a:ln xmlns:a="http://schemas.openxmlformats.org/drawingml/2006/main" w="0">
+            <a:noFill/>
+            <a:prstDash val="solid"/>
+          </a:ln>
+        </p:spPr>
+        <p:txBody>
+          <a:bodyPr xmlns:a="http://schemas.openxmlformats.org/drawingml/2006/main"/>
+          <a:lstStyle xmlns:a="http://schemas.openxmlformats.org/drawingml/2006/main"/>
+          <a:p xmlns:a="http://schemas.openxmlformats.org/drawingml/2006/main">
+            <a:pPr algn="l">
+              <a:defRPr sz="975" b="1">
+                <a:solidFill>
+                  <a:srgbClr val="2730B6"/>
+                </a:solidFill>
+              </a:defRPr>
+            </a:pPr>
+            <a:r>
+              <a:rPr sz="975" b="1">
+                <a:solidFill>
+                  <a:srgbClr val="2730B6"/>
+                </a:solidFill>
+              </a:rPr>
+              <a:t>НИ ТГУ · ИДО</a:t>
+            </a:r>
+          </a:p>
+        </p:txBody>
+      </p:sp>
+      <p:sp>
+        <p:nvSpPr>
+          <p:cNvPr id="4" name="">
+            <a:extLst xmlns:a="http://schemas.openxmlformats.org/drawingml/2006/main">
+              <a:ext uri="{FF2B5EF4-FFF2-40B4-BE49-F238E27FC236}">
+                <a16:creationId xmlns:a16="http://schemas.microsoft.com/office/drawing/2014/main" id="{70ECFF27-3E95-4194-BCC5-79337F7F1F5C}"/>
+              </a:ext>
+            </a:extLst>
+          </p:cNvPr>
+          <p:cNvSpPr>
+            <a:spLocks xmlns:a="http://schemas.openxmlformats.org/drawingml/2006/main" noGrp="1"/>
+          </p:cNvSpPr>
+          <p:nvPr/>
+        </p:nvSpPr>
+        <p:spPr>
+          <a:xfrm xmlns:a="http://schemas.openxmlformats.org/drawingml/2006/main">
+            <a:off x="11382375" y="400050"/>
+            <a:ext cx="361950" cy="228600"/>
+          </a:xfrm>
+          <a:prstGeom xmlns:a="http://schemas.openxmlformats.org/drawingml/2006/main" prst="rect">
+            <a:avLst/>
+          </a:prstGeom>
+          <a:noFill xmlns:a="http://schemas.openxmlformats.org/drawingml/2006/main"/>
+          <a:ln xmlns:a="http://schemas.openxmlformats.org/drawingml/2006/main" w="0">
+            <a:noFill/>
+            <a:prstDash val="solid"/>
+          </a:ln>
+        </p:spPr>
+        <p:txBody>
+          <a:bodyPr xmlns:a="http://schemas.openxmlformats.org/drawingml/2006/main"/>
+          <a:lstStyle xmlns:a="http://schemas.openxmlformats.org/drawingml/2006/main"/>
+          <a:p xmlns:a="http://schemas.openxmlformats.org/drawingml/2006/main">
+            <a:pPr algn="r">
+              <a:defRPr sz="975" b="0">
+                <a:solidFill>
+                  <a:srgbClr val="2730B6"/>
+                </a:solidFill>
+              </a:defRPr>
+            </a:pPr>
+            <a:r>
+              <a:rPr sz="975" b="0">
+                <a:solidFill>
+                  <a:srgbClr val="2730B6"/>
+                </a:solidFill>
+              </a:rPr>
+              <a:t>5</a:t>
+            </a:r>
+          </a:p>
+        </p:txBody>
+      </p:sp>
+      <p:sp>
+        <p:nvSpPr>
+          <p:cNvPr id="5" name="">
+            <a:extLst xmlns:a="http://schemas.openxmlformats.org/drawingml/2006/main">
+              <a:ext uri="{FF2B5EF4-FFF2-40B4-BE49-F238E27FC236}">
+                <a16:creationId xmlns:a16="http://schemas.microsoft.com/office/drawing/2014/main" id="{7DCB0F80-D0C9-4003-9FBF-0D371203518B}"/>
               </a:ext>
             </a:extLst>
           </p:cNvPr>
@@ -5128,10 +6255,10 @@
       </p:sp>
       <p:sp>
         <p:nvSpPr>
-          <p:cNvPr id="2" name="">
-            <a:extLst xmlns:a="http://schemas.openxmlformats.org/drawingml/2006/main">
-              <a:ext uri="{FF2B5EF4-FFF2-40B4-BE49-F238E27FC236}">
-                <a16:creationId xmlns:a16="http://schemas.microsoft.com/office/drawing/2014/main" id="{DB4F5BF5-EFBF-4F13-8454-0A6E76EA4324}"/>
+          <p:cNvPr id="6" name="">
+            <a:extLst xmlns:a="http://schemas.openxmlformats.org/drawingml/2006/main">
+              <a:ext uri="{FF2B5EF4-FFF2-40B4-BE49-F238E27FC236}">
+                <a16:creationId xmlns:a16="http://schemas.microsoft.com/office/drawing/2014/main" id="{CDD23748-B558-4F22-B5C5-99679A9DC4D6}"/>
               </a:ext>
             </a:extLst>
           </p:cNvPr>
@@ -5149,11 +6276,11 @@
             <a:avLst/>
           </a:prstGeom>
           <a:solidFill xmlns:a="http://schemas.openxmlformats.org/drawingml/2006/main">
-            <a:srgbClr val="0F766E"/>
+            <a:srgbClr val="36D2CF"/>
           </a:solidFill>
           <a:ln xmlns:a="http://schemas.openxmlformats.org/drawingml/2006/main" w="0">
             <a:solidFill>
-              <a:srgbClr val="0F766E"/>
+              <a:srgbClr val="36D2CF"/>
             </a:solidFill>
             <a:prstDash val="solid"/>
           </a:ln>
@@ -5161,14 +6288,14 @@
       </p:sp>
       <p:pic>
         <p:nvPicPr>
-          <p:cNvPr id="12" name=""/>
+          <p:cNvPr id="20" name=""/>
           <p:cNvPicPr>
             <a:picLocks xmlns:a="http://schemas.openxmlformats.org/drawingml/2006/main" noChangeAspect="1"/>
           </p:cNvPicPr>
           <p:nvPr/>
         </p:nvPicPr>
         <p:blipFill>
-          <a:blip xmlns:r="http://schemas.openxmlformats.org/officeDocument/2006/relationships" xmlns:a="http://schemas.openxmlformats.org/drawingml/2006/main" r:embed="Ra37f084d62c94db2"/>
+          <a:blip xmlns:r="http://schemas.openxmlformats.org/officeDocument/2006/relationships" xmlns:a="http://schemas.openxmlformats.org/drawingml/2006/main" r:embed="R06737f89e3d84af4"/>
           <a:stretch xmlns:a="http://schemas.openxmlformats.org/drawingml/2006/main"/>
         </p:blipFill>
         <p:spPr>
@@ -5183,10 +6310,10 @@
       </p:pic>
       <p:sp>
         <p:nvSpPr>
-          <p:cNvPr id="4" name="">
-            <a:extLst xmlns:a="http://schemas.openxmlformats.org/drawingml/2006/main">
-              <a:ext uri="{FF2B5EF4-FFF2-40B4-BE49-F238E27FC236}">
-                <a16:creationId xmlns:a16="http://schemas.microsoft.com/office/drawing/2014/main" id="{746BC0C2-AAAE-444F-B4DF-72E2E5ACB4E6}"/>
+          <p:cNvPr id="8" name="">
+            <a:extLst xmlns:a="http://schemas.openxmlformats.org/drawingml/2006/main">
+              <a:ext uri="{FF2B5EF4-FFF2-40B4-BE49-F238E27FC236}">
+                <a16:creationId xmlns:a16="http://schemas.microsoft.com/office/drawing/2014/main" id="{953472DD-3620-4DA4-8DCC-A92551664992}"/>
               </a:ext>
             </a:extLst>
           </p:cNvPr>
@@ -5239,10 +6366,10 @@
       </p:sp>
       <p:sp>
         <p:nvSpPr>
-          <p:cNvPr id="5" name="">
-            <a:extLst xmlns:a="http://schemas.openxmlformats.org/drawingml/2006/main">
-              <a:ext uri="{FF2B5EF4-FFF2-40B4-BE49-F238E27FC236}">
-                <a16:creationId xmlns:a16="http://schemas.microsoft.com/office/drawing/2014/main" id="{48089B71-4B06-4ECF-9280-1E4775663BE9}"/>
+          <p:cNvPr id="9" name="">
+            <a:extLst xmlns:a="http://schemas.openxmlformats.org/drawingml/2006/main">
+              <a:ext uri="{FF2B5EF4-FFF2-40B4-BE49-F238E27FC236}">
+                <a16:creationId xmlns:a16="http://schemas.microsoft.com/office/drawing/2014/main" id="{A90B4F07-F0F0-429B-AFB3-4260B368E8DB}"/>
               </a:ext>
             </a:extLst>
           </p:cNvPr>
@@ -5295,10 +6422,10 @@
       </p:sp>
       <p:sp>
         <p:nvSpPr>
-          <p:cNvPr id="6" name="">
-            <a:extLst xmlns:a="http://schemas.openxmlformats.org/drawingml/2006/main">
-              <a:ext uri="{FF2B5EF4-FFF2-40B4-BE49-F238E27FC236}">
-                <a16:creationId xmlns:a16="http://schemas.microsoft.com/office/drawing/2014/main" id="{C977493A-146F-49C3-95EE-7E3050220DEB}"/>
+          <p:cNvPr id="10" name="">
+            <a:extLst xmlns:a="http://schemas.openxmlformats.org/drawingml/2006/main">
+              <a:ext uri="{FF2B5EF4-FFF2-40B4-BE49-F238E27FC236}">
+                <a16:creationId xmlns:a16="http://schemas.microsoft.com/office/drawing/2014/main" id="{F8744807-B525-4F75-BAC1-0C054B35A459}"/>
               </a:ext>
             </a:extLst>
           </p:cNvPr>
@@ -5351,10 +6478,10 @@
       </p:sp>
       <p:sp>
         <p:nvSpPr>
-          <p:cNvPr id="7" name="">
-            <a:extLst xmlns:a="http://schemas.openxmlformats.org/drawingml/2006/main">
-              <a:ext uri="{FF2B5EF4-FFF2-40B4-BE49-F238E27FC236}">
-                <a16:creationId xmlns:a16="http://schemas.microsoft.com/office/drawing/2014/main" id="{138806E5-029E-4010-A383-C5C6D6E36360}"/>
+          <p:cNvPr id="11" name="">
+            <a:extLst xmlns:a="http://schemas.openxmlformats.org/drawingml/2006/main">
+              <a:ext uri="{FF2B5EF4-FFF2-40B4-BE49-F238E27FC236}">
+                <a16:creationId xmlns:a16="http://schemas.microsoft.com/office/drawing/2014/main" id="{7021F5BE-58B5-4F39-9453-C4BB75D14CC7}"/>
               </a:ext>
             </a:extLst>
           </p:cNvPr>
@@ -5407,10 +6534,10 @@
       </p:sp>
       <p:sp>
         <p:nvSpPr>
-          <p:cNvPr id="8" name="">
-            <a:extLst xmlns:a="http://schemas.openxmlformats.org/drawingml/2006/main">
-              <a:ext uri="{FF2B5EF4-FFF2-40B4-BE49-F238E27FC236}">
-                <a16:creationId xmlns:a16="http://schemas.microsoft.com/office/drawing/2014/main" id="{62DE64CD-11C2-4504-A00F-1C6E0CAC0399}"/>
+          <p:cNvPr id="12" name="">
+            <a:extLst xmlns:a="http://schemas.openxmlformats.org/drawingml/2006/main">
+              <a:ext uri="{FF2B5EF4-FFF2-40B4-BE49-F238E27FC236}">
+                <a16:creationId xmlns:a16="http://schemas.microsoft.com/office/drawing/2014/main" id="{3D296DDA-DB8A-4104-AE19-709548733FDE}"/>
               </a:ext>
             </a:extLst>
           </p:cNvPr>
@@ -5440,14 +6567,14 @@
             <a:pPr algn="l">
               <a:defRPr sz="975" b="0">
                 <a:solidFill>
-                  <a:srgbClr val="64748B"/>
+                  <a:srgbClr val="2730B6"/>
                 </a:solidFill>
               </a:defRPr>
             </a:pPr>
             <a:r>
               <a:rPr sz="975" b="0">
                 <a:solidFill>
-                  <a:srgbClr val="64748B"/>
+                  <a:srgbClr val="2730B6"/>
                 </a:solidFill>
               </a:rPr>
               <a:t>ADAS ScenarioGuard · ВКР · 2026</a:t>
@@ -5457,10 +6584,10 @@
       </p:sp>
       <p:sp>
         <p:nvSpPr>
-          <p:cNvPr id="9" name="">
-            <a:extLst xmlns:a="http://schemas.openxmlformats.org/drawingml/2006/main">
-              <a:ext uri="{FF2B5EF4-FFF2-40B4-BE49-F238E27FC236}">
-                <a16:creationId xmlns:a16="http://schemas.microsoft.com/office/drawing/2014/main" id="{B6F77225-D2B8-4C87-AD27-C49652E1987E}"/>
+          <p:cNvPr id="13" name="">
+            <a:extLst xmlns:a="http://schemas.openxmlformats.org/drawingml/2006/main">
+              <a:ext uri="{FF2B5EF4-FFF2-40B4-BE49-F238E27FC236}">
+                <a16:creationId xmlns:a16="http://schemas.microsoft.com/office/drawing/2014/main" id="{F388F6F1-2376-4D66-B11D-903F3A00116A}"/>
               </a:ext>
             </a:extLst>
           </p:cNvPr>
@@ -5490,14 +6617,14 @@
             <a:pPr algn="r">
               <a:defRPr sz="975" b="0">
                 <a:solidFill>
-                  <a:srgbClr val="64748B"/>
+                  <a:srgbClr val="2730B6"/>
                 </a:solidFill>
               </a:defRPr>
             </a:pPr>
             <a:r>
               <a:rPr sz="975" b="0">
                 <a:solidFill>
-                  <a:srgbClr val="64748B"/>
+                  <a:srgbClr val="2730B6"/>
                 </a:solidFill>
               </a:rPr>
               <a:t>5</a:t>
@@ -5508,7 +6635,7 @@
     </p:spTree>
     <p:extLst>
       <p:ext uri="{BB962C8B-B14F-4D97-AF65-F5344CB8AC3E}">
-        <p14:creationId xmlns:p14="http://schemas.microsoft.com/office/powerpoint/2010/main" val="311077645"/>
+        <p14:creationId xmlns:p14="http://schemas.microsoft.com/office/powerpoint/2010/main" val="1835321808"/>
       </p:ext>
     </p:extLst>
   </p:cSld>
@@ -5539,7 +6666,173 @@
           <p:cNvPr id="1" name="">
             <a:extLst xmlns:a="http://schemas.openxmlformats.org/drawingml/2006/main">
               <a:ext uri="{FF2B5EF4-FFF2-40B4-BE49-F238E27FC236}">
-                <a16:creationId xmlns:a16="http://schemas.microsoft.com/office/drawing/2014/main" id="{724AE388-4C79-488F-A4AC-5E3FE630CE6A}"/>
+                <a16:creationId xmlns:a16="http://schemas.microsoft.com/office/drawing/2014/main" id="{AE944E90-78E6-410E-A33E-7D43AA5AB464}"/>
+              </a:ext>
+            </a:extLst>
+          </p:cNvPr>
+          <p:cNvSpPr>
+            <a:spLocks xmlns:a="http://schemas.openxmlformats.org/drawingml/2006/main" noGrp="1"/>
+          </p:cNvSpPr>
+          <p:nvPr/>
+        </p:nvSpPr>
+        <p:spPr>
+          <a:xfrm xmlns:a="http://schemas.openxmlformats.org/drawingml/2006/main">
+            <a:off x="0" y="0"/>
+            <a:ext cx="12192000" cy="171450"/>
+          </a:xfrm>
+          <a:prstGeom xmlns:a="http://schemas.openxmlformats.org/drawingml/2006/main" prst="rect">
+            <a:avLst/>
+          </a:prstGeom>
+          <a:solidFill xmlns:a="http://schemas.openxmlformats.org/drawingml/2006/main">
+            <a:srgbClr val="2730B6"/>
+          </a:solidFill>
+          <a:ln xmlns:a="http://schemas.openxmlformats.org/drawingml/2006/main" w="0">
+            <a:solidFill>
+              <a:srgbClr val="2730B6"/>
+            </a:solidFill>
+            <a:prstDash val="solid"/>
+          </a:ln>
+        </p:spPr>
+      </p:sp>
+      <p:sp>
+        <p:nvSpPr>
+          <p:cNvPr id="2" name="">
+            <a:extLst xmlns:a="http://schemas.openxmlformats.org/drawingml/2006/main">
+              <a:ext uri="{FF2B5EF4-FFF2-40B4-BE49-F238E27FC236}">
+                <a16:creationId xmlns:a16="http://schemas.microsoft.com/office/drawing/2014/main" id="{AE14C3D5-1C6E-4E2E-AE1E-EF181A2B50D8}"/>
+              </a:ext>
+            </a:extLst>
+          </p:cNvPr>
+          <p:cNvSpPr>
+            <a:spLocks xmlns:a="http://schemas.openxmlformats.org/drawingml/2006/main" noGrp="1"/>
+          </p:cNvSpPr>
+          <p:nvPr/>
+        </p:nvSpPr>
+        <p:spPr>
+          <a:xfrm xmlns:a="http://schemas.openxmlformats.org/drawingml/2006/main">
+            <a:off x="0" y="0"/>
+            <a:ext cx="171450" cy="6858000"/>
+          </a:xfrm>
+          <a:prstGeom xmlns:a="http://schemas.openxmlformats.org/drawingml/2006/main" prst="rect">
+            <a:avLst/>
+          </a:prstGeom>
+          <a:solidFill xmlns:a="http://schemas.openxmlformats.org/drawingml/2006/main">
+            <a:srgbClr val="2730B6"/>
+          </a:solidFill>
+          <a:ln xmlns:a="http://schemas.openxmlformats.org/drawingml/2006/main" w="0">
+            <a:solidFill>
+              <a:srgbClr val="2730B6"/>
+            </a:solidFill>
+            <a:prstDash val="solid"/>
+          </a:ln>
+        </p:spPr>
+      </p:sp>
+      <p:sp>
+        <p:nvSpPr>
+          <p:cNvPr id="3" name="">
+            <a:extLst xmlns:a="http://schemas.openxmlformats.org/drawingml/2006/main">
+              <a:ext uri="{FF2B5EF4-FFF2-40B4-BE49-F238E27FC236}">
+                <a16:creationId xmlns:a16="http://schemas.microsoft.com/office/drawing/2014/main" id="{75584E7F-1B94-4777-A30B-A7A0905188EE}"/>
+              </a:ext>
+            </a:extLst>
+          </p:cNvPr>
+          <p:cNvSpPr>
+            <a:spLocks xmlns:a="http://schemas.openxmlformats.org/drawingml/2006/main" noGrp="1"/>
+          </p:cNvSpPr>
+          <p:nvPr/>
+        </p:nvSpPr>
+        <p:spPr>
+          <a:xfrm xmlns:a="http://schemas.openxmlformats.org/drawingml/2006/main">
+            <a:off x="9810750" y="400050"/>
+            <a:ext cx="1428750" cy="228600"/>
+          </a:xfrm>
+          <a:prstGeom xmlns:a="http://schemas.openxmlformats.org/drawingml/2006/main" prst="rect">
+            <a:avLst/>
+          </a:prstGeom>
+          <a:noFill xmlns:a="http://schemas.openxmlformats.org/drawingml/2006/main"/>
+          <a:ln xmlns:a="http://schemas.openxmlformats.org/drawingml/2006/main" w="0">
+            <a:noFill/>
+            <a:prstDash val="solid"/>
+          </a:ln>
+        </p:spPr>
+        <p:txBody>
+          <a:bodyPr xmlns:a="http://schemas.openxmlformats.org/drawingml/2006/main"/>
+          <a:lstStyle xmlns:a="http://schemas.openxmlformats.org/drawingml/2006/main"/>
+          <a:p xmlns:a="http://schemas.openxmlformats.org/drawingml/2006/main">
+            <a:pPr algn="l">
+              <a:defRPr sz="975" b="1">
+                <a:solidFill>
+                  <a:srgbClr val="2730B6"/>
+                </a:solidFill>
+              </a:defRPr>
+            </a:pPr>
+            <a:r>
+              <a:rPr sz="975" b="1">
+                <a:solidFill>
+                  <a:srgbClr val="2730B6"/>
+                </a:solidFill>
+              </a:rPr>
+              <a:t>НИ ТГУ · ИДО</a:t>
+            </a:r>
+          </a:p>
+        </p:txBody>
+      </p:sp>
+      <p:sp>
+        <p:nvSpPr>
+          <p:cNvPr id="4" name="">
+            <a:extLst xmlns:a="http://schemas.openxmlformats.org/drawingml/2006/main">
+              <a:ext uri="{FF2B5EF4-FFF2-40B4-BE49-F238E27FC236}">
+                <a16:creationId xmlns:a16="http://schemas.microsoft.com/office/drawing/2014/main" id="{B5FC7695-6BBD-4D99-A2A5-AE6DD4254803}"/>
+              </a:ext>
+            </a:extLst>
+          </p:cNvPr>
+          <p:cNvSpPr>
+            <a:spLocks xmlns:a="http://schemas.openxmlformats.org/drawingml/2006/main" noGrp="1"/>
+          </p:cNvSpPr>
+          <p:nvPr/>
+        </p:nvSpPr>
+        <p:spPr>
+          <a:xfrm xmlns:a="http://schemas.openxmlformats.org/drawingml/2006/main">
+            <a:off x="11382375" y="400050"/>
+            <a:ext cx="361950" cy="228600"/>
+          </a:xfrm>
+          <a:prstGeom xmlns:a="http://schemas.openxmlformats.org/drawingml/2006/main" prst="rect">
+            <a:avLst/>
+          </a:prstGeom>
+          <a:noFill xmlns:a="http://schemas.openxmlformats.org/drawingml/2006/main"/>
+          <a:ln xmlns:a="http://schemas.openxmlformats.org/drawingml/2006/main" w="0">
+            <a:noFill/>
+            <a:prstDash val="solid"/>
+          </a:ln>
+        </p:spPr>
+        <p:txBody>
+          <a:bodyPr xmlns:a="http://schemas.openxmlformats.org/drawingml/2006/main"/>
+          <a:lstStyle xmlns:a="http://schemas.openxmlformats.org/drawingml/2006/main"/>
+          <a:p xmlns:a="http://schemas.openxmlformats.org/drawingml/2006/main">
+            <a:pPr algn="r">
+              <a:defRPr sz="975" b="0">
+                <a:solidFill>
+                  <a:srgbClr val="2730B6"/>
+                </a:solidFill>
+              </a:defRPr>
+            </a:pPr>
+            <a:r>
+              <a:rPr sz="975" b="0">
+                <a:solidFill>
+                  <a:srgbClr val="2730B6"/>
+                </a:solidFill>
+              </a:rPr>
+              <a:t>6</a:t>
+            </a:r>
+          </a:p>
+        </p:txBody>
+      </p:sp>
+      <p:sp>
+        <p:nvSpPr>
+          <p:cNvPr id="5" name="">
+            <a:extLst xmlns:a="http://schemas.openxmlformats.org/drawingml/2006/main">
+              <a:ext uri="{FF2B5EF4-FFF2-40B4-BE49-F238E27FC236}">
+                <a16:creationId xmlns:a16="http://schemas.microsoft.com/office/drawing/2014/main" id="{9DED0800-15C5-47FF-B33E-C17075A770CA}"/>
               </a:ext>
             </a:extLst>
           </p:cNvPr>
@@ -5579,17 +6872,17 @@
                   <a:srgbClr val="0F172A"/>
                 </a:solidFill>
               </a:rPr>
-              <a:t>Архитектура разделяет данные, обучение, оценку и артефакты</a:t>
-            </a:r>
-          </a:p>
-        </p:txBody>
-      </p:sp>
-      <p:sp>
-        <p:nvSpPr>
-          <p:cNvPr id="2" name="">
-            <a:extLst xmlns:a="http://schemas.openxmlformats.org/drawingml/2006/main">
-              <a:ext uri="{FF2B5EF4-FFF2-40B4-BE49-F238E27FC236}">
-                <a16:creationId xmlns:a16="http://schemas.microsoft.com/office/drawing/2014/main" id="{D90C9CF5-FE70-4BA8-89D4-B8D7A2BA7D35}"/>
+              <a:t>Архитектура разделяет данные, обучение и оценку</a:t>
+            </a:r>
+          </a:p>
+        </p:txBody>
+      </p:sp>
+      <p:sp>
+        <p:nvSpPr>
+          <p:cNvPr id="6" name="">
+            <a:extLst xmlns:a="http://schemas.openxmlformats.org/drawingml/2006/main">
+              <a:ext uri="{FF2B5EF4-FFF2-40B4-BE49-F238E27FC236}">
+                <a16:creationId xmlns:a16="http://schemas.microsoft.com/office/drawing/2014/main" id="{2A5D015A-15DF-43BE-B0C3-16CF247F2562}"/>
               </a:ext>
             </a:extLst>
           </p:cNvPr>
@@ -5607,11 +6900,11 @@
             <a:avLst/>
           </a:prstGeom>
           <a:solidFill xmlns:a="http://schemas.openxmlformats.org/drawingml/2006/main">
-            <a:srgbClr val="0F766E"/>
+            <a:srgbClr val="36D2CF"/>
           </a:solidFill>
           <a:ln xmlns:a="http://schemas.openxmlformats.org/drawingml/2006/main" w="0">
             <a:solidFill>
-              <a:srgbClr val="0F766E"/>
+              <a:srgbClr val="36D2CF"/>
             </a:solidFill>
             <a:prstDash val="solid"/>
           </a:ln>
@@ -5619,14 +6912,14 @@
       </p:sp>
       <p:pic>
         <p:nvPicPr>
-          <p:cNvPr id="10" name=""/>
+          <p:cNvPr id="18" name=""/>
           <p:cNvPicPr>
             <a:picLocks xmlns:a="http://schemas.openxmlformats.org/drawingml/2006/main" noChangeAspect="1"/>
           </p:cNvPicPr>
           <p:nvPr/>
         </p:nvPicPr>
         <p:blipFill>
-          <a:blip xmlns:r="http://schemas.openxmlformats.org/officeDocument/2006/relationships" xmlns:a="http://schemas.openxmlformats.org/drawingml/2006/main" r:embed="Re1816ec0c4834255"/>
+          <a:blip xmlns:r="http://schemas.openxmlformats.org/officeDocument/2006/relationships" xmlns:a="http://schemas.openxmlformats.org/drawingml/2006/main" r:embed="R6fccbfe6081e411b"/>
           <a:stretch xmlns:a="http://schemas.openxmlformats.org/drawingml/2006/main"/>
         </p:blipFill>
         <p:spPr>
@@ -5641,14 +6934,14 @@
       </p:pic>
       <p:pic>
         <p:nvPicPr>
-          <p:cNvPr id="11" name=""/>
+          <p:cNvPr id="19" name=""/>
           <p:cNvPicPr>
             <a:picLocks xmlns:a="http://schemas.openxmlformats.org/drawingml/2006/main" noChangeAspect="1"/>
           </p:cNvPicPr>
           <p:nvPr/>
         </p:nvPicPr>
         <p:blipFill>
-          <a:blip xmlns:r="http://schemas.openxmlformats.org/officeDocument/2006/relationships" xmlns:a="http://schemas.openxmlformats.org/drawingml/2006/main" r:embed="R3e35a38eb8bf40af"/>
+          <a:blip xmlns:r="http://schemas.openxmlformats.org/officeDocument/2006/relationships" xmlns:a="http://schemas.openxmlformats.org/drawingml/2006/main" r:embed="R6889629a508f4cc4"/>
           <a:stretch xmlns:a="http://schemas.openxmlformats.org/drawingml/2006/main"/>
         </p:blipFill>
         <p:spPr>
@@ -5663,10 +6956,10 @@
       </p:pic>
       <p:sp>
         <p:nvSpPr>
-          <p:cNvPr id="5" name="">
-            <a:extLst xmlns:a="http://schemas.openxmlformats.org/drawingml/2006/main">
-              <a:ext uri="{FF2B5EF4-FFF2-40B4-BE49-F238E27FC236}">
-                <a16:creationId xmlns:a16="http://schemas.microsoft.com/office/drawing/2014/main" id="{42EEA042-7FB0-4E8C-BC7E-DA8D5FA042A7}"/>
+          <p:cNvPr id="9" name="">
+            <a:extLst xmlns:a="http://schemas.openxmlformats.org/drawingml/2006/main">
+              <a:ext uri="{FF2B5EF4-FFF2-40B4-BE49-F238E27FC236}">
+                <a16:creationId xmlns:a16="http://schemas.microsoft.com/office/drawing/2014/main" id="{7D50419B-B367-4C09-94C2-6699BC1067A5}"/>
               </a:ext>
             </a:extLst>
           </p:cNvPr>
@@ -5713,10 +7006,10 @@
       </p:sp>
       <p:sp>
         <p:nvSpPr>
-          <p:cNvPr id="6" name="">
-            <a:extLst xmlns:a="http://schemas.openxmlformats.org/drawingml/2006/main">
-              <a:ext uri="{FF2B5EF4-FFF2-40B4-BE49-F238E27FC236}">
-                <a16:creationId xmlns:a16="http://schemas.microsoft.com/office/drawing/2014/main" id="{C043E216-0A07-4A66-B5DB-201B150B8684}"/>
+          <p:cNvPr id="10" name="">
+            <a:extLst xmlns:a="http://schemas.openxmlformats.org/drawingml/2006/main">
+              <a:ext uri="{FF2B5EF4-FFF2-40B4-BE49-F238E27FC236}">
+                <a16:creationId xmlns:a16="http://schemas.microsoft.com/office/drawing/2014/main" id="{25563533-EB05-4DB2-A9D3-30A07E5E889A}"/>
               </a:ext>
             </a:extLst>
           </p:cNvPr>
@@ -5746,14 +7039,14 @@
             <a:pPr algn="l">
               <a:defRPr sz="975" b="0">
                 <a:solidFill>
-                  <a:srgbClr val="64748B"/>
+                  <a:srgbClr val="2730B6"/>
                 </a:solidFill>
               </a:defRPr>
             </a:pPr>
             <a:r>
               <a:rPr sz="975" b="0">
                 <a:solidFill>
-                  <a:srgbClr val="64748B"/>
+                  <a:srgbClr val="2730B6"/>
                 </a:solidFill>
               </a:rPr>
               <a:t>ADAS ScenarioGuard · ВКР · 2026</a:t>
@@ -5763,10 +7056,10 @@
       </p:sp>
       <p:sp>
         <p:nvSpPr>
-          <p:cNvPr id="7" name="">
-            <a:extLst xmlns:a="http://schemas.openxmlformats.org/drawingml/2006/main">
-              <a:ext uri="{FF2B5EF4-FFF2-40B4-BE49-F238E27FC236}">
-                <a16:creationId xmlns:a16="http://schemas.microsoft.com/office/drawing/2014/main" id="{2DEDBC03-F90D-4F49-99F5-A7B783AE741E}"/>
+          <p:cNvPr id="11" name="">
+            <a:extLst xmlns:a="http://schemas.openxmlformats.org/drawingml/2006/main">
+              <a:ext uri="{FF2B5EF4-FFF2-40B4-BE49-F238E27FC236}">
+                <a16:creationId xmlns:a16="http://schemas.microsoft.com/office/drawing/2014/main" id="{1213ADD8-386C-4653-B491-9A79CD8C9FC3}"/>
               </a:ext>
             </a:extLst>
           </p:cNvPr>
@@ -5796,14 +7089,14 @@
             <a:pPr algn="r">
               <a:defRPr sz="975" b="0">
                 <a:solidFill>
-                  <a:srgbClr val="64748B"/>
+                  <a:srgbClr val="2730B6"/>
                 </a:solidFill>
               </a:defRPr>
             </a:pPr>
             <a:r>
               <a:rPr sz="975" b="0">
                 <a:solidFill>
-                  <a:srgbClr val="64748B"/>
+                  <a:srgbClr val="2730B6"/>
                 </a:solidFill>
               </a:rPr>
               <a:t>6</a:t>
@@ -5814,7 +7107,7 @@
     </p:spTree>
     <p:extLst>
       <p:ext uri="{BB962C8B-B14F-4D97-AF65-F5344CB8AC3E}">
-        <p14:creationId xmlns:p14="http://schemas.microsoft.com/office/powerpoint/2010/main" val="1270894888"/>
+        <p14:creationId xmlns:p14="http://schemas.microsoft.com/office/powerpoint/2010/main" val="1015240549"/>
       </p:ext>
     </p:extLst>
   </p:cSld>
@@ -5845,7 +7138,173 @@
           <p:cNvPr id="1" name="">
             <a:extLst xmlns:a="http://schemas.openxmlformats.org/drawingml/2006/main">
               <a:ext uri="{FF2B5EF4-FFF2-40B4-BE49-F238E27FC236}">
-                <a16:creationId xmlns:a16="http://schemas.microsoft.com/office/drawing/2014/main" id="{80043200-1C44-4855-B84D-5538C145B8B7}"/>
+                <a16:creationId xmlns:a16="http://schemas.microsoft.com/office/drawing/2014/main" id="{0E1E0D6A-B4C6-4460-A3AF-B20176AEC1EA}"/>
+              </a:ext>
+            </a:extLst>
+          </p:cNvPr>
+          <p:cNvSpPr>
+            <a:spLocks xmlns:a="http://schemas.openxmlformats.org/drawingml/2006/main" noGrp="1"/>
+          </p:cNvSpPr>
+          <p:nvPr/>
+        </p:nvSpPr>
+        <p:spPr>
+          <a:xfrm xmlns:a="http://schemas.openxmlformats.org/drawingml/2006/main">
+            <a:off x="0" y="0"/>
+            <a:ext cx="12192000" cy="171450"/>
+          </a:xfrm>
+          <a:prstGeom xmlns:a="http://schemas.openxmlformats.org/drawingml/2006/main" prst="rect">
+            <a:avLst/>
+          </a:prstGeom>
+          <a:solidFill xmlns:a="http://schemas.openxmlformats.org/drawingml/2006/main">
+            <a:srgbClr val="2730B6"/>
+          </a:solidFill>
+          <a:ln xmlns:a="http://schemas.openxmlformats.org/drawingml/2006/main" w="0">
+            <a:solidFill>
+              <a:srgbClr val="2730B6"/>
+            </a:solidFill>
+            <a:prstDash val="solid"/>
+          </a:ln>
+        </p:spPr>
+      </p:sp>
+      <p:sp>
+        <p:nvSpPr>
+          <p:cNvPr id="2" name="">
+            <a:extLst xmlns:a="http://schemas.openxmlformats.org/drawingml/2006/main">
+              <a:ext uri="{FF2B5EF4-FFF2-40B4-BE49-F238E27FC236}">
+                <a16:creationId xmlns:a16="http://schemas.microsoft.com/office/drawing/2014/main" id="{A14AFC46-6CCB-4A73-B6D0-7E5711EEF549}"/>
+              </a:ext>
+            </a:extLst>
+          </p:cNvPr>
+          <p:cNvSpPr>
+            <a:spLocks xmlns:a="http://schemas.openxmlformats.org/drawingml/2006/main" noGrp="1"/>
+          </p:cNvSpPr>
+          <p:nvPr/>
+        </p:nvSpPr>
+        <p:spPr>
+          <a:xfrm xmlns:a="http://schemas.openxmlformats.org/drawingml/2006/main">
+            <a:off x="0" y="0"/>
+            <a:ext cx="171450" cy="6858000"/>
+          </a:xfrm>
+          <a:prstGeom xmlns:a="http://schemas.openxmlformats.org/drawingml/2006/main" prst="rect">
+            <a:avLst/>
+          </a:prstGeom>
+          <a:solidFill xmlns:a="http://schemas.openxmlformats.org/drawingml/2006/main">
+            <a:srgbClr val="2730B6"/>
+          </a:solidFill>
+          <a:ln xmlns:a="http://schemas.openxmlformats.org/drawingml/2006/main" w="0">
+            <a:solidFill>
+              <a:srgbClr val="2730B6"/>
+            </a:solidFill>
+            <a:prstDash val="solid"/>
+          </a:ln>
+        </p:spPr>
+      </p:sp>
+      <p:sp>
+        <p:nvSpPr>
+          <p:cNvPr id="3" name="">
+            <a:extLst xmlns:a="http://schemas.openxmlformats.org/drawingml/2006/main">
+              <a:ext uri="{FF2B5EF4-FFF2-40B4-BE49-F238E27FC236}">
+                <a16:creationId xmlns:a16="http://schemas.microsoft.com/office/drawing/2014/main" id="{336E7126-7428-46EC-BE41-5FCCCC3336D4}"/>
+              </a:ext>
+            </a:extLst>
+          </p:cNvPr>
+          <p:cNvSpPr>
+            <a:spLocks xmlns:a="http://schemas.openxmlformats.org/drawingml/2006/main" noGrp="1"/>
+          </p:cNvSpPr>
+          <p:nvPr/>
+        </p:nvSpPr>
+        <p:spPr>
+          <a:xfrm xmlns:a="http://schemas.openxmlformats.org/drawingml/2006/main">
+            <a:off x="9810750" y="400050"/>
+            <a:ext cx="1428750" cy="228600"/>
+          </a:xfrm>
+          <a:prstGeom xmlns:a="http://schemas.openxmlformats.org/drawingml/2006/main" prst="rect">
+            <a:avLst/>
+          </a:prstGeom>
+          <a:noFill xmlns:a="http://schemas.openxmlformats.org/drawingml/2006/main"/>
+          <a:ln xmlns:a="http://schemas.openxmlformats.org/drawingml/2006/main" w="0">
+            <a:noFill/>
+            <a:prstDash val="solid"/>
+          </a:ln>
+        </p:spPr>
+        <p:txBody>
+          <a:bodyPr xmlns:a="http://schemas.openxmlformats.org/drawingml/2006/main"/>
+          <a:lstStyle xmlns:a="http://schemas.openxmlformats.org/drawingml/2006/main"/>
+          <a:p xmlns:a="http://schemas.openxmlformats.org/drawingml/2006/main">
+            <a:pPr algn="l">
+              <a:defRPr sz="975" b="1">
+                <a:solidFill>
+                  <a:srgbClr val="2730B6"/>
+                </a:solidFill>
+              </a:defRPr>
+            </a:pPr>
+            <a:r>
+              <a:rPr sz="975" b="1">
+                <a:solidFill>
+                  <a:srgbClr val="2730B6"/>
+                </a:solidFill>
+              </a:rPr>
+              <a:t>НИ ТГУ · ИДО</a:t>
+            </a:r>
+          </a:p>
+        </p:txBody>
+      </p:sp>
+      <p:sp>
+        <p:nvSpPr>
+          <p:cNvPr id="4" name="">
+            <a:extLst xmlns:a="http://schemas.openxmlformats.org/drawingml/2006/main">
+              <a:ext uri="{FF2B5EF4-FFF2-40B4-BE49-F238E27FC236}">
+                <a16:creationId xmlns:a16="http://schemas.microsoft.com/office/drawing/2014/main" id="{B8559073-3A83-4FD9-AD3B-9FDBF65D484E}"/>
+              </a:ext>
+            </a:extLst>
+          </p:cNvPr>
+          <p:cNvSpPr>
+            <a:spLocks xmlns:a="http://schemas.openxmlformats.org/drawingml/2006/main" noGrp="1"/>
+          </p:cNvSpPr>
+          <p:nvPr/>
+        </p:nvSpPr>
+        <p:spPr>
+          <a:xfrm xmlns:a="http://schemas.openxmlformats.org/drawingml/2006/main">
+            <a:off x="11382375" y="400050"/>
+            <a:ext cx="361950" cy="228600"/>
+          </a:xfrm>
+          <a:prstGeom xmlns:a="http://schemas.openxmlformats.org/drawingml/2006/main" prst="rect">
+            <a:avLst/>
+          </a:prstGeom>
+          <a:noFill xmlns:a="http://schemas.openxmlformats.org/drawingml/2006/main"/>
+          <a:ln xmlns:a="http://schemas.openxmlformats.org/drawingml/2006/main" w="0">
+            <a:noFill/>
+            <a:prstDash val="solid"/>
+          </a:ln>
+        </p:spPr>
+        <p:txBody>
+          <a:bodyPr xmlns:a="http://schemas.openxmlformats.org/drawingml/2006/main"/>
+          <a:lstStyle xmlns:a="http://schemas.openxmlformats.org/drawingml/2006/main"/>
+          <a:p xmlns:a="http://schemas.openxmlformats.org/drawingml/2006/main">
+            <a:pPr algn="r">
+              <a:defRPr sz="975" b="0">
+                <a:solidFill>
+                  <a:srgbClr val="2730B6"/>
+                </a:solidFill>
+              </a:defRPr>
+            </a:pPr>
+            <a:r>
+              <a:rPr sz="975" b="0">
+                <a:solidFill>
+                  <a:srgbClr val="2730B6"/>
+                </a:solidFill>
+              </a:rPr>
+              <a:t>7</a:t>
+            </a:r>
+          </a:p>
+        </p:txBody>
+      </p:sp>
+      <p:sp>
+        <p:nvSpPr>
+          <p:cNvPr id="5" name="">
+            <a:extLst xmlns:a="http://schemas.openxmlformats.org/drawingml/2006/main">
+              <a:ext uri="{FF2B5EF4-FFF2-40B4-BE49-F238E27FC236}">
+                <a16:creationId xmlns:a16="http://schemas.microsoft.com/office/drawing/2014/main" id="{8A9CF86D-B329-4BEA-A738-8197238C473B}"/>
               </a:ext>
             </a:extLst>
           </p:cNvPr>
@@ -5892,10 +7351,10 @@
       </p:sp>
       <p:sp>
         <p:nvSpPr>
-          <p:cNvPr id="2" name="">
-            <a:extLst xmlns:a="http://schemas.openxmlformats.org/drawingml/2006/main">
-              <a:ext uri="{FF2B5EF4-FFF2-40B4-BE49-F238E27FC236}">
-                <a16:creationId xmlns:a16="http://schemas.microsoft.com/office/drawing/2014/main" id="{55214EDC-5AAD-4D21-A232-E83F125533F1}"/>
+          <p:cNvPr id="6" name="">
+            <a:extLst xmlns:a="http://schemas.openxmlformats.org/drawingml/2006/main">
+              <a:ext uri="{FF2B5EF4-FFF2-40B4-BE49-F238E27FC236}">
+                <a16:creationId xmlns:a16="http://schemas.microsoft.com/office/drawing/2014/main" id="{FD9ED136-30CC-4C51-A7AE-09CF5ADE60CD}"/>
               </a:ext>
             </a:extLst>
           </p:cNvPr>
@@ -5913,11 +7372,11 @@
             <a:avLst/>
           </a:prstGeom>
           <a:solidFill xmlns:a="http://schemas.openxmlformats.org/drawingml/2006/main">
-            <a:srgbClr val="0F766E"/>
+            <a:srgbClr val="36D2CF"/>
           </a:solidFill>
           <a:ln xmlns:a="http://schemas.openxmlformats.org/drawingml/2006/main" w="0">
             <a:solidFill>
-              <a:srgbClr val="0F766E"/>
+              <a:srgbClr val="36D2CF"/>
             </a:solidFill>
             <a:prstDash val="solid"/>
           </a:ln>
@@ -5925,10 +7384,10 @@
       </p:sp>
       <p:sp>
         <p:nvSpPr>
-          <p:cNvPr id="3" name="">
-            <a:extLst xmlns:a="http://schemas.openxmlformats.org/drawingml/2006/main">
-              <a:ext uri="{FF2B5EF4-FFF2-40B4-BE49-F238E27FC236}">
-                <a16:creationId xmlns:a16="http://schemas.microsoft.com/office/drawing/2014/main" id="{A065CACE-8F84-4605-9145-0B22C5968682}"/>
+          <p:cNvPr id="7" name="">
+            <a:extLst xmlns:a="http://schemas.openxmlformats.org/drawingml/2006/main">
+              <a:ext uri="{FF2B5EF4-FFF2-40B4-BE49-F238E27FC236}">
+                <a16:creationId xmlns:a16="http://schemas.microsoft.com/office/drawing/2014/main" id="{8FDA8A66-5CFB-44C6-822E-EC845676C5B9}"/>
               </a:ext>
             </a:extLst>
           </p:cNvPr>
@@ -5998,10 +7457,10 @@
       </p:sp>
       <p:sp>
         <p:nvSpPr>
-          <p:cNvPr id="4" name="">
-            <a:extLst xmlns:a="http://schemas.openxmlformats.org/drawingml/2006/main">
-              <a:ext uri="{FF2B5EF4-FFF2-40B4-BE49-F238E27FC236}">
-                <a16:creationId xmlns:a16="http://schemas.microsoft.com/office/drawing/2014/main" id="{54CF2173-DB4B-4517-B646-CDE043E8D9DB}"/>
+          <p:cNvPr id="8" name="">
+            <a:extLst xmlns:a="http://schemas.openxmlformats.org/drawingml/2006/main">
+              <a:ext uri="{FF2B5EF4-FFF2-40B4-BE49-F238E27FC236}">
+                <a16:creationId xmlns:a16="http://schemas.microsoft.com/office/drawing/2014/main" id="{6C19BF6A-8D0B-48B7-B9E8-EEC1E50E161F}"/>
               </a:ext>
             </a:extLst>
           </p:cNvPr>
@@ -6071,10 +7530,10 @@
       </p:sp>
       <p:sp>
         <p:nvSpPr>
-          <p:cNvPr id="5" name="">
-            <a:extLst xmlns:a="http://schemas.openxmlformats.org/drawingml/2006/main">
-              <a:ext uri="{FF2B5EF4-FFF2-40B4-BE49-F238E27FC236}">
-                <a16:creationId xmlns:a16="http://schemas.microsoft.com/office/drawing/2014/main" id="{3D70449B-0101-48AF-897B-B8E5733E72BA}"/>
+          <p:cNvPr id="9" name="">
+            <a:extLst xmlns:a="http://schemas.openxmlformats.org/drawingml/2006/main">
+              <a:ext uri="{FF2B5EF4-FFF2-40B4-BE49-F238E27FC236}">
+                <a16:creationId xmlns:a16="http://schemas.microsoft.com/office/drawing/2014/main" id="{ED00D7BE-0B44-4FEE-A496-807F548B026E}"/>
               </a:ext>
             </a:extLst>
           </p:cNvPr>
@@ -6144,10 +7603,10 @@
       </p:sp>
       <p:sp>
         <p:nvSpPr>
-          <p:cNvPr id="6" name="">
-            <a:extLst xmlns:a="http://schemas.openxmlformats.org/drawingml/2006/main">
-              <a:ext uri="{FF2B5EF4-FFF2-40B4-BE49-F238E27FC236}">
-                <a16:creationId xmlns:a16="http://schemas.microsoft.com/office/drawing/2014/main" id="{ED5512CB-58DE-47B8-90E5-42E9D8582F48}"/>
+          <p:cNvPr id="10" name="">
+            <a:extLst xmlns:a="http://schemas.openxmlformats.org/drawingml/2006/main">
+              <a:ext uri="{FF2B5EF4-FFF2-40B4-BE49-F238E27FC236}">
+                <a16:creationId xmlns:a16="http://schemas.microsoft.com/office/drawing/2014/main" id="{6C23835E-AA01-4F01-ADAA-55E9DD547242}"/>
               </a:ext>
             </a:extLst>
           </p:cNvPr>
@@ -6217,10 +7676,10 @@
       </p:sp>
       <p:sp>
         <p:nvSpPr>
-          <p:cNvPr id="7" name="">
-            <a:extLst xmlns:a="http://schemas.openxmlformats.org/drawingml/2006/main">
-              <a:ext uri="{FF2B5EF4-FFF2-40B4-BE49-F238E27FC236}">
-                <a16:creationId xmlns:a16="http://schemas.microsoft.com/office/drawing/2014/main" id="{E7EF699F-C70D-4C86-82F3-BAC10C4E595F}"/>
+          <p:cNvPr id="11" name="">
+            <a:extLst xmlns:a="http://schemas.openxmlformats.org/drawingml/2006/main">
+              <a:ext uri="{FF2B5EF4-FFF2-40B4-BE49-F238E27FC236}">
+                <a16:creationId xmlns:a16="http://schemas.microsoft.com/office/drawing/2014/main" id="{9C44839F-8124-4B97-8E2C-DFAF9EE373E5}"/>
               </a:ext>
             </a:extLst>
           </p:cNvPr>
@@ -6250,14 +7709,14 @@
             <a:pPr algn="l">
               <a:defRPr sz="1725" b="1">
                 <a:solidFill>
-                  <a:srgbClr val="0F766E"/>
+                  <a:srgbClr val="2730B6"/>
                 </a:solidFill>
               </a:defRPr>
             </a:pPr>
             <a:r>
               <a:rPr sz="1725" b="1">
                 <a:solidFill>
-                  <a:srgbClr val="0F766E"/>
+                  <a:srgbClr val="2730B6"/>
                 </a:solidFill>
               </a:rPr>
               <a:t>•</a:t>
@@ -6267,10 +7726,10 @@
       </p:sp>
       <p:sp>
         <p:nvSpPr>
-          <p:cNvPr id="8" name="">
-            <a:extLst xmlns:a="http://schemas.openxmlformats.org/drawingml/2006/main">
-              <a:ext uri="{FF2B5EF4-FFF2-40B4-BE49-F238E27FC236}">
-                <a16:creationId xmlns:a16="http://schemas.microsoft.com/office/drawing/2014/main" id="{7731C13F-714C-4C6D-B474-6D7FA5AA27EF}"/>
+          <p:cNvPr id="12" name="">
+            <a:extLst xmlns:a="http://schemas.openxmlformats.org/drawingml/2006/main">
+              <a:ext uri="{FF2B5EF4-FFF2-40B4-BE49-F238E27FC236}">
+                <a16:creationId xmlns:a16="http://schemas.microsoft.com/office/drawing/2014/main" id="{308DBFE6-0E5E-400A-8EBB-7181C33424BD}"/>
               </a:ext>
             </a:extLst>
           </p:cNvPr>
@@ -6317,10 +7776,10 @@
       </p:sp>
       <p:sp>
         <p:nvSpPr>
-          <p:cNvPr id="9" name="">
-            <a:extLst xmlns:a="http://schemas.openxmlformats.org/drawingml/2006/main">
-              <a:ext uri="{FF2B5EF4-FFF2-40B4-BE49-F238E27FC236}">
-                <a16:creationId xmlns:a16="http://schemas.microsoft.com/office/drawing/2014/main" id="{F21441A3-6347-45C8-832F-A3CE00E760F3}"/>
+          <p:cNvPr id="13" name="">
+            <a:extLst xmlns:a="http://schemas.openxmlformats.org/drawingml/2006/main">
+              <a:ext uri="{FF2B5EF4-FFF2-40B4-BE49-F238E27FC236}">
+                <a16:creationId xmlns:a16="http://schemas.microsoft.com/office/drawing/2014/main" id="{E8A1F157-D7D8-4CCE-9F3F-FC31D0563628}"/>
               </a:ext>
             </a:extLst>
           </p:cNvPr>
@@ -6350,14 +7809,14 @@
             <a:pPr algn="l">
               <a:defRPr sz="1725" b="1">
                 <a:solidFill>
-                  <a:srgbClr val="0F766E"/>
+                  <a:srgbClr val="2730B6"/>
                 </a:solidFill>
               </a:defRPr>
             </a:pPr>
             <a:r>
               <a:rPr sz="1725" b="1">
                 <a:solidFill>
-                  <a:srgbClr val="0F766E"/>
+                  <a:srgbClr val="2730B6"/>
                 </a:solidFill>
               </a:rPr>
               <a:t>•</a:t>
@@ -6367,10 +7826,10 @@
       </p:sp>
       <p:sp>
         <p:nvSpPr>
-          <p:cNvPr id="10" name="">
-            <a:extLst xmlns:a="http://schemas.openxmlformats.org/drawingml/2006/main">
-              <a:ext uri="{FF2B5EF4-FFF2-40B4-BE49-F238E27FC236}">
-                <a16:creationId xmlns:a16="http://schemas.microsoft.com/office/drawing/2014/main" id="{8CE5BBA5-BDC7-4A89-9032-186DD2C22CEB}"/>
+          <p:cNvPr id="14" name="">
+            <a:extLst xmlns:a="http://schemas.openxmlformats.org/drawingml/2006/main">
+              <a:ext uri="{FF2B5EF4-FFF2-40B4-BE49-F238E27FC236}">
+                <a16:creationId xmlns:a16="http://schemas.microsoft.com/office/drawing/2014/main" id="{9AEDE02D-DD3D-4C03-B5F0-34D9AC0CADAA}"/>
               </a:ext>
             </a:extLst>
           </p:cNvPr>
@@ -6417,10 +7876,10 @@
       </p:sp>
       <p:sp>
         <p:nvSpPr>
-          <p:cNvPr id="11" name="">
-            <a:extLst xmlns:a="http://schemas.openxmlformats.org/drawingml/2006/main">
-              <a:ext uri="{FF2B5EF4-FFF2-40B4-BE49-F238E27FC236}">
-                <a16:creationId xmlns:a16="http://schemas.microsoft.com/office/drawing/2014/main" id="{A6F20767-FADE-4486-AC4F-F49837E06245}"/>
+          <p:cNvPr id="15" name="">
+            <a:extLst xmlns:a="http://schemas.openxmlformats.org/drawingml/2006/main">
+              <a:ext uri="{FF2B5EF4-FFF2-40B4-BE49-F238E27FC236}">
+                <a16:creationId xmlns:a16="http://schemas.microsoft.com/office/drawing/2014/main" id="{0874990E-99CE-4CA0-81DD-084A82006A15}"/>
               </a:ext>
             </a:extLst>
           </p:cNvPr>
@@ -6450,14 +7909,14 @@
             <a:pPr algn="l">
               <a:defRPr sz="1725" b="1">
                 <a:solidFill>
-                  <a:srgbClr val="0F766E"/>
+                  <a:srgbClr val="2730B6"/>
                 </a:solidFill>
               </a:defRPr>
             </a:pPr>
             <a:r>
               <a:rPr sz="1725" b="1">
                 <a:solidFill>
-                  <a:srgbClr val="0F766E"/>
+                  <a:srgbClr val="2730B6"/>
                 </a:solidFill>
               </a:rPr>
               <a:t>•</a:t>
@@ -6467,10 +7926,10 @@
       </p:sp>
       <p:sp>
         <p:nvSpPr>
-          <p:cNvPr id="12" name="">
-            <a:extLst xmlns:a="http://schemas.openxmlformats.org/drawingml/2006/main">
-              <a:ext uri="{FF2B5EF4-FFF2-40B4-BE49-F238E27FC236}">
-                <a16:creationId xmlns:a16="http://schemas.microsoft.com/office/drawing/2014/main" id="{516445FA-1061-46B7-AB46-CEBCE10874B7}"/>
+          <p:cNvPr id="16" name="">
+            <a:extLst xmlns:a="http://schemas.openxmlformats.org/drawingml/2006/main">
+              <a:ext uri="{FF2B5EF4-FFF2-40B4-BE49-F238E27FC236}">
+                <a16:creationId xmlns:a16="http://schemas.microsoft.com/office/drawing/2014/main" id="{DB8E25BA-9BA1-4C0D-B5AE-3C649152AD0A}"/>
               </a:ext>
             </a:extLst>
           </p:cNvPr>
@@ -6517,10 +7976,10 @@
       </p:sp>
       <p:sp>
         <p:nvSpPr>
-          <p:cNvPr id="13" name="">
-            <a:extLst xmlns:a="http://schemas.openxmlformats.org/drawingml/2006/main">
-              <a:ext uri="{FF2B5EF4-FFF2-40B4-BE49-F238E27FC236}">
-                <a16:creationId xmlns:a16="http://schemas.microsoft.com/office/drawing/2014/main" id="{56C70A71-B747-4372-A0F1-AB8A5F7178FF}"/>
+          <p:cNvPr id="17" name="">
+            <a:extLst xmlns:a="http://schemas.openxmlformats.org/drawingml/2006/main">
+              <a:ext uri="{FF2B5EF4-FFF2-40B4-BE49-F238E27FC236}">
+                <a16:creationId xmlns:a16="http://schemas.microsoft.com/office/drawing/2014/main" id="{07E7B631-A522-460B-B357-370AF04EA54F}"/>
               </a:ext>
             </a:extLst>
           </p:cNvPr>
@@ -6550,14 +8009,14 @@
             <a:pPr algn="l">
               <a:defRPr sz="975" b="0">
                 <a:solidFill>
-                  <a:srgbClr val="64748B"/>
+                  <a:srgbClr val="2730B6"/>
                 </a:solidFill>
               </a:defRPr>
             </a:pPr>
             <a:r>
               <a:rPr sz="975" b="0">
                 <a:solidFill>
-                  <a:srgbClr val="64748B"/>
+                  <a:srgbClr val="2730B6"/>
                 </a:solidFill>
               </a:rPr>
               <a:t>ADAS ScenarioGuard · ВКР · 2026</a:t>
@@ -6567,10 +8026,10 @@
       </p:sp>
       <p:sp>
         <p:nvSpPr>
-          <p:cNvPr id="14" name="">
-            <a:extLst xmlns:a="http://schemas.openxmlformats.org/drawingml/2006/main">
-              <a:ext uri="{FF2B5EF4-FFF2-40B4-BE49-F238E27FC236}">
-                <a16:creationId xmlns:a16="http://schemas.microsoft.com/office/drawing/2014/main" id="{6414688A-DD4E-461D-AF63-AE0A63A76623}"/>
+          <p:cNvPr id="18" name="">
+            <a:extLst xmlns:a="http://schemas.openxmlformats.org/drawingml/2006/main">
+              <a:ext uri="{FF2B5EF4-FFF2-40B4-BE49-F238E27FC236}">
+                <a16:creationId xmlns:a16="http://schemas.microsoft.com/office/drawing/2014/main" id="{3D7BBB55-770F-4E25-8579-111ECD7A8ED8}"/>
               </a:ext>
             </a:extLst>
           </p:cNvPr>
@@ -6600,14 +8059,14 @@
             <a:pPr algn="r">
               <a:defRPr sz="975" b="0">
                 <a:solidFill>
-                  <a:srgbClr val="64748B"/>
+                  <a:srgbClr val="2730B6"/>
                 </a:solidFill>
               </a:defRPr>
             </a:pPr>
             <a:r>
               <a:rPr sz="975" b="0">
                 <a:solidFill>
-                  <a:srgbClr val="64748B"/>
+                  <a:srgbClr val="2730B6"/>
                 </a:solidFill>
               </a:rPr>
               <a:t>7</a:t>
@@ -6618,7 +8077,7 @@
     </p:spTree>
     <p:extLst>
       <p:ext uri="{BB962C8B-B14F-4D97-AF65-F5344CB8AC3E}">
-        <p14:creationId xmlns:p14="http://schemas.microsoft.com/office/powerpoint/2010/main" val="115752127"/>
+        <p14:creationId xmlns:p14="http://schemas.microsoft.com/office/powerpoint/2010/main" val="1950483786"/>
       </p:ext>
     </p:extLst>
   </p:cSld>
@@ -6649,7 +8108,173 @@
           <p:cNvPr id="1" name="">
             <a:extLst xmlns:a="http://schemas.openxmlformats.org/drawingml/2006/main">
               <a:ext uri="{FF2B5EF4-FFF2-40B4-BE49-F238E27FC236}">
-                <a16:creationId xmlns:a16="http://schemas.microsoft.com/office/drawing/2014/main" id="{46BFC825-D355-4F80-AAA6-0CA73B3A2A73}"/>
+                <a16:creationId xmlns:a16="http://schemas.microsoft.com/office/drawing/2014/main" id="{042E9C2A-85B2-458B-B8F1-3981876040E7}"/>
+              </a:ext>
+            </a:extLst>
+          </p:cNvPr>
+          <p:cNvSpPr>
+            <a:spLocks xmlns:a="http://schemas.openxmlformats.org/drawingml/2006/main" noGrp="1"/>
+          </p:cNvSpPr>
+          <p:nvPr/>
+        </p:nvSpPr>
+        <p:spPr>
+          <a:xfrm xmlns:a="http://schemas.openxmlformats.org/drawingml/2006/main">
+            <a:off x="0" y="0"/>
+            <a:ext cx="12192000" cy="171450"/>
+          </a:xfrm>
+          <a:prstGeom xmlns:a="http://schemas.openxmlformats.org/drawingml/2006/main" prst="rect">
+            <a:avLst/>
+          </a:prstGeom>
+          <a:solidFill xmlns:a="http://schemas.openxmlformats.org/drawingml/2006/main">
+            <a:srgbClr val="2730B6"/>
+          </a:solidFill>
+          <a:ln xmlns:a="http://schemas.openxmlformats.org/drawingml/2006/main" w="0">
+            <a:solidFill>
+              <a:srgbClr val="2730B6"/>
+            </a:solidFill>
+            <a:prstDash val="solid"/>
+          </a:ln>
+        </p:spPr>
+      </p:sp>
+      <p:sp>
+        <p:nvSpPr>
+          <p:cNvPr id="2" name="">
+            <a:extLst xmlns:a="http://schemas.openxmlformats.org/drawingml/2006/main">
+              <a:ext uri="{FF2B5EF4-FFF2-40B4-BE49-F238E27FC236}">
+                <a16:creationId xmlns:a16="http://schemas.microsoft.com/office/drawing/2014/main" id="{B808AC5C-A3B5-4964-B237-1D6A9BD0F02F}"/>
+              </a:ext>
+            </a:extLst>
+          </p:cNvPr>
+          <p:cNvSpPr>
+            <a:spLocks xmlns:a="http://schemas.openxmlformats.org/drawingml/2006/main" noGrp="1"/>
+          </p:cNvSpPr>
+          <p:nvPr/>
+        </p:nvSpPr>
+        <p:spPr>
+          <a:xfrm xmlns:a="http://schemas.openxmlformats.org/drawingml/2006/main">
+            <a:off x="0" y="0"/>
+            <a:ext cx="171450" cy="6858000"/>
+          </a:xfrm>
+          <a:prstGeom xmlns:a="http://schemas.openxmlformats.org/drawingml/2006/main" prst="rect">
+            <a:avLst/>
+          </a:prstGeom>
+          <a:solidFill xmlns:a="http://schemas.openxmlformats.org/drawingml/2006/main">
+            <a:srgbClr val="2730B6"/>
+          </a:solidFill>
+          <a:ln xmlns:a="http://schemas.openxmlformats.org/drawingml/2006/main" w="0">
+            <a:solidFill>
+              <a:srgbClr val="2730B6"/>
+            </a:solidFill>
+            <a:prstDash val="solid"/>
+          </a:ln>
+        </p:spPr>
+      </p:sp>
+      <p:sp>
+        <p:nvSpPr>
+          <p:cNvPr id="3" name="">
+            <a:extLst xmlns:a="http://schemas.openxmlformats.org/drawingml/2006/main">
+              <a:ext uri="{FF2B5EF4-FFF2-40B4-BE49-F238E27FC236}">
+                <a16:creationId xmlns:a16="http://schemas.microsoft.com/office/drawing/2014/main" id="{01ED0619-B2FE-4D68-B36C-4AE80C8EE08D}"/>
+              </a:ext>
+            </a:extLst>
+          </p:cNvPr>
+          <p:cNvSpPr>
+            <a:spLocks xmlns:a="http://schemas.openxmlformats.org/drawingml/2006/main" noGrp="1"/>
+          </p:cNvSpPr>
+          <p:nvPr/>
+        </p:nvSpPr>
+        <p:spPr>
+          <a:xfrm xmlns:a="http://schemas.openxmlformats.org/drawingml/2006/main">
+            <a:off x="9810750" y="400050"/>
+            <a:ext cx="1428750" cy="228600"/>
+          </a:xfrm>
+          <a:prstGeom xmlns:a="http://schemas.openxmlformats.org/drawingml/2006/main" prst="rect">
+            <a:avLst/>
+          </a:prstGeom>
+          <a:noFill xmlns:a="http://schemas.openxmlformats.org/drawingml/2006/main"/>
+          <a:ln xmlns:a="http://schemas.openxmlformats.org/drawingml/2006/main" w="0">
+            <a:noFill/>
+            <a:prstDash val="solid"/>
+          </a:ln>
+        </p:spPr>
+        <p:txBody>
+          <a:bodyPr xmlns:a="http://schemas.openxmlformats.org/drawingml/2006/main"/>
+          <a:lstStyle xmlns:a="http://schemas.openxmlformats.org/drawingml/2006/main"/>
+          <a:p xmlns:a="http://schemas.openxmlformats.org/drawingml/2006/main">
+            <a:pPr algn="l">
+              <a:defRPr sz="975" b="1">
+                <a:solidFill>
+                  <a:srgbClr val="2730B6"/>
+                </a:solidFill>
+              </a:defRPr>
+            </a:pPr>
+            <a:r>
+              <a:rPr sz="975" b="1">
+                <a:solidFill>
+                  <a:srgbClr val="2730B6"/>
+                </a:solidFill>
+              </a:rPr>
+              <a:t>НИ ТГУ · ИДО</a:t>
+            </a:r>
+          </a:p>
+        </p:txBody>
+      </p:sp>
+      <p:sp>
+        <p:nvSpPr>
+          <p:cNvPr id="4" name="">
+            <a:extLst xmlns:a="http://schemas.openxmlformats.org/drawingml/2006/main">
+              <a:ext uri="{FF2B5EF4-FFF2-40B4-BE49-F238E27FC236}">
+                <a16:creationId xmlns:a16="http://schemas.microsoft.com/office/drawing/2014/main" id="{96341C4B-381D-4B77-970C-8FFB28D67607}"/>
+              </a:ext>
+            </a:extLst>
+          </p:cNvPr>
+          <p:cNvSpPr>
+            <a:spLocks xmlns:a="http://schemas.openxmlformats.org/drawingml/2006/main" noGrp="1"/>
+          </p:cNvSpPr>
+          <p:nvPr/>
+        </p:nvSpPr>
+        <p:spPr>
+          <a:xfrm xmlns:a="http://schemas.openxmlformats.org/drawingml/2006/main">
+            <a:off x="11382375" y="400050"/>
+            <a:ext cx="361950" cy="228600"/>
+          </a:xfrm>
+          <a:prstGeom xmlns:a="http://schemas.openxmlformats.org/drawingml/2006/main" prst="rect">
+            <a:avLst/>
+          </a:prstGeom>
+          <a:noFill xmlns:a="http://schemas.openxmlformats.org/drawingml/2006/main"/>
+          <a:ln xmlns:a="http://schemas.openxmlformats.org/drawingml/2006/main" w="0">
+            <a:noFill/>
+            <a:prstDash val="solid"/>
+          </a:ln>
+        </p:spPr>
+        <p:txBody>
+          <a:bodyPr xmlns:a="http://schemas.openxmlformats.org/drawingml/2006/main"/>
+          <a:lstStyle xmlns:a="http://schemas.openxmlformats.org/drawingml/2006/main"/>
+          <a:p xmlns:a="http://schemas.openxmlformats.org/drawingml/2006/main">
+            <a:pPr algn="r">
+              <a:defRPr sz="975" b="0">
+                <a:solidFill>
+                  <a:srgbClr val="2730B6"/>
+                </a:solidFill>
+              </a:defRPr>
+            </a:pPr>
+            <a:r>
+              <a:rPr sz="975" b="0">
+                <a:solidFill>
+                  <a:srgbClr val="2730B6"/>
+                </a:solidFill>
+              </a:rPr>
+              <a:t>8</a:t>
+            </a:r>
+          </a:p>
+        </p:txBody>
+      </p:sp>
+      <p:sp>
+        <p:nvSpPr>
+          <p:cNvPr id="5" name="">
+            <a:extLst xmlns:a="http://schemas.openxmlformats.org/drawingml/2006/main">
+              <a:ext uri="{FF2B5EF4-FFF2-40B4-BE49-F238E27FC236}">
+                <a16:creationId xmlns:a16="http://schemas.microsoft.com/office/drawing/2014/main" id="{17BF6C3A-3791-45ED-A477-E9F537F1F490}"/>
               </a:ext>
             </a:extLst>
           </p:cNvPr>
@@ -6696,10 +8321,10 @@
       </p:sp>
       <p:sp>
         <p:nvSpPr>
-          <p:cNvPr id="2" name="">
-            <a:extLst xmlns:a="http://schemas.openxmlformats.org/drawingml/2006/main">
-              <a:ext uri="{FF2B5EF4-FFF2-40B4-BE49-F238E27FC236}">
-                <a16:creationId xmlns:a16="http://schemas.microsoft.com/office/drawing/2014/main" id="{018AB83D-3F6A-4687-90F1-C61C7B6CEA2A}"/>
+          <p:cNvPr id="6" name="">
+            <a:extLst xmlns:a="http://schemas.openxmlformats.org/drawingml/2006/main">
+              <a:ext uri="{FF2B5EF4-FFF2-40B4-BE49-F238E27FC236}">
+                <a16:creationId xmlns:a16="http://schemas.microsoft.com/office/drawing/2014/main" id="{BE6E60BE-C071-4941-874B-54E66559E291}"/>
               </a:ext>
             </a:extLst>
           </p:cNvPr>
@@ -6717,11 +8342,11 @@
             <a:avLst/>
           </a:prstGeom>
           <a:solidFill xmlns:a="http://schemas.openxmlformats.org/drawingml/2006/main">
-            <a:srgbClr val="0F766E"/>
+            <a:srgbClr val="36D2CF"/>
           </a:solidFill>
           <a:ln xmlns:a="http://schemas.openxmlformats.org/drawingml/2006/main" w="0">
             <a:solidFill>
-              <a:srgbClr val="0F766E"/>
+              <a:srgbClr val="36D2CF"/>
             </a:solidFill>
             <a:prstDash val="solid"/>
           </a:ln>
@@ -6729,14 +8354,14 @@
       </p:sp>
       <p:pic>
         <p:nvPicPr>
-          <p:cNvPr id="10" name=""/>
+          <p:cNvPr id="18" name=""/>
           <p:cNvPicPr>
             <a:picLocks xmlns:a="http://schemas.openxmlformats.org/drawingml/2006/main" noChangeAspect="1"/>
           </p:cNvPicPr>
           <p:nvPr/>
         </p:nvPicPr>
         <p:blipFill>
-          <a:blip xmlns:r="http://schemas.openxmlformats.org/officeDocument/2006/relationships" xmlns:a="http://schemas.openxmlformats.org/drawingml/2006/main" r:embed="Rf6c2759496364b15"/>
+          <a:blip xmlns:r="http://schemas.openxmlformats.org/officeDocument/2006/relationships" xmlns:a="http://schemas.openxmlformats.org/drawingml/2006/main" r:embed="Rcbf39d8675864ecd"/>
           <a:stretch xmlns:a="http://schemas.openxmlformats.org/drawingml/2006/main"/>
         </p:blipFill>
         <p:spPr>
@@ -6751,14 +8376,14 @@
       </p:pic>
       <p:pic>
         <p:nvPicPr>
-          <p:cNvPr id="11" name=""/>
+          <p:cNvPr id="19" name=""/>
           <p:cNvPicPr>
             <a:picLocks xmlns:a="http://schemas.openxmlformats.org/drawingml/2006/main" noChangeAspect="1"/>
           </p:cNvPicPr>
           <p:nvPr/>
         </p:nvPicPr>
         <p:blipFill>
-          <a:blip xmlns:r="http://schemas.openxmlformats.org/officeDocument/2006/relationships" xmlns:a="http://schemas.openxmlformats.org/drawingml/2006/main" r:embed="Re3f8614253a64df4"/>
+          <a:blip xmlns:r="http://schemas.openxmlformats.org/officeDocument/2006/relationships" xmlns:a="http://schemas.openxmlformats.org/drawingml/2006/main" r:embed="Rcb739ca2712e48b5"/>
           <a:stretch xmlns:a="http://schemas.openxmlformats.org/drawingml/2006/main"/>
         </p:blipFill>
         <p:spPr>
@@ -6773,10 +8398,10 @@
       </p:pic>
       <p:sp>
         <p:nvSpPr>
-          <p:cNvPr id="5" name="">
-            <a:extLst xmlns:a="http://schemas.openxmlformats.org/drawingml/2006/main">
-              <a:ext uri="{FF2B5EF4-FFF2-40B4-BE49-F238E27FC236}">
-                <a16:creationId xmlns:a16="http://schemas.microsoft.com/office/drawing/2014/main" id="{D21CCAED-8507-4B96-ACEF-5E193DAF3EB8}"/>
+          <p:cNvPr id="9" name="">
+            <a:extLst xmlns:a="http://schemas.openxmlformats.org/drawingml/2006/main">
+              <a:ext uri="{FF2B5EF4-FFF2-40B4-BE49-F238E27FC236}">
+                <a16:creationId xmlns:a16="http://schemas.microsoft.com/office/drawing/2014/main" id="{BF55902B-7025-4D2C-92BE-FE270F75B66B}"/>
               </a:ext>
             </a:extLst>
           </p:cNvPr>
@@ -6823,10 +8448,10 @@
       </p:sp>
       <p:sp>
         <p:nvSpPr>
-          <p:cNvPr id="6" name="">
-            <a:extLst xmlns:a="http://schemas.openxmlformats.org/drawingml/2006/main">
-              <a:ext uri="{FF2B5EF4-FFF2-40B4-BE49-F238E27FC236}">
-                <a16:creationId xmlns:a16="http://schemas.microsoft.com/office/drawing/2014/main" id="{E6BDE7D0-C6D6-4DD9-8F69-063B94A29180}"/>
+          <p:cNvPr id="10" name="">
+            <a:extLst xmlns:a="http://schemas.openxmlformats.org/drawingml/2006/main">
+              <a:ext uri="{FF2B5EF4-FFF2-40B4-BE49-F238E27FC236}">
+                <a16:creationId xmlns:a16="http://schemas.microsoft.com/office/drawing/2014/main" id="{50032D0D-0A15-485D-8367-243BAE5C2A7E}"/>
               </a:ext>
             </a:extLst>
           </p:cNvPr>
@@ -6856,14 +8481,14 @@
             <a:pPr algn="l">
               <a:defRPr sz="975" b="0">
                 <a:solidFill>
-                  <a:srgbClr val="64748B"/>
+                  <a:srgbClr val="2730B6"/>
                 </a:solidFill>
               </a:defRPr>
             </a:pPr>
             <a:r>
               <a:rPr sz="975" b="0">
                 <a:solidFill>
-                  <a:srgbClr val="64748B"/>
+                  <a:srgbClr val="2730B6"/>
                 </a:solidFill>
               </a:rPr>
               <a:t>ADAS ScenarioGuard · ВКР · 2026</a:t>
@@ -6873,10 +8498,10 @@
       </p:sp>
       <p:sp>
         <p:nvSpPr>
-          <p:cNvPr id="7" name="">
-            <a:extLst xmlns:a="http://schemas.openxmlformats.org/drawingml/2006/main">
-              <a:ext uri="{FF2B5EF4-FFF2-40B4-BE49-F238E27FC236}">
-                <a16:creationId xmlns:a16="http://schemas.microsoft.com/office/drawing/2014/main" id="{F75473F5-DC15-481A-9FC9-94F278050359}"/>
+          <p:cNvPr id="11" name="">
+            <a:extLst xmlns:a="http://schemas.openxmlformats.org/drawingml/2006/main">
+              <a:ext uri="{FF2B5EF4-FFF2-40B4-BE49-F238E27FC236}">
+                <a16:creationId xmlns:a16="http://schemas.microsoft.com/office/drawing/2014/main" id="{2BAF04E9-940F-4391-9FCC-5CD04CAE8282}"/>
               </a:ext>
             </a:extLst>
           </p:cNvPr>
@@ -6906,14 +8531,14 @@
             <a:pPr algn="r">
               <a:defRPr sz="975" b="0">
                 <a:solidFill>
-                  <a:srgbClr val="64748B"/>
+                  <a:srgbClr val="2730B6"/>
                 </a:solidFill>
               </a:defRPr>
             </a:pPr>
             <a:r>
               <a:rPr sz="975" b="0">
                 <a:solidFill>
-                  <a:srgbClr val="64748B"/>
+                  <a:srgbClr val="2730B6"/>
                 </a:solidFill>
               </a:rPr>
               <a:t>8</a:t>
@@ -6924,7 +8549,7 @@
     </p:spTree>
     <p:extLst>
       <p:ext uri="{BB962C8B-B14F-4D97-AF65-F5344CB8AC3E}">
-        <p14:creationId xmlns:p14="http://schemas.microsoft.com/office/powerpoint/2010/main" val="631467216"/>
+        <p14:creationId xmlns:p14="http://schemas.microsoft.com/office/powerpoint/2010/main" val="316107444"/>
       </p:ext>
     </p:extLst>
   </p:cSld>
@@ -6955,7 +8580,173 @@
           <p:cNvPr id="1" name="">
             <a:extLst xmlns:a="http://schemas.openxmlformats.org/drawingml/2006/main">
               <a:ext uri="{FF2B5EF4-FFF2-40B4-BE49-F238E27FC236}">
-                <a16:creationId xmlns:a16="http://schemas.microsoft.com/office/drawing/2014/main" id="{01941B48-206A-4C61-8089-DEFD76D47F9D}"/>
+                <a16:creationId xmlns:a16="http://schemas.microsoft.com/office/drawing/2014/main" id="{939A240A-3FF6-4795-BF30-295045EA7242}"/>
+              </a:ext>
+            </a:extLst>
+          </p:cNvPr>
+          <p:cNvSpPr>
+            <a:spLocks xmlns:a="http://schemas.openxmlformats.org/drawingml/2006/main" noGrp="1"/>
+          </p:cNvSpPr>
+          <p:nvPr/>
+        </p:nvSpPr>
+        <p:spPr>
+          <a:xfrm xmlns:a="http://schemas.openxmlformats.org/drawingml/2006/main">
+            <a:off x="0" y="0"/>
+            <a:ext cx="12192000" cy="171450"/>
+          </a:xfrm>
+          <a:prstGeom xmlns:a="http://schemas.openxmlformats.org/drawingml/2006/main" prst="rect">
+            <a:avLst/>
+          </a:prstGeom>
+          <a:solidFill xmlns:a="http://schemas.openxmlformats.org/drawingml/2006/main">
+            <a:srgbClr val="2730B6"/>
+          </a:solidFill>
+          <a:ln xmlns:a="http://schemas.openxmlformats.org/drawingml/2006/main" w="0">
+            <a:solidFill>
+              <a:srgbClr val="2730B6"/>
+            </a:solidFill>
+            <a:prstDash val="solid"/>
+          </a:ln>
+        </p:spPr>
+      </p:sp>
+      <p:sp>
+        <p:nvSpPr>
+          <p:cNvPr id="2" name="">
+            <a:extLst xmlns:a="http://schemas.openxmlformats.org/drawingml/2006/main">
+              <a:ext uri="{FF2B5EF4-FFF2-40B4-BE49-F238E27FC236}">
+                <a16:creationId xmlns:a16="http://schemas.microsoft.com/office/drawing/2014/main" id="{76036D1D-CDDE-4EB9-81D0-505813A809E2}"/>
+              </a:ext>
+            </a:extLst>
+          </p:cNvPr>
+          <p:cNvSpPr>
+            <a:spLocks xmlns:a="http://schemas.openxmlformats.org/drawingml/2006/main" noGrp="1"/>
+          </p:cNvSpPr>
+          <p:nvPr/>
+        </p:nvSpPr>
+        <p:spPr>
+          <a:xfrm xmlns:a="http://schemas.openxmlformats.org/drawingml/2006/main">
+            <a:off x="0" y="0"/>
+            <a:ext cx="171450" cy="6858000"/>
+          </a:xfrm>
+          <a:prstGeom xmlns:a="http://schemas.openxmlformats.org/drawingml/2006/main" prst="rect">
+            <a:avLst/>
+          </a:prstGeom>
+          <a:solidFill xmlns:a="http://schemas.openxmlformats.org/drawingml/2006/main">
+            <a:srgbClr val="2730B6"/>
+          </a:solidFill>
+          <a:ln xmlns:a="http://schemas.openxmlformats.org/drawingml/2006/main" w="0">
+            <a:solidFill>
+              <a:srgbClr val="2730B6"/>
+            </a:solidFill>
+            <a:prstDash val="solid"/>
+          </a:ln>
+        </p:spPr>
+      </p:sp>
+      <p:sp>
+        <p:nvSpPr>
+          <p:cNvPr id="3" name="">
+            <a:extLst xmlns:a="http://schemas.openxmlformats.org/drawingml/2006/main">
+              <a:ext uri="{FF2B5EF4-FFF2-40B4-BE49-F238E27FC236}">
+                <a16:creationId xmlns:a16="http://schemas.microsoft.com/office/drawing/2014/main" id="{7E4FC6D1-8E51-4D68-8333-AEB00A62DE18}"/>
+              </a:ext>
+            </a:extLst>
+          </p:cNvPr>
+          <p:cNvSpPr>
+            <a:spLocks xmlns:a="http://schemas.openxmlformats.org/drawingml/2006/main" noGrp="1"/>
+          </p:cNvSpPr>
+          <p:nvPr/>
+        </p:nvSpPr>
+        <p:spPr>
+          <a:xfrm xmlns:a="http://schemas.openxmlformats.org/drawingml/2006/main">
+            <a:off x="9810750" y="400050"/>
+            <a:ext cx="1428750" cy="228600"/>
+          </a:xfrm>
+          <a:prstGeom xmlns:a="http://schemas.openxmlformats.org/drawingml/2006/main" prst="rect">
+            <a:avLst/>
+          </a:prstGeom>
+          <a:noFill xmlns:a="http://schemas.openxmlformats.org/drawingml/2006/main"/>
+          <a:ln xmlns:a="http://schemas.openxmlformats.org/drawingml/2006/main" w="0">
+            <a:noFill/>
+            <a:prstDash val="solid"/>
+          </a:ln>
+        </p:spPr>
+        <p:txBody>
+          <a:bodyPr xmlns:a="http://schemas.openxmlformats.org/drawingml/2006/main"/>
+          <a:lstStyle xmlns:a="http://schemas.openxmlformats.org/drawingml/2006/main"/>
+          <a:p xmlns:a="http://schemas.openxmlformats.org/drawingml/2006/main">
+            <a:pPr algn="l">
+              <a:defRPr sz="975" b="1">
+                <a:solidFill>
+                  <a:srgbClr val="2730B6"/>
+                </a:solidFill>
+              </a:defRPr>
+            </a:pPr>
+            <a:r>
+              <a:rPr sz="975" b="1">
+                <a:solidFill>
+                  <a:srgbClr val="2730B6"/>
+                </a:solidFill>
+              </a:rPr>
+              <a:t>НИ ТГУ · ИДО</a:t>
+            </a:r>
+          </a:p>
+        </p:txBody>
+      </p:sp>
+      <p:sp>
+        <p:nvSpPr>
+          <p:cNvPr id="4" name="">
+            <a:extLst xmlns:a="http://schemas.openxmlformats.org/drawingml/2006/main">
+              <a:ext uri="{FF2B5EF4-FFF2-40B4-BE49-F238E27FC236}">
+                <a16:creationId xmlns:a16="http://schemas.microsoft.com/office/drawing/2014/main" id="{1D3E6560-78DD-4D52-8028-88E6109372F4}"/>
+              </a:ext>
+            </a:extLst>
+          </p:cNvPr>
+          <p:cNvSpPr>
+            <a:spLocks xmlns:a="http://schemas.openxmlformats.org/drawingml/2006/main" noGrp="1"/>
+          </p:cNvSpPr>
+          <p:nvPr/>
+        </p:nvSpPr>
+        <p:spPr>
+          <a:xfrm xmlns:a="http://schemas.openxmlformats.org/drawingml/2006/main">
+            <a:off x="11382375" y="400050"/>
+            <a:ext cx="361950" cy="228600"/>
+          </a:xfrm>
+          <a:prstGeom xmlns:a="http://schemas.openxmlformats.org/drawingml/2006/main" prst="rect">
+            <a:avLst/>
+          </a:prstGeom>
+          <a:noFill xmlns:a="http://schemas.openxmlformats.org/drawingml/2006/main"/>
+          <a:ln xmlns:a="http://schemas.openxmlformats.org/drawingml/2006/main" w="0">
+            <a:noFill/>
+            <a:prstDash val="solid"/>
+          </a:ln>
+        </p:spPr>
+        <p:txBody>
+          <a:bodyPr xmlns:a="http://schemas.openxmlformats.org/drawingml/2006/main"/>
+          <a:lstStyle xmlns:a="http://schemas.openxmlformats.org/drawingml/2006/main"/>
+          <a:p xmlns:a="http://schemas.openxmlformats.org/drawingml/2006/main">
+            <a:pPr algn="r">
+              <a:defRPr sz="975" b="0">
+                <a:solidFill>
+                  <a:srgbClr val="2730B6"/>
+                </a:solidFill>
+              </a:defRPr>
+            </a:pPr>
+            <a:r>
+              <a:rPr sz="975" b="0">
+                <a:solidFill>
+                  <a:srgbClr val="2730B6"/>
+                </a:solidFill>
+              </a:rPr>
+              <a:t>9</a:t>
+            </a:r>
+          </a:p>
+        </p:txBody>
+      </p:sp>
+      <p:sp>
+        <p:nvSpPr>
+          <p:cNvPr id="5" name="">
+            <a:extLst xmlns:a="http://schemas.openxmlformats.org/drawingml/2006/main">
+              <a:ext uri="{FF2B5EF4-FFF2-40B4-BE49-F238E27FC236}">
+                <a16:creationId xmlns:a16="http://schemas.microsoft.com/office/drawing/2014/main" id="{9FB2FE20-58E5-4666-91B5-0E73EFFBAFE4}"/>
               </a:ext>
             </a:extLst>
           </p:cNvPr>
@@ -6995,17 +8786,17 @@
                   <a:srgbClr val="0F172A"/>
                 </a:solidFill>
               </a:rPr>
-              <a:t>Ошибки связаны с близкими и частично видимыми объектами</a:t>
-            </a:r>
-          </a:p>
-        </p:txBody>
-      </p:sp>
-      <p:sp>
-        <p:nvSpPr>
-          <p:cNvPr id="2" name="">
-            <a:extLst xmlns:a="http://schemas.openxmlformats.org/drawingml/2006/main">
-              <a:ext uri="{FF2B5EF4-FFF2-40B4-BE49-F238E27FC236}">
-                <a16:creationId xmlns:a16="http://schemas.microsoft.com/office/drawing/2014/main" id="{4C413A70-FBC0-48A6-8CAE-22B60E523F1B}"/>
+              <a:t>Близкие и частично видимые объекты объясняют ошибки</a:t>
+            </a:r>
+          </a:p>
+        </p:txBody>
+      </p:sp>
+      <p:sp>
+        <p:nvSpPr>
+          <p:cNvPr id="6" name="">
+            <a:extLst xmlns:a="http://schemas.openxmlformats.org/drawingml/2006/main">
+              <a:ext uri="{FF2B5EF4-FFF2-40B4-BE49-F238E27FC236}">
+                <a16:creationId xmlns:a16="http://schemas.microsoft.com/office/drawing/2014/main" id="{F8CC20C9-39CF-4013-9E62-B8E12459D9AE}"/>
               </a:ext>
             </a:extLst>
           </p:cNvPr>
@@ -7023,11 +8814,11 @@
             <a:avLst/>
           </a:prstGeom>
           <a:solidFill xmlns:a="http://schemas.openxmlformats.org/drawingml/2006/main">
-            <a:srgbClr val="0F766E"/>
+            <a:srgbClr val="36D2CF"/>
           </a:solidFill>
           <a:ln xmlns:a="http://schemas.openxmlformats.org/drawingml/2006/main" w="0">
             <a:solidFill>
-              <a:srgbClr val="0F766E"/>
+              <a:srgbClr val="36D2CF"/>
             </a:solidFill>
             <a:prstDash val="solid"/>
           </a:ln>
@@ -7035,14 +8826,14 @@
       </p:sp>
       <p:pic>
         <p:nvPicPr>
-          <p:cNvPr id="15" name=""/>
+          <p:cNvPr id="23" name=""/>
           <p:cNvPicPr>
             <a:picLocks xmlns:a="http://schemas.openxmlformats.org/drawingml/2006/main" noChangeAspect="1"/>
           </p:cNvPicPr>
           <p:nvPr/>
         </p:nvPicPr>
         <p:blipFill>
-          <a:blip xmlns:r="http://schemas.openxmlformats.org/officeDocument/2006/relationships" xmlns:a="http://schemas.openxmlformats.org/drawingml/2006/main" r:embed="R64f3fca8b3164d15"/>
+          <a:blip xmlns:r="http://schemas.openxmlformats.org/officeDocument/2006/relationships" xmlns:a="http://schemas.openxmlformats.org/drawingml/2006/main" r:embed="R4901c00c377142c3"/>
           <a:stretch xmlns:a="http://schemas.openxmlformats.org/drawingml/2006/main"/>
         </p:blipFill>
         <p:spPr>
@@ -7057,14 +8848,14 @@
       </p:pic>
       <p:pic>
         <p:nvPicPr>
-          <p:cNvPr id="16" name=""/>
+          <p:cNvPr id="24" name=""/>
           <p:cNvPicPr>
             <a:picLocks xmlns:a="http://schemas.openxmlformats.org/drawingml/2006/main" noChangeAspect="1"/>
           </p:cNvPicPr>
           <p:nvPr/>
         </p:nvPicPr>
         <p:blipFill>
-          <a:blip xmlns:r="http://schemas.openxmlformats.org/officeDocument/2006/relationships" xmlns:a="http://schemas.openxmlformats.org/drawingml/2006/main" r:embed="R093ab347a7004184"/>
+          <a:blip xmlns:r="http://schemas.openxmlformats.org/officeDocument/2006/relationships" xmlns:a="http://schemas.openxmlformats.org/drawingml/2006/main" r:embed="R7757b31f1a924ea3"/>
           <a:stretch xmlns:a="http://schemas.openxmlformats.org/drawingml/2006/main"/>
         </p:blipFill>
         <p:spPr>
@@ -7079,10 +8870,10 @@
       </p:pic>
       <p:sp>
         <p:nvSpPr>
-          <p:cNvPr id="5" name="">
-            <a:extLst xmlns:a="http://schemas.openxmlformats.org/drawingml/2006/main">
-              <a:ext uri="{FF2B5EF4-FFF2-40B4-BE49-F238E27FC236}">
-                <a16:creationId xmlns:a16="http://schemas.microsoft.com/office/drawing/2014/main" id="{AB405B04-54FB-4133-B782-04F4B9B928EE}"/>
+          <p:cNvPr id="9" name="">
+            <a:extLst xmlns:a="http://schemas.openxmlformats.org/drawingml/2006/main">
+              <a:ext uri="{FF2B5EF4-FFF2-40B4-BE49-F238E27FC236}">
+                <a16:creationId xmlns:a16="http://schemas.microsoft.com/office/drawing/2014/main" id="{2216E0FF-8752-4711-AC3D-5AE7651D86BF}"/>
               </a:ext>
             </a:extLst>
           </p:cNvPr>
@@ -7112,14 +8903,14 @@
             <a:pPr algn="l">
               <a:defRPr sz="1500" b="1">
                 <a:solidFill>
-                  <a:srgbClr val="0F766E"/>
+                  <a:srgbClr val="2730B6"/>
                 </a:solidFill>
               </a:defRPr>
             </a:pPr>
             <a:r>
               <a:rPr sz="1500" b="1">
                 <a:solidFill>
-                  <a:srgbClr val="0F766E"/>
+                  <a:srgbClr val="2730B6"/>
                 </a:solidFill>
               </a:rPr>
               <a:t>•</a:t>
@@ -7129,10 +8920,10 @@
       </p:sp>
       <p:sp>
         <p:nvSpPr>
-          <p:cNvPr id="6" name="">
-            <a:extLst xmlns:a="http://schemas.openxmlformats.org/drawingml/2006/main">
-              <a:ext uri="{FF2B5EF4-FFF2-40B4-BE49-F238E27FC236}">
-                <a16:creationId xmlns:a16="http://schemas.microsoft.com/office/drawing/2014/main" id="{FEAC3F46-5183-4D7C-9F17-D978AB928DA3}"/>
+          <p:cNvPr id="10" name="">
+            <a:extLst xmlns:a="http://schemas.openxmlformats.org/drawingml/2006/main">
+              <a:ext uri="{FF2B5EF4-FFF2-40B4-BE49-F238E27FC236}">
+                <a16:creationId xmlns:a16="http://schemas.microsoft.com/office/drawing/2014/main" id="{4BA99A2A-9940-4B2F-BAB2-C16F60B7219B}"/>
               </a:ext>
             </a:extLst>
           </p:cNvPr>
@@ -7179,10 +8970,10 @@
       </p:sp>
       <p:sp>
         <p:nvSpPr>
-          <p:cNvPr id="7" name="">
-            <a:extLst xmlns:a="http://schemas.openxmlformats.org/drawingml/2006/main">
-              <a:ext uri="{FF2B5EF4-FFF2-40B4-BE49-F238E27FC236}">
-                <a16:creationId xmlns:a16="http://schemas.microsoft.com/office/drawing/2014/main" id="{47F4D1B3-34CB-4823-97AB-2788052BD30D}"/>
+          <p:cNvPr id="11" name="">
+            <a:extLst xmlns:a="http://schemas.openxmlformats.org/drawingml/2006/main">
+              <a:ext uri="{FF2B5EF4-FFF2-40B4-BE49-F238E27FC236}">
+                <a16:creationId xmlns:a16="http://schemas.microsoft.com/office/drawing/2014/main" id="{4F21FA9D-166C-4225-B328-55BD9EAE2871}"/>
               </a:ext>
             </a:extLst>
           </p:cNvPr>
@@ -7212,14 +9003,14 @@
             <a:pPr algn="l">
               <a:defRPr sz="1500" b="1">
                 <a:solidFill>
-                  <a:srgbClr val="0F766E"/>
+                  <a:srgbClr val="2730B6"/>
                 </a:solidFill>
               </a:defRPr>
             </a:pPr>
             <a:r>
               <a:rPr sz="1500" b="1">
                 <a:solidFill>
-                  <a:srgbClr val="0F766E"/>
+                  <a:srgbClr val="2730B6"/>
                 </a:solidFill>
               </a:rPr>
               <a:t>•</a:t>
@@ -7229,10 +9020,10 @@
       </p:sp>
       <p:sp>
         <p:nvSpPr>
-          <p:cNvPr id="8" name="">
-            <a:extLst xmlns:a="http://schemas.openxmlformats.org/drawingml/2006/main">
-              <a:ext uri="{FF2B5EF4-FFF2-40B4-BE49-F238E27FC236}">
-                <a16:creationId xmlns:a16="http://schemas.microsoft.com/office/drawing/2014/main" id="{EECD614B-1C50-4CB5-8B82-70F4FD3C9683}"/>
+          <p:cNvPr id="12" name="">
+            <a:extLst xmlns:a="http://schemas.openxmlformats.org/drawingml/2006/main">
+              <a:ext uri="{FF2B5EF4-FFF2-40B4-BE49-F238E27FC236}">
+                <a16:creationId xmlns:a16="http://schemas.microsoft.com/office/drawing/2014/main" id="{31CD8CFC-1119-4772-9E78-CC94CD75E767}"/>
               </a:ext>
             </a:extLst>
           </p:cNvPr>
@@ -7279,10 +9070,10 @@
       </p:sp>
       <p:sp>
         <p:nvSpPr>
-          <p:cNvPr id="9" name="">
-            <a:extLst xmlns:a="http://schemas.openxmlformats.org/drawingml/2006/main">
-              <a:ext uri="{FF2B5EF4-FFF2-40B4-BE49-F238E27FC236}">
-                <a16:creationId xmlns:a16="http://schemas.microsoft.com/office/drawing/2014/main" id="{9CACB09B-34B6-4499-B1F2-E7DB4C58D15B}"/>
+          <p:cNvPr id="13" name="">
+            <a:extLst xmlns:a="http://schemas.openxmlformats.org/drawingml/2006/main">
+              <a:ext uri="{FF2B5EF4-FFF2-40B4-BE49-F238E27FC236}">
+                <a16:creationId xmlns:a16="http://schemas.microsoft.com/office/drawing/2014/main" id="{1D8E0523-3697-4038-8C73-860C006C4374}"/>
               </a:ext>
             </a:extLst>
           </p:cNvPr>
@@ -7312,14 +9103,14 @@
             <a:pPr algn="l">
               <a:defRPr sz="1500" b="1">
                 <a:solidFill>
-                  <a:srgbClr val="0F766E"/>
+                  <a:srgbClr val="2730B6"/>
                 </a:solidFill>
               </a:defRPr>
             </a:pPr>
             <a:r>
               <a:rPr sz="1500" b="1">
                 <a:solidFill>
-                  <a:srgbClr val="0F766E"/>
+                  <a:srgbClr val="2730B6"/>
                 </a:solidFill>
               </a:rPr>
               <a:t>•</a:t>
@@ -7329,10 +9120,10 @@
       </p:sp>
       <p:sp>
         <p:nvSpPr>
-          <p:cNvPr id="10" name="">
-            <a:extLst xmlns:a="http://schemas.openxmlformats.org/drawingml/2006/main">
-              <a:ext uri="{FF2B5EF4-FFF2-40B4-BE49-F238E27FC236}">
-                <a16:creationId xmlns:a16="http://schemas.microsoft.com/office/drawing/2014/main" id="{9F1F786C-27B2-4A6D-B7DD-46DA2F8CD2BD}"/>
+          <p:cNvPr id="14" name="">
+            <a:extLst xmlns:a="http://schemas.openxmlformats.org/drawingml/2006/main">
+              <a:ext uri="{FF2B5EF4-FFF2-40B4-BE49-F238E27FC236}">
+                <a16:creationId xmlns:a16="http://schemas.microsoft.com/office/drawing/2014/main" id="{067DB48D-37F7-42F9-B292-4F2194022AC4}"/>
               </a:ext>
             </a:extLst>
           </p:cNvPr>
@@ -7379,10 +9170,10 @@
       </p:sp>
       <p:sp>
         <p:nvSpPr>
-          <p:cNvPr id="11" name="">
-            <a:extLst xmlns:a="http://schemas.openxmlformats.org/drawingml/2006/main">
-              <a:ext uri="{FF2B5EF4-FFF2-40B4-BE49-F238E27FC236}">
-                <a16:creationId xmlns:a16="http://schemas.microsoft.com/office/drawing/2014/main" id="{06A7AF78-31CF-4F6D-9027-E3BA2599685A}"/>
+          <p:cNvPr id="15" name="">
+            <a:extLst xmlns:a="http://schemas.openxmlformats.org/drawingml/2006/main">
+              <a:ext uri="{FF2B5EF4-FFF2-40B4-BE49-F238E27FC236}">
+                <a16:creationId xmlns:a16="http://schemas.microsoft.com/office/drawing/2014/main" id="{F949990A-A45C-4463-991E-9A71D4612F67}"/>
               </a:ext>
             </a:extLst>
           </p:cNvPr>
@@ -7412,14 +9203,14 @@
             <a:pPr algn="l">
               <a:defRPr sz="975" b="0">
                 <a:solidFill>
-                  <a:srgbClr val="64748B"/>
+                  <a:srgbClr val="2730B6"/>
                 </a:solidFill>
               </a:defRPr>
             </a:pPr>
             <a:r>
               <a:rPr sz="975" b="0">
                 <a:solidFill>
-                  <a:srgbClr val="64748B"/>
+                  <a:srgbClr val="2730B6"/>
                 </a:solidFill>
               </a:rPr>
               <a:t>ADAS ScenarioGuard · ВКР · 2026</a:t>
@@ -7429,10 +9220,10 @@
       </p:sp>
       <p:sp>
         <p:nvSpPr>
-          <p:cNvPr id="12" name="">
-            <a:extLst xmlns:a="http://schemas.openxmlformats.org/drawingml/2006/main">
-              <a:ext uri="{FF2B5EF4-FFF2-40B4-BE49-F238E27FC236}">
-                <a16:creationId xmlns:a16="http://schemas.microsoft.com/office/drawing/2014/main" id="{88A99722-4407-419B-B24F-EA54D583658F}"/>
+          <p:cNvPr id="16" name="">
+            <a:extLst xmlns:a="http://schemas.openxmlformats.org/drawingml/2006/main">
+              <a:ext uri="{FF2B5EF4-FFF2-40B4-BE49-F238E27FC236}">
+                <a16:creationId xmlns:a16="http://schemas.microsoft.com/office/drawing/2014/main" id="{19B55B2C-CA50-4F5A-9E3C-027D205324B1}"/>
               </a:ext>
             </a:extLst>
           </p:cNvPr>
@@ -7462,14 +9253,14 @@
             <a:pPr algn="r">
               <a:defRPr sz="975" b="0">
                 <a:solidFill>
-                  <a:srgbClr val="64748B"/>
+                  <a:srgbClr val="2730B6"/>
                 </a:solidFill>
               </a:defRPr>
             </a:pPr>
             <a:r>
               <a:rPr sz="975" b="0">
                 <a:solidFill>
-                  <a:srgbClr val="64748B"/>
+                  <a:srgbClr val="2730B6"/>
                 </a:solidFill>
               </a:rPr>
               <a:t>9</a:t>
@@ -7480,7 +9271,7 @@
     </p:spTree>
     <p:extLst>
       <p:ext uri="{BB962C8B-B14F-4D97-AF65-F5344CB8AC3E}">
-        <p14:creationId xmlns:p14="http://schemas.microsoft.com/office/powerpoint/2010/main" val="1127592128"/>
+        <p14:creationId xmlns:p14="http://schemas.microsoft.com/office/powerpoint/2010/main" val="1222529628"/>
       </p:ext>
     </p:extLst>
   </p:cSld>

</xml_diff>

<commit_message>
Polish VKR wording and diagrams
</commit_message>
<xml_diff>
--- a/Marianovskiy_VKR_ADAS_defense_final.pptx
+++ b/Marianovskiy_VKR_ADAS_defense_final.pptx
@@ -2,22 +2,22 @@
 <file path=ppt/presentation.xml><?xml version="1.0" encoding="utf-8"?>
 <p:presentation xmlns:p="http://schemas.openxmlformats.org/presentationml/2006/main">
   <p:sldMasterIdLst>
-    <p:sldMasterId xmlns:r="http://schemas.openxmlformats.org/officeDocument/2006/relationships" id="2147483648" r:id="R5ce15b082f554ba6"/>
+    <p:sldMasterId xmlns:r="http://schemas.openxmlformats.org/officeDocument/2006/relationships" id="2147483648" r:id="R8a794627bb424862"/>
   </p:sldMasterIdLst>
   <p:notesMasterIdLst>
-    <p:notesMasterId xmlns:r="http://schemas.openxmlformats.org/officeDocument/2006/relationships" r:id="Rba44ad804a464a82"/>
+    <p:notesMasterId xmlns:r="http://schemas.openxmlformats.org/officeDocument/2006/relationships" r:id="R1339183959c646af"/>
   </p:notesMasterIdLst>
   <p:sldIdLst>
-    <p:sldId xmlns:r="http://schemas.openxmlformats.org/officeDocument/2006/relationships" id="256" r:id="R12c88dfb7c244048"/>
-    <p:sldId xmlns:r="http://schemas.openxmlformats.org/officeDocument/2006/relationships" id="257" r:id="Rb535552363c84cca"/>
-    <p:sldId xmlns:r="http://schemas.openxmlformats.org/officeDocument/2006/relationships" id="258" r:id="R94ef14c306494179"/>
-    <p:sldId xmlns:r="http://schemas.openxmlformats.org/officeDocument/2006/relationships" id="259" r:id="R31410e0acbda4713"/>
-    <p:sldId xmlns:r="http://schemas.openxmlformats.org/officeDocument/2006/relationships" id="260" r:id="R7d98882c708f4333"/>
-    <p:sldId xmlns:r="http://schemas.openxmlformats.org/officeDocument/2006/relationships" id="261" r:id="R302b4576b99a4b8e"/>
-    <p:sldId xmlns:r="http://schemas.openxmlformats.org/officeDocument/2006/relationships" id="262" r:id="R9e2dc50453064a8f"/>
-    <p:sldId xmlns:r="http://schemas.openxmlformats.org/officeDocument/2006/relationships" id="263" r:id="R8fc0390dc80a48d3"/>
-    <p:sldId xmlns:r="http://schemas.openxmlformats.org/officeDocument/2006/relationships" id="264" r:id="R3badb57250004d8b"/>
-    <p:sldId xmlns:r="http://schemas.openxmlformats.org/officeDocument/2006/relationships" id="265" r:id="Rb4d069bff68c4c1e"/>
+    <p:sldId xmlns:r="http://schemas.openxmlformats.org/officeDocument/2006/relationships" id="256" r:id="R7eab4a9c6e3240ad"/>
+    <p:sldId xmlns:r="http://schemas.openxmlformats.org/officeDocument/2006/relationships" id="257" r:id="R765bd6eb99dd4b1b"/>
+    <p:sldId xmlns:r="http://schemas.openxmlformats.org/officeDocument/2006/relationships" id="258" r:id="Re80a04e912154b84"/>
+    <p:sldId xmlns:r="http://schemas.openxmlformats.org/officeDocument/2006/relationships" id="259" r:id="R0d78c8e9ff2b486d"/>
+    <p:sldId xmlns:r="http://schemas.openxmlformats.org/officeDocument/2006/relationships" id="260" r:id="R4c5dd6dab6f24f0b"/>
+    <p:sldId xmlns:r="http://schemas.openxmlformats.org/officeDocument/2006/relationships" id="261" r:id="Rc0e22f4a7ae9421c"/>
+    <p:sldId xmlns:r="http://schemas.openxmlformats.org/officeDocument/2006/relationships" id="262" r:id="Rdaf41d6cc11a41b7"/>
+    <p:sldId xmlns:r="http://schemas.openxmlformats.org/officeDocument/2006/relationships" id="263" r:id="R0c24acaacf0d4fb1"/>
+    <p:sldId xmlns:r="http://schemas.openxmlformats.org/officeDocument/2006/relationships" id="264" r:id="R2cce137da98c468c"/>
+    <p:sldId xmlns:r="http://schemas.openxmlformats.org/officeDocument/2006/relationships" id="265" r:id="R92c2bf8d7b8b497d"/>
   </p:sldIdLst>
   <p:sldSz cx="12192000" cy="6858000"/>
   <p:notesSz cx="6858000" cy="9144000"/>
@@ -1294,7 +1294,7 @@
   </p:cSld>
   <p:clrMap bg1="lt1" tx1="dk1" bg2="lt2" tx2="dk2" accent1="accent1" accent2="accent2" accent3="accent3" accent4="accent4" accent5="accent5" accent6="accent6" hlink="hlink" folHlink="folHlink"/>
   <p:sldLayoutIdLst>
-    <p:sldLayoutId xmlns:r="http://schemas.openxmlformats.org/officeDocument/2006/relationships" id="2147483649" r:id="R787a97ca6591413f"/>
+    <p:sldLayoutId xmlns:r="http://schemas.openxmlformats.org/officeDocument/2006/relationships" id="2147483649" r:id="R87c5323c3c82476f"/>
   </p:sldLayoutIdLst>
   <p:txStyles>
     <p:titleStyle>
@@ -1845,7 +1845,7 @@
           <p:cNvPr id="1" name="">
             <a:extLst xmlns:a="http://schemas.openxmlformats.org/drawingml/2006/main">
               <a:ext uri="{FF2B5EF4-FFF2-40B4-BE49-F238E27FC236}">
-                <a16:creationId xmlns:a16="http://schemas.microsoft.com/office/drawing/2014/main" id="{A7453B2F-F8D4-451A-9211-7E74F18818AC}"/>
+                <a16:creationId xmlns:a16="http://schemas.microsoft.com/office/drawing/2014/main" id="{6DBD24F9-8728-47B5-B3DC-07888F0D7D6B}"/>
               </a:ext>
             </a:extLst>
           </p:cNvPr>
@@ -1880,7 +1880,7 @@
           <p:cNvPr id="2" name="">
             <a:extLst xmlns:a="http://schemas.openxmlformats.org/drawingml/2006/main">
               <a:ext uri="{FF2B5EF4-FFF2-40B4-BE49-F238E27FC236}">
-                <a16:creationId xmlns:a16="http://schemas.microsoft.com/office/drawing/2014/main" id="{4635F429-FD5C-41D6-89C1-78DBE7A38C9D}"/>
+                <a16:creationId xmlns:a16="http://schemas.microsoft.com/office/drawing/2014/main" id="{B7BA7851-4101-48B7-AC78-7FA89F2F0351}"/>
               </a:ext>
             </a:extLst>
           </p:cNvPr>
@@ -1915,7 +1915,7 @@
           <p:cNvPr id="3" name="">
             <a:extLst xmlns:a="http://schemas.openxmlformats.org/drawingml/2006/main">
               <a:ext uri="{FF2B5EF4-FFF2-40B4-BE49-F238E27FC236}">
-                <a16:creationId xmlns:a16="http://schemas.microsoft.com/office/drawing/2014/main" id="{28F4DD55-DE70-4542-B4B2-CCCD4BDDD708}"/>
+                <a16:creationId xmlns:a16="http://schemas.microsoft.com/office/drawing/2014/main" id="{862CA637-BF63-48FC-959E-A4A3BA0F9B5E}"/>
               </a:ext>
             </a:extLst>
           </p:cNvPr>
@@ -1950,7 +1950,7 @@
           <p:cNvPr id="4" name="">
             <a:extLst xmlns:a="http://schemas.openxmlformats.org/drawingml/2006/main">
               <a:ext uri="{FF2B5EF4-FFF2-40B4-BE49-F238E27FC236}">
-                <a16:creationId xmlns:a16="http://schemas.microsoft.com/office/drawing/2014/main" id="{FD47C648-6867-4A8F-AFFE-944C69717047}"/>
+                <a16:creationId xmlns:a16="http://schemas.microsoft.com/office/drawing/2014/main" id="{48839BC0-6654-410D-BA7C-1592B782899D}"/>
               </a:ext>
             </a:extLst>
           </p:cNvPr>
@@ -2004,7 +2004,7 @@
           <p:cNvPr id="5" name="">
             <a:extLst xmlns:a="http://schemas.openxmlformats.org/drawingml/2006/main">
               <a:ext uri="{FF2B5EF4-FFF2-40B4-BE49-F238E27FC236}">
-                <a16:creationId xmlns:a16="http://schemas.microsoft.com/office/drawing/2014/main" id="{67FECDAA-1C0A-4427-95A7-73C48D45BF26}"/>
+                <a16:creationId xmlns:a16="http://schemas.microsoft.com/office/drawing/2014/main" id="{630567B1-F170-451C-B2BD-92D0D7675FC3}"/>
               </a:ext>
             </a:extLst>
           </p:cNvPr>
@@ -2088,7 +2088,7 @@
           <p:cNvPr id="6" name="">
             <a:extLst xmlns:a="http://schemas.openxmlformats.org/drawingml/2006/main">
               <a:ext uri="{FF2B5EF4-FFF2-40B4-BE49-F238E27FC236}">
-                <a16:creationId xmlns:a16="http://schemas.microsoft.com/office/drawing/2014/main" id="{87122F36-CEF4-4313-AC72-161C4AF9468B}"/>
+                <a16:creationId xmlns:a16="http://schemas.microsoft.com/office/drawing/2014/main" id="{FAB2AD95-5AA5-442C-8074-32DC8F5A49CE}"/>
               </a:ext>
             </a:extLst>
           </p:cNvPr>
@@ -2142,7 +2142,7 @@
           <p:cNvPr id="7" name="">
             <a:extLst xmlns:a="http://schemas.openxmlformats.org/drawingml/2006/main">
               <a:ext uri="{FF2B5EF4-FFF2-40B4-BE49-F238E27FC236}">
-                <a16:creationId xmlns:a16="http://schemas.microsoft.com/office/drawing/2014/main" id="{1900ADA4-847A-4E3F-BA7F-1274221C17C7}"/>
+                <a16:creationId xmlns:a16="http://schemas.microsoft.com/office/drawing/2014/main" id="{D22EC012-4637-47C0-9BD2-0D4B620E8319}"/>
               </a:ext>
             </a:extLst>
           </p:cNvPr>
@@ -2192,7 +2192,7 @@
           <p:cNvPr id="8" name="">
             <a:extLst xmlns:a="http://schemas.openxmlformats.org/drawingml/2006/main">
               <a:ext uri="{FF2B5EF4-FFF2-40B4-BE49-F238E27FC236}">
-                <a16:creationId xmlns:a16="http://schemas.microsoft.com/office/drawing/2014/main" id="{318C67D6-680A-417A-932D-B710C233C0EB}"/>
+                <a16:creationId xmlns:a16="http://schemas.microsoft.com/office/drawing/2014/main" id="{E5E38A9D-D9E5-48B2-B2FD-F1E81DD1B477}"/>
               </a:ext>
             </a:extLst>
           </p:cNvPr>
@@ -2242,7 +2242,7 @@
           <p:cNvPr id="9" name="">
             <a:extLst xmlns:a="http://schemas.openxmlformats.org/drawingml/2006/main">
               <a:ext uri="{FF2B5EF4-FFF2-40B4-BE49-F238E27FC236}">
-                <a16:creationId xmlns:a16="http://schemas.microsoft.com/office/drawing/2014/main" id="{515347BA-195B-4E6C-986F-8EAC050FCB6C}"/>
+                <a16:creationId xmlns:a16="http://schemas.microsoft.com/office/drawing/2014/main" id="{B3AF7D46-4A1D-431C-B682-70395597F003}"/>
               </a:ext>
             </a:extLst>
           </p:cNvPr>
@@ -2332,7 +2332,7 @@
           <p:cNvPr id="10" name="">
             <a:extLst xmlns:a="http://schemas.openxmlformats.org/drawingml/2006/main">
               <a:ext uri="{FF2B5EF4-FFF2-40B4-BE49-F238E27FC236}">
-                <a16:creationId xmlns:a16="http://schemas.microsoft.com/office/drawing/2014/main" id="{3944F75F-1F6A-4A0C-8EC7-E933D2399DF5}"/>
+                <a16:creationId xmlns:a16="http://schemas.microsoft.com/office/drawing/2014/main" id="{6D570BF5-3F78-460E-808A-62955ECCCF2E}"/>
               </a:ext>
             </a:extLst>
           </p:cNvPr>
@@ -2422,7 +2422,7 @@
           <p:cNvPr id="11" name="">
             <a:extLst xmlns:a="http://schemas.openxmlformats.org/drawingml/2006/main">
               <a:ext uri="{FF2B5EF4-FFF2-40B4-BE49-F238E27FC236}">
-                <a16:creationId xmlns:a16="http://schemas.microsoft.com/office/drawing/2014/main" id="{71618E0E-8BEC-4B1A-9129-E8E47299D72A}"/>
+                <a16:creationId xmlns:a16="http://schemas.microsoft.com/office/drawing/2014/main" id="{91A06AEB-EDD1-4F61-9894-37F4FC0B1520}"/>
               </a:ext>
             </a:extLst>
           </p:cNvPr>
@@ -2472,7 +2472,7 @@
           <p:cNvPr id="12" name="">
             <a:extLst xmlns:a="http://schemas.openxmlformats.org/drawingml/2006/main">
               <a:ext uri="{FF2B5EF4-FFF2-40B4-BE49-F238E27FC236}">
-                <a16:creationId xmlns:a16="http://schemas.microsoft.com/office/drawing/2014/main" id="{CEE325CD-61BD-4372-AED0-4DA29B0B60A2}"/>
+                <a16:creationId xmlns:a16="http://schemas.microsoft.com/office/drawing/2014/main" id="{5B755220-0970-4F31-B1DA-99915B316DD2}"/>
               </a:ext>
             </a:extLst>
           </p:cNvPr>
@@ -2520,7 +2520,7 @@
     </p:spTree>
     <p:extLst>
       <p:ext uri="{BB962C8B-B14F-4D97-AF65-F5344CB8AC3E}">
-        <p14:creationId xmlns:p14="http://schemas.microsoft.com/office/powerpoint/2010/main" val="1288575013"/>
+        <p14:creationId xmlns:p14="http://schemas.microsoft.com/office/powerpoint/2010/main" val="863518060"/>
       </p:ext>
     </p:extLst>
   </p:cSld>
@@ -2551,7 +2551,7 @@
           <p:cNvPr id="1" name="">
             <a:extLst xmlns:a="http://schemas.openxmlformats.org/drawingml/2006/main">
               <a:ext uri="{FF2B5EF4-FFF2-40B4-BE49-F238E27FC236}">
-                <a16:creationId xmlns:a16="http://schemas.microsoft.com/office/drawing/2014/main" id="{F5E9667A-A205-40CB-9CC9-C4225C4D9248}"/>
+                <a16:creationId xmlns:a16="http://schemas.microsoft.com/office/drawing/2014/main" id="{1B2D2B12-8FF5-4C35-8C31-B9F5B220D64C}"/>
               </a:ext>
             </a:extLst>
           </p:cNvPr>
@@ -2584,7 +2584,7 @@
           <p:cNvPr id="2" name="">
             <a:extLst xmlns:a="http://schemas.openxmlformats.org/drawingml/2006/main">
               <a:ext uri="{FF2B5EF4-FFF2-40B4-BE49-F238E27FC236}">
-                <a16:creationId xmlns:a16="http://schemas.microsoft.com/office/drawing/2014/main" id="{B7E13FE2-4C75-45A5-BF44-4CA2B47666F8}"/>
+                <a16:creationId xmlns:a16="http://schemas.microsoft.com/office/drawing/2014/main" id="{4D7D16BF-9F5E-4C5B-AC55-A8F09C1B84BB}"/>
               </a:ext>
             </a:extLst>
           </p:cNvPr>
@@ -2617,7 +2617,7 @@
           <p:cNvPr id="3" name="">
             <a:extLst xmlns:a="http://schemas.openxmlformats.org/drawingml/2006/main">
               <a:ext uri="{FF2B5EF4-FFF2-40B4-BE49-F238E27FC236}">
-                <a16:creationId xmlns:a16="http://schemas.microsoft.com/office/drawing/2014/main" id="{5970A187-50D4-4494-918C-0E0490C837FB}"/>
+                <a16:creationId xmlns:a16="http://schemas.microsoft.com/office/drawing/2014/main" id="{97FB26BF-3EFA-48F1-B395-AC4DC606F641}"/>
               </a:ext>
             </a:extLst>
           </p:cNvPr>
@@ -2667,7 +2667,7 @@
           <p:cNvPr id="4" name="">
             <a:extLst xmlns:a="http://schemas.openxmlformats.org/drawingml/2006/main">
               <a:ext uri="{FF2B5EF4-FFF2-40B4-BE49-F238E27FC236}">
-                <a16:creationId xmlns:a16="http://schemas.microsoft.com/office/drawing/2014/main" id="{A4FEF7D7-5008-464B-BF5E-B31D4930F317}"/>
+                <a16:creationId xmlns:a16="http://schemas.microsoft.com/office/drawing/2014/main" id="{86406D1F-B481-464F-8743-B00B5C2F5BDF}"/>
               </a:ext>
             </a:extLst>
           </p:cNvPr>
@@ -2717,7 +2717,7 @@
           <p:cNvPr id="5" name="">
             <a:extLst xmlns:a="http://schemas.openxmlformats.org/drawingml/2006/main">
               <a:ext uri="{FF2B5EF4-FFF2-40B4-BE49-F238E27FC236}">
-                <a16:creationId xmlns:a16="http://schemas.microsoft.com/office/drawing/2014/main" id="{04516874-257D-41DD-999C-70E07749FB06}"/>
+                <a16:creationId xmlns:a16="http://schemas.microsoft.com/office/drawing/2014/main" id="{19DC939D-2122-47FD-9814-F43659034A22}"/>
               </a:ext>
             </a:extLst>
           </p:cNvPr>
@@ -2767,7 +2767,7 @@
           <p:cNvPr id="6" name="">
             <a:extLst xmlns:a="http://schemas.openxmlformats.org/drawingml/2006/main">
               <a:ext uri="{FF2B5EF4-FFF2-40B4-BE49-F238E27FC236}">
-                <a16:creationId xmlns:a16="http://schemas.microsoft.com/office/drawing/2014/main" id="{E465EF18-FC41-4686-BE73-90A7BA5AFEE0}"/>
+                <a16:creationId xmlns:a16="http://schemas.microsoft.com/office/drawing/2014/main" id="{488052EE-AB94-4C9D-8143-9081CEFABB8C}"/>
               </a:ext>
             </a:extLst>
           </p:cNvPr>
@@ -2800,7 +2800,7 @@
           <p:cNvPr id="7" name="">
             <a:extLst xmlns:a="http://schemas.openxmlformats.org/drawingml/2006/main">
               <a:ext uri="{FF2B5EF4-FFF2-40B4-BE49-F238E27FC236}">
-                <a16:creationId xmlns:a16="http://schemas.microsoft.com/office/drawing/2014/main" id="{424A5367-BBC6-4473-A74F-6692BDA74F0C}"/>
+                <a16:creationId xmlns:a16="http://schemas.microsoft.com/office/drawing/2014/main" id="{A5AF3968-4619-4333-89AB-E2C8A0C7FD7B}"/>
               </a:ext>
             </a:extLst>
           </p:cNvPr>
@@ -2873,7 +2873,7 @@
           <p:cNvPr id="8" name="">
             <a:extLst xmlns:a="http://schemas.openxmlformats.org/drawingml/2006/main">
               <a:ext uri="{FF2B5EF4-FFF2-40B4-BE49-F238E27FC236}">
-                <a16:creationId xmlns:a16="http://schemas.microsoft.com/office/drawing/2014/main" id="{F909C4E5-8F06-4E41-91BC-73FEC82C3686}"/>
+                <a16:creationId xmlns:a16="http://schemas.microsoft.com/office/drawing/2014/main" id="{73BFE756-B1E5-437A-B0F5-DC442D1DE12C}"/>
               </a:ext>
             </a:extLst>
           </p:cNvPr>
@@ -2946,7 +2946,7 @@
           <p:cNvPr id="9" name="">
             <a:extLst xmlns:a="http://schemas.openxmlformats.org/drawingml/2006/main">
               <a:ext uri="{FF2B5EF4-FFF2-40B4-BE49-F238E27FC236}">
-                <a16:creationId xmlns:a16="http://schemas.microsoft.com/office/drawing/2014/main" id="{63D8CA0B-FA5D-4CF0-868F-1FDC7EC6A57F}"/>
+                <a16:creationId xmlns:a16="http://schemas.microsoft.com/office/drawing/2014/main" id="{DEA6BFA1-C28A-4599-8738-FA1DF1D20850}"/>
               </a:ext>
             </a:extLst>
           </p:cNvPr>
@@ -3019,7 +3019,7 @@
           <p:cNvPr id="10" name="">
             <a:extLst xmlns:a="http://schemas.openxmlformats.org/drawingml/2006/main">
               <a:ext uri="{FF2B5EF4-FFF2-40B4-BE49-F238E27FC236}">
-                <a16:creationId xmlns:a16="http://schemas.microsoft.com/office/drawing/2014/main" id="{94F37D9E-68C8-42CB-BCB4-152E74977093}"/>
+                <a16:creationId xmlns:a16="http://schemas.microsoft.com/office/drawing/2014/main" id="{A99EB50D-F326-4DAB-8E21-91AC39A5F7B2}"/>
               </a:ext>
             </a:extLst>
           </p:cNvPr>
@@ -3069,7 +3069,7 @@
           <p:cNvPr id="11" name="">
             <a:extLst xmlns:a="http://schemas.openxmlformats.org/drawingml/2006/main">
               <a:ext uri="{FF2B5EF4-FFF2-40B4-BE49-F238E27FC236}">
-                <a16:creationId xmlns:a16="http://schemas.microsoft.com/office/drawing/2014/main" id="{0F6F5D41-ED1A-481D-94F4-27B5A4B009EC}"/>
+                <a16:creationId xmlns:a16="http://schemas.microsoft.com/office/drawing/2014/main" id="{81DA0E85-4708-429D-A702-8600998073DA}"/>
               </a:ext>
             </a:extLst>
           </p:cNvPr>
@@ -3119,7 +3119,7 @@
           <p:cNvPr id="12" name="">
             <a:extLst xmlns:a="http://schemas.openxmlformats.org/drawingml/2006/main">
               <a:ext uri="{FF2B5EF4-FFF2-40B4-BE49-F238E27FC236}">
-                <a16:creationId xmlns:a16="http://schemas.microsoft.com/office/drawing/2014/main" id="{9041C964-D03D-4193-857C-55519C1EB76D}"/>
+                <a16:creationId xmlns:a16="http://schemas.microsoft.com/office/drawing/2014/main" id="{67A3C6F4-0291-48CF-882E-703B542EF29F}"/>
               </a:ext>
             </a:extLst>
           </p:cNvPr>
@@ -3169,7 +3169,7 @@
           <p:cNvPr id="13" name="">
             <a:extLst xmlns:a="http://schemas.openxmlformats.org/drawingml/2006/main">
               <a:ext uri="{FF2B5EF4-FFF2-40B4-BE49-F238E27FC236}">
-                <a16:creationId xmlns:a16="http://schemas.microsoft.com/office/drawing/2014/main" id="{8283AB71-F071-4926-BD50-54D1EC518957}"/>
+                <a16:creationId xmlns:a16="http://schemas.microsoft.com/office/drawing/2014/main" id="{CD601550-104B-4779-BD21-5BCCEFCA8FBE}"/>
               </a:ext>
             </a:extLst>
           </p:cNvPr>
@@ -3219,7 +3219,7 @@
           <p:cNvPr id="14" name="">
             <a:extLst xmlns:a="http://schemas.openxmlformats.org/drawingml/2006/main">
               <a:ext uri="{FF2B5EF4-FFF2-40B4-BE49-F238E27FC236}">
-                <a16:creationId xmlns:a16="http://schemas.microsoft.com/office/drawing/2014/main" id="{46C27831-BF07-4862-BCCC-0E75584E111D}"/>
+                <a16:creationId xmlns:a16="http://schemas.microsoft.com/office/drawing/2014/main" id="{137E69C5-44BE-4379-9C4A-017DFA4BA5AE}"/>
               </a:ext>
             </a:extLst>
           </p:cNvPr>
@@ -3269,7 +3269,7 @@
           <p:cNvPr id="15" name="">
             <a:extLst xmlns:a="http://schemas.openxmlformats.org/drawingml/2006/main">
               <a:ext uri="{FF2B5EF4-FFF2-40B4-BE49-F238E27FC236}">
-                <a16:creationId xmlns:a16="http://schemas.microsoft.com/office/drawing/2014/main" id="{45AEDB4E-C7FC-4FAA-89DE-D726BE1C4D30}"/>
+                <a16:creationId xmlns:a16="http://schemas.microsoft.com/office/drawing/2014/main" id="{1BE832D3-BA1D-4384-9FFE-9D5646AE0E51}"/>
               </a:ext>
             </a:extLst>
           </p:cNvPr>
@@ -3319,7 +3319,7 @@
           <p:cNvPr id="16" name="">
             <a:extLst xmlns:a="http://schemas.openxmlformats.org/drawingml/2006/main">
               <a:ext uri="{FF2B5EF4-FFF2-40B4-BE49-F238E27FC236}">
-                <a16:creationId xmlns:a16="http://schemas.microsoft.com/office/drawing/2014/main" id="{837ED683-E4C0-47B0-B46E-6A869035D1BC}"/>
+                <a16:creationId xmlns:a16="http://schemas.microsoft.com/office/drawing/2014/main" id="{790C0721-AC91-453F-8798-D9939BB944D6}"/>
               </a:ext>
             </a:extLst>
           </p:cNvPr>
@@ -3369,7 +3369,7 @@
           <p:cNvPr id="17" name="">
             <a:extLst xmlns:a="http://schemas.openxmlformats.org/drawingml/2006/main">
               <a:ext uri="{FF2B5EF4-FFF2-40B4-BE49-F238E27FC236}">
-                <a16:creationId xmlns:a16="http://schemas.microsoft.com/office/drawing/2014/main" id="{6D7B680D-33A7-4B19-BA02-43AF9628439A}"/>
+                <a16:creationId xmlns:a16="http://schemas.microsoft.com/office/drawing/2014/main" id="{92994CE0-38AF-451B-9B53-B3FB463B480E}"/>
               </a:ext>
             </a:extLst>
           </p:cNvPr>
@@ -3417,7 +3417,7 @@
     </p:spTree>
     <p:extLst>
       <p:ext uri="{BB962C8B-B14F-4D97-AF65-F5344CB8AC3E}">
-        <p14:creationId xmlns:p14="http://schemas.microsoft.com/office/powerpoint/2010/main" val="1150759484"/>
+        <p14:creationId xmlns:p14="http://schemas.microsoft.com/office/powerpoint/2010/main" val="691753455"/>
       </p:ext>
     </p:extLst>
   </p:cSld>
@@ -3448,7 +3448,7 @@
           <p:cNvPr id="1" name="">
             <a:extLst xmlns:a="http://schemas.openxmlformats.org/drawingml/2006/main">
               <a:ext uri="{FF2B5EF4-FFF2-40B4-BE49-F238E27FC236}">
-                <a16:creationId xmlns:a16="http://schemas.microsoft.com/office/drawing/2014/main" id="{1C1A2BFA-3A7F-4820-A81B-CAAB90D5ACE4}"/>
+                <a16:creationId xmlns:a16="http://schemas.microsoft.com/office/drawing/2014/main" id="{5A1BC1B3-3BFF-4277-8211-B93A52340767}"/>
               </a:ext>
             </a:extLst>
           </p:cNvPr>
@@ -3481,7 +3481,7 @@
           <p:cNvPr id="2" name="">
             <a:extLst xmlns:a="http://schemas.openxmlformats.org/drawingml/2006/main">
               <a:ext uri="{FF2B5EF4-FFF2-40B4-BE49-F238E27FC236}">
-                <a16:creationId xmlns:a16="http://schemas.microsoft.com/office/drawing/2014/main" id="{42483C4C-E6C0-4CF6-9507-586D6AC5791C}"/>
+                <a16:creationId xmlns:a16="http://schemas.microsoft.com/office/drawing/2014/main" id="{62B35F67-D4E7-4E36-B685-D59980CAE966}"/>
               </a:ext>
             </a:extLst>
           </p:cNvPr>
@@ -3514,7 +3514,7 @@
           <p:cNvPr id="3" name="">
             <a:extLst xmlns:a="http://schemas.openxmlformats.org/drawingml/2006/main">
               <a:ext uri="{FF2B5EF4-FFF2-40B4-BE49-F238E27FC236}">
-                <a16:creationId xmlns:a16="http://schemas.microsoft.com/office/drawing/2014/main" id="{9C7FE624-AEA5-4C1F-8B6E-4BB3AD571CE0}"/>
+                <a16:creationId xmlns:a16="http://schemas.microsoft.com/office/drawing/2014/main" id="{DAA511EE-72DB-4359-AD23-C1379D21726F}"/>
               </a:ext>
             </a:extLst>
           </p:cNvPr>
@@ -3564,7 +3564,7 @@
           <p:cNvPr id="4" name="">
             <a:extLst xmlns:a="http://schemas.openxmlformats.org/drawingml/2006/main">
               <a:ext uri="{FF2B5EF4-FFF2-40B4-BE49-F238E27FC236}">
-                <a16:creationId xmlns:a16="http://schemas.microsoft.com/office/drawing/2014/main" id="{F7407F5D-106B-4E1E-A3DC-5085B5B20707}"/>
+                <a16:creationId xmlns:a16="http://schemas.microsoft.com/office/drawing/2014/main" id="{FD5FCCE5-117D-48B8-8C85-9A927408DF2C}"/>
               </a:ext>
             </a:extLst>
           </p:cNvPr>
@@ -3614,7 +3614,7 @@
           <p:cNvPr id="5" name="">
             <a:extLst xmlns:a="http://schemas.openxmlformats.org/drawingml/2006/main">
               <a:ext uri="{FF2B5EF4-FFF2-40B4-BE49-F238E27FC236}">
-                <a16:creationId xmlns:a16="http://schemas.microsoft.com/office/drawing/2014/main" id="{6E43E40B-6237-4BAE-A387-43E6E5055226}"/>
+                <a16:creationId xmlns:a16="http://schemas.microsoft.com/office/drawing/2014/main" id="{8898330C-2D80-41E8-B911-A1DA5EA10014}"/>
               </a:ext>
             </a:extLst>
           </p:cNvPr>
@@ -3664,7 +3664,7 @@
           <p:cNvPr id="6" name="">
             <a:extLst xmlns:a="http://schemas.openxmlformats.org/drawingml/2006/main">
               <a:ext uri="{FF2B5EF4-FFF2-40B4-BE49-F238E27FC236}">
-                <a16:creationId xmlns:a16="http://schemas.microsoft.com/office/drawing/2014/main" id="{64179AB9-81D9-494D-8D8C-9B634DD4D4CD}"/>
+                <a16:creationId xmlns:a16="http://schemas.microsoft.com/office/drawing/2014/main" id="{2822A4DF-7489-4041-879B-278C958A4B54}"/>
               </a:ext>
             </a:extLst>
           </p:cNvPr>
@@ -3697,7 +3697,7 @@
           <p:cNvPr id="7" name="">
             <a:extLst xmlns:a="http://schemas.openxmlformats.org/drawingml/2006/main">
               <a:ext uri="{FF2B5EF4-FFF2-40B4-BE49-F238E27FC236}">
-                <a16:creationId xmlns:a16="http://schemas.microsoft.com/office/drawing/2014/main" id="{3D32DF74-6B93-4530-A5C7-3277D540C7A1}"/>
+                <a16:creationId xmlns:a16="http://schemas.microsoft.com/office/drawing/2014/main" id="{75F26F68-FE62-4DED-8E91-350C0760A307}"/>
               </a:ext>
             </a:extLst>
           </p:cNvPr>
@@ -3747,7 +3747,7 @@
           <p:cNvPr id="8" name="">
             <a:extLst xmlns:a="http://schemas.openxmlformats.org/drawingml/2006/main">
               <a:ext uri="{FF2B5EF4-FFF2-40B4-BE49-F238E27FC236}">
-                <a16:creationId xmlns:a16="http://schemas.microsoft.com/office/drawing/2014/main" id="{20486FF1-B08E-4640-AE67-22B3E552EFA2}"/>
+                <a16:creationId xmlns:a16="http://schemas.microsoft.com/office/drawing/2014/main" id="{32086570-3391-4307-9200-029C8E0A6289}"/>
               </a:ext>
             </a:extLst>
           </p:cNvPr>
@@ -3797,7 +3797,7 @@
           <p:cNvPr id="9" name="">
             <a:extLst xmlns:a="http://schemas.openxmlformats.org/drawingml/2006/main">
               <a:ext uri="{FF2B5EF4-FFF2-40B4-BE49-F238E27FC236}">
-                <a16:creationId xmlns:a16="http://schemas.microsoft.com/office/drawing/2014/main" id="{BD49BA8E-AD54-4A67-A270-5A508AE72DD9}"/>
+                <a16:creationId xmlns:a16="http://schemas.microsoft.com/office/drawing/2014/main" id="{083CE996-EDD4-4C70-9A4F-79CBDC4696F5}"/>
               </a:ext>
             </a:extLst>
           </p:cNvPr>
@@ -3847,7 +3847,7 @@
           <p:cNvPr id="10" name="">
             <a:extLst xmlns:a="http://schemas.openxmlformats.org/drawingml/2006/main">
               <a:ext uri="{FF2B5EF4-FFF2-40B4-BE49-F238E27FC236}">
-                <a16:creationId xmlns:a16="http://schemas.microsoft.com/office/drawing/2014/main" id="{71B9212E-AB95-4542-B6A8-57F7E8EA9CB8}"/>
+                <a16:creationId xmlns:a16="http://schemas.microsoft.com/office/drawing/2014/main" id="{7A9A1BE6-0B62-4432-ADA2-3309821C4DAA}"/>
               </a:ext>
             </a:extLst>
           </p:cNvPr>
@@ -3897,7 +3897,7 @@
           <p:cNvPr id="11" name="">
             <a:extLst xmlns:a="http://schemas.openxmlformats.org/drawingml/2006/main">
               <a:ext uri="{FF2B5EF4-FFF2-40B4-BE49-F238E27FC236}">
-                <a16:creationId xmlns:a16="http://schemas.microsoft.com/office/drawing/2014/main" id="{57FCAD9B-1AC4-44DD-A0F1-D57DF7975236}"/>
+                <a16:creationId xmlns:a16="http://schemas.microsoft.com/office/drawing/2014/main" id="{504F18E7-9EA6-4E29-8E8B-39060CB1D535}"/>
               </a:ext>
             </a:extLst>
           </p:cNvPr>
@@ -3947,7 +3947,7 @@
           <p:cNvPr id="12" name="">
             <a:extLst xmlns:a="http://schemas.openxmlformats.org/drawingml/2006/main">
               <a:ext uri="{FF2B5EF4-FFF2-40B4-BE49-F238E27FC236}">
-                <a16:creationId xmlns:a16="http://schemas.microsoft.com/office/drawing/2014/main" id="{3F9771A8-6FC3-4309-88EE-03564F50B0C1}"/>
+                <a16:creationId xmlns:a16="http://schemas.microsoft.com/office/drawing/2014/main" id="{AFE07983-D151-4535-8035-A2D04F685E91}"/>
               </a:ext>
             </a:extLst>
           </p:cNvPr>
@@ -3997,7 +3997,7 @@
           <p:cNvPr id="13" name="">
             <a:extLst xmlns:a="http://schemas.openxmlformats.org/drawingml/2006/main">
               <a:ext uri="{FF2B5EF4-FFF2-40B4-BE49-F238E27FC236}">
-                <a16:creationId xmlns:a16="http://schemas.microsoft.com/office/drawing/2014/main" id="{C64A502F-80EF-4581-80AD-4ED7D9031B16}"/>
+                <a16:creationId xmlns:a16="http://schemas.microsoft.com/office/drawing/2014/main" id="{2875FEB4-3113-40C6-A841-89397D5C11C4}"/>
               </a:ext>
             </a:extLst>
           </p:cNvPr>
@@ -4070,7 +4070,7 @@
           <p:cNvPr id="14" name="">
             <a:extLst xmlns:a="http://schemas.openxmlformats.org/drawingml/2006/main">
               <a:ext uri="{FF2B5EF4-FFF2-40B4-BE49-F238E27FC236}">
-                <a16:creationId xmlns:a16="http://schemas.microsoft.com/office/drawing/2014/main" id="{C9738A64-191A-41F3-A7B1-DDFBA67CA9C6}"/>
+                <a16:creationId xmlns:a16="http://schemas.microsoft.com/office/drawing/2014/main" id="{F4C11E2A-C876-4AA9-8258-1F1661824678}"/>
               </a:ext>
             </a:extLst>
           </p:cNvPr>
@@ -4143,7 +4143,7 @@
           <p:cNvPr id="15" name="">
             <a:extLst xmlns:a="http://schemas.openxmlformats.org/drawingml/2006/main">
               <a:ext uri="{FF2B5EF4-FFF2-40B4-BE49-F238E27FC236}">
-                <a16:creationId xmlns:a16="http://schemas.microsoft.com/office/drawing/2014/main" id="{CAB0D732-6319-40F1-B2B2-5189F8A4561C}"/>
+                <a16:creationId xmlns:a16="http://schemas.microsoft.com/office/drawing/2014/main" id="{1D377B61-C148-4476-8E39-E824BEF6269B}"/>
               </a:ext>
             </a:extLst>
           </p:cNvPr>
@@ -4216,7 +4216,7 @@
           <p:cNvPr id="16" name="">
             <a:extLst xmlns:a="http://schemas.openxmlformats.org/drawingml/2006/main">
               <a:ext uri="{FF2B5EF4-FFF2-40B4-BE49-F238E27FC236}">
-                <a16:creationId xmlns:a16="http://schemas.microsoft.com/office/drawing/2014/main" id="{D833DB80-D47D-4A5F-A8D4-2CD08A20B071}"/>
+                <a16:creationId xmlns:a16="http://schemas.microsoft.com/office/drawing/2014/main" id="{C4B183C0-67F0-4B71-9CEC-14D216874913}"/>
               </a:ext>
             </a:extLst>
           </p:cNvPr>
@@ -4266,7 +4266,7 @@
           <p:cNvPr id="17" name="">
             <a:extLst xmlns:a="http://schemas.openxmlformats.org/drawingml/2006/main">
               <a:ext uri="{FF2B5EF4-FFF2-40B4-BE49-F238E27FC236}">
-                <a16:creationId xmlns:a16="http://schemas.microsoft.com/office/drawing/2014/main" id="{2E798899-C9C9-4E39-AA62-DB99BC12F980}"/>
+                <a16:creationId xmlns:a16="http://schemas.microsoft.com/office/drawing/2014/main" id="{34907B53-AC44-4E26-B017-0A820771AC86}"/>
               </a:ext>
             </a:extLst>
           </p:cNvPr>
@@ -4314,7 +4314,7 @@
     </p:spTree>
     <p:extLst>
       <p:ext uri="{BB962C8B-B14F-4D97-AF65-F5344CB8AC3E}">
-        <p14:creationId xmlns:p14="http://schemas.microsoft.com/office/powerpoint/2010/main" val="162725665"/>
+        <p14:creationId xmlns:p14="http://schemas.microsoft.com/office/powerpoint/2010/main" val="1174947707"/>
       </p:ext>
     </p:extLst>
   </p:cSld>
@@ -4345,7 +4345,7 @@
           <p:cNvPr id="1" name="">
             <a:extLst xmlns:a="http://schemas.openxmlformats.org/drawingml/2006/main">
               <a:ext uri="{FF2B5EF4-FFF2-40B4-BE49-F238E27FC236}">
-                <a16:creationId xmlns:a16="http://schemas.microsoft.com/office/drawing/2014/main" id="{7F544B8B-E141-4F4F-A107-37986E05F81E}"/>
+                <a16:creationId xmlns:a16="http://schemas.microsoft.com/office/drawing/2014/main" id="{023EE017-046C-4C29-A79E-8078C2815AA8}"/>
               </a:ext>
             </a:extLst>
           </p:cNvPr>
@@ -4378,7 +4378,7 @@
           <p:cNvPr id="2" name="">
             <a:extLst xmlns:a="http://schemas.openxmlformats.org/drawingml/2006/main">
               <a:ext uri="{FF2B5EF4-FFF2-40B4-BE49-F238E27FC236}">
-                <a16:creationId xmlns:a16="http://schemas.microsoft.com/office/drawing/2014/main" id="{3EDAF137-395D-49A2-88DC-2F923DD82129}"/>
+                <a16:creationId xmlns:a16="http://schemas.microsoft.com/office/drawing/2014/main" id="{711DBAF5-107F-4ED0-8941-2474F86AEC51}"/>
               </a:ext>
             </a:extLst>
           </p:cNvPr>
@@ -4411,7 +4411,7 @@
           <p:cNvPr id="3" name="">
             <a:extLst xmlns:a="http://schemas.openxmlformats.org/drawingml/2006/main">
               <a:ext uri="{FF2B5EF4-FFF2-40B4-BE49-F238E27FC236}">
-                <a16:creationId xmlns:a16="http://schemas.microsoft.com/office/drawing/2014/main" id="{3983A7B5-B939-4D83-8AAF-012C6EF71D2D}"/>
+                <a16:creationId xmlns:a16="http://schemas.microsoft.com/office/drawing/2014/main" id="{3899710F-11C5-4A51-99FA-BDBE0C602F2A}"/>
               </a:ext>
             </a:extLst>
           </p:cNvPr>
@@ -4461,7 +4461,7 @@
           <p:cNvPr id="4" name="">
             <a:extLst xmlns:a="http://schemas.openxmlformats.org/drawingml/2006/main">
               <a:ext uri="{FF2B5EF4-FFF2-40B4-BE49-F238E27FC236}">
-                <a16:creationId xmlns:a16="http://schemas.microsoft.com/office/drawing/2014/main" id="{D06254B1-71A0-4623-AC3C-52C5E9597987}"/>
+                <a16:creationId xmlns:a16="http://schemas.microsoft.com/office/drawing/2014/main" id="{8624F6D7-CF8D-45E4-98C1-765856809684}"/>
               </a:ext>
             </a:extLst>
           </p:cNvPr>
@@ -4511,7 +4511,7 @@
           <p:cNvPr id="5" name="">
             <a:extLst xmlns:a="http://schemas.openxmlformats.org/drawingml/2006/main">
               <a:ext uri="{FF2B5EF4-FFF2-40B4-BE49-F238E27FC236}">
-                <a16:creationId xmlns:a16="http://schemas.microsoft.com/office/drawing/2014/main" id="{EE9C5703-2B22-46A3-8796-5ECCD2B5741F}"/>
+                <a16:creationId xmlns:a16="http://schemas.microsoft.com/office/drawing/2014/main" id="{3B9F70CE-9B67-4225-8EB3-220B025025F8}"/>
               </a:ext>
             </a:extLst>
           </p:cNvPr>
@@ -4561,7 +4561,7 @@
           <p:cNvPr id="6" name="">
             <a:extLst xmlns:a="http://schemas.openxmlformats.org/drawingml/2006/main">
               <a:ext uri="{FF2B5EF4-FFF2-40B4-BE49-F238E27FC236}">
-                <a16:creationId xmlns:a16="http://schemas.microsoft.com/office/drawing/2014/main" id="{2414C65B-BFA0-4608-BBB6-CD42CBA54947}"/>
+                <a16:creationId xmlns:a16="http://schemas.microsoft.com/office/drawing/2014/main" id="{13777037-C8E7-49A8-8BBB-A63736F5050B}"/>
               </a:ext>
             </a:extLst>
           </p:cNvPr>
@@ -4594,7 +4594,7 @@
           <p:cNvPr id="7" name="">
             <a:extLst xmlns:a="http://schemas.openxmlformats.org/drawingml/2006/main">
               <a:ext uri="{FF2B5EF4-FFF2-40B4-BE49-F238E27FC236}">
-                <a16:creationId xmlns:a16="http://schemas.microsoft.com/office/drawing/2014/main" id="{0CAC98D5-B3D4-44EA-945C-91340271295F}"/>
+                <a16:creationId xmlns:a16="http://schemas.microsoft.com/office/drawing/2014/main" id="{EF840826-18F5-4442-B140-8302F7F74C8A}"/>
               </a:ext>
             </a:extLst>
           </p:cNvPr>
@@ -4667,7 +4667,7 @@
           <p:cNvPr id="8" name="">
             <a:extLst xmlns:a="http://schemas.openxmlformats.org/drawingml/2006/main">
               <a:ext uri="{FF2B5EF4-FFF2-40B4-BE49-F238E27FC236}">
-                <a16:creationId xmlns:a16="http://schemas.microsoft.com/office/drawing/2014/main" id="{6307A6A4-7A2F-44A6-846A-B932092190BD}"/>
+                <a16:creationId xmlns:a16="http://schemas.microsoft.com/office/drawing/2014/main" id="{F1B84103-26B8-4B98-82D0-AEAE1FC6A8BB}"/>
               </a:ext>
             </a:extLst>
           </p:cNvPr>
@@ -4740,7 +4740,7 @@
           <p:cNvPr id="9" name="">
             <a:extLst xmlns:a="http://schemas.openxmlformats.org/drawingml/2006/main">
               <a:ext uri="{FF2B5EF4-FFF2-40B4-BE49-F238E27FC236}">
-                <a16:creationId xmlns:a16="http://schemas.microsoft.com/office/drawing/2014/main" id="{382AABC6-C73B-4839-B7BB-7F319C4F53B3}"/>
+                <a16:creationId xmlns:a16="http://schemas.microsoft.com/office/drawing/2014/main" id="{D95B03EC-7B55-4688-B9DE-8AC807E8C3DA}"/>
               </a:ext>
             </a:extLst>
           </p:cNvPr>
@@ -4813,7 +4813,7 @@
           <p:cNvPr id="10" name="">
             <a:extLst xmlns:a="http://schemas.openxmlformats.org/drawingml/2006/main">
               <a:ext uri="{FF2B5EF4-FFF2-40B4-BE49-F238E27FC236}">
-                <a16:creationId xmlns:a16="http://schemas.microsoft.com/office/drawing/2014/main" id="{2B1C7F0A-BB69-4B75-AC75-FD48AFF4CEB3}"/>
+                <a16:creationId xmlns:a16="http://schemas.microsoft.com/office/drawing/2014/main" id="{FA2F5079-5575-40ED-82D6-4B71D4250758}"/>
               </a:ext>
             </a:extLst>
           </p:cNvPr>
@@ -4863,7 +4863,7 @@
           <p:cNvPr id="11" name="">
             <a:extLst xmlns:a="http://schemas.openxmlformats.org/drawingml/2006/main">
               <a:ext uri="{FF2B5EF4-FFF2-40B4-BE49-F238E27FC236}">
-                <a16:creationId xmlns:a16="http://schemas.microsoft.com/office/drawing/2014/main" id="{96576173-C8BE-4CE3-B698-7D9DF555EA5B}"/>
+                <a16:creationId xmlns:a16="http://schemas.microsoft.com/office/drawing/2014/main" id="{C6472B8D-2EA3-450C-A920-8E0F2DC4BC0F}"/>
               </a:ext>
             </a:extLst>
           </p:cNvPr>
@@ -4913,7 +4913,7 @@
           <p:cNvPr id="12" name="">
             <a:extLst xmlns:a="http://schemas.openxmlformats.org/drawingml/2006/main">
               <a:ext uri="{FF2B5EF4-FFF2-40B4-BE49-F238E27FC236}">
-                <a16:creationId xmlns:a16="http://schemas.microsoft.com/office/drawing/2014/main" id="{EB51F922-6E2F-499F-B15C-3C70B4715078}"/>
+                <a16:creationId xmlns:a16="http://schemas.microsoft.com/office/drawing/2014/main" id="{DB606BE6-10BB-4D46-B00E-57970046316A}"/>
               </a:ext>
             </a:extLst>
           </p:cNvPr>
@@ -4963,7 +4963,7 @@
           <p:cNvPr id="13" name="">
             <a:extLst xmlns:a="http://schemas.openxmlformats.org/drawingml/2006/main">
               <a:ext uri="{FF2B5EF4-FFF2-40B4-BE49-F238E27FC236}">
-                <a16:creationId xmlns:a16="http://schemas.microsoft.com/office/drawing/2014/main" id="{50F8D85F-6592-4EFD-9804-9AACF785BDE9}"/>
+                <a16:creationId xmlns:a16="http://schemas.microsoft.com/office/drawing/2014/main" id="{C09344F9-ED81-4DA3-8C52-D83A33BA24D0}"/>
               </a:ext>
             </a:extLst>
           </p:cNvPr>
@@ -5013,7 +5013,7 @@
           <p:cNvPr id="14" name="">
             <a:extLst xmlns:a="http://schemas.openxmlformats.org/drawingml/2006/main">
               <a:ext uri="{FF2B5EF4-FFF2-40B4-BE49-F238E27FC236}">
-                <a16:creationId xmlns:a16="http://schemas.microsoft.com/office/drawing/2014/main" id="{685EB775-4CCC-44BC-A885-F990B8CD1F67}"/>
+                <a16:creationId xmlns:a16="http://schemas.microsoft.com/office/drawing/2014/main" id="{2C3082D5-0B1F-4AE8-A6B4-83E1CCC067CE}"/>
               </a:ext>
             </a:extLst>
           </p:cNvPr>
@@ -5063,7 +5063,7 @@
           <p:cNvPr id="15" name="">
             <a:extLst xmlns:a="http://schemas.openxmlformats.org/drawingml/2006/main">
               <a:ext uri="{FF2B5EF4-FFF2-40B4-BE49-F238E27FC236}">
-                <a16:creationId xmlns:a16="http://schemas.microsoft.com/office/drawing/2014/main" id="{F291F3A3-6525-4750-835C-84C815DDDE25}"/>
+                <a16:creationId xmlns:a16="http://schemas.microsoft.com/office/drawing/2014/main" id="{3C843CB0-AC27-4D88-A64B-FE0D915B7EBC}"/>
               </a:ext>
             </a:extLst>
           </p:cNvPr>
@@ -5113,7 +5113,7 @@
           <p:cNvPr id="16" name="">
             <a:extLst xmlns:a="http://schemas.openxmlformats.org/drawingml/2006/main">
               <a:ext uri="{FF2B5EF4-FFF2-40B4-BE49-F238E27FC236}">
-                <a16:creationId xmlns:a16="http://schemas.microsoft.com/office/drawing/2014/main" id="{8FA1C75D-B139-45A1-9B7D-F5DE9DA12F7E}"/>
+                <a16:creationId xmlns:a16="http://schemas.microsoft.com/office/drawing/2014/main" id="{D3673417-DAD5-4058-B685-1E222F9E8E0D}"/>
               </a:ext>
             </a:extLst>
           </p:cNvPr>
@@ -5163,7 +5163,7 @@
           <p:cNvPr id="17" name="">
             <a:extLst xmlns:a="http://schemas.openxmlformats.org/drawingml/2006/main">
               <a:ext uri="{FF2B5EF4-FFF2-40B4-BE49-F238E27FC236}">
-                <a16:creationId xmlns:a16="http://schemas.microsoft.com/office/drawing/2014/main" id="{E72CE993-C10C-4A32-8AA6-8515F4D627CB}"/>
+                <a16:creationId xmlns:a16="http://schemas.microsoft.com/office/drawing/2014/main" id="{143DBBF7-CA2A-4122-9672-2EA27F1BE0D0}"/>
               </a:ext>
             </a:extLst>
           </p:cNvPr>
@@ -5211,7 +5211,7 @@
     </p:spTree>
     <p:extLst>
       <p:ext uri="{BB962C8B-B14F-4D97-AF65-F5344CB8AC3E}">
-        <p14:creationId xmlns:p14="http://schemas.microsoft.com/office/powerpoint/2010/main" val="1732213059"/>
+        <p14:creationId xmlns:p14="http://schemas.microsoft.com/office/powerpoint/2010/main" val="995393691"/>
       </p:ext>
     </p:extLst>
   </p:cSld>
@@ -5242,7 +5242,7 @@
           <p:cNvPr id="1" name="">
             <a:extLst xmlns:a="http://schemas.openxmlformats.org/drawingml/2006/main">
               <a:ext uri="{FF2B5EF4-FFF2-40B4-BE49-F238E27FC236}">
-                <a16:creationId xmlns:a16="http://schemas.microsoft.com/office/drawing/2014/main" id="{658D3A8A-9D9D-43EF-9966-9B34A3F3910D}"/>
+                <a16:creationId xmlns:a16="http://schemas.microsoft.com/office/drawing/2014/main" id="{BEEE57DC-BD4E-47AB-97F8-813D37AE7216}"/>
               </a:ext>
             </a:extLst>
           </p:cNvPr>
@@ -5275,7 +5275,7 @@
           <p:cNvPr id="2" name="">
             <a:extLst xmlns:a="http://schemas.openxmlformats.org/drawingml/2006/main">
               <a:ext uri="{FF2B5EF4-FFF2-40B4-BE49-F238E27FC236}">
-                <a16:creationId xmlns:a16="http://schemas.microsoft.com/office/drawing/2014/main" id="{96E7C136-7478-4223-A596-1CE7D8247167}"/>
+                <a16:creationId xmlns:a16="http://schemas.microsoft.com/office/drawing/2014/main" id="{5D05C580-98A2-40E2-82FD-D5422001B745}"/>
               </a:ext>
             </a:extLst>
           </p:cNvPr>
@@ -5308,7 +5308,7 @@
           <p:cNvPr id="3" name="">
             <a:extLst xmlns:a="http://schemas.openxmlformats.org/drawingml/2006/main">
               <a:ext uri="{FF2B5EF4-FFF2-40B4-BE49-F238E27FC236}">
-                <a16:creationId xmlns:a16="http://schemas.microsoft.com/office/drawing/2014/main" id="{A4260971-9334-4FB1-9F0F-3185EE1C58F6}"/>
+                <a16:creationId xmlns:a16="http://schemas.microsoft.com/office/drawing/2014/main" id="{606947D1-C764-4C44-A90F-27FE20BF8BEA}"/>
               </a:ext>
             </a:extLst>
           </p:cNvPr>
@@ -5358,7 +5358,7 @@
           <p:cNvPr id="4" name="">
             <a:extLst xmlns:a="http://schemas.openxmlformats.org/drawingml/2006/main">
               <a:ext uri="{FF2B5EF4-FFF2-40B4-BE49-F238E27FC236}">
-                <a16:creationId xmlns:a16="http://schemas.microsoft.com/office/drawing/2014/main" id="{293E8F10-7FA2-42CC-9DF1-12FB2314D979}"/>
+                <a16:creationId xmlns:a16="http://schemas.microsoft.com/office/drawing/2014/main" id="{9D9DF730-E9A9-452A-9637-A0DB8883DD32}"/>
               </a:ext>
             </a:extLst>
           </p:cNvPr>
@@ -5408,7 +5408,7 @@
           <p:cNvPr id="5" name="">
             <a:extLst xmlns:a="http://schemas.openxmlformats.org/drawingml/2006/main">
               <a:ext uri="{FF2B5EF4-FFF2-40B4-BE49-F238E27FC236}">
-                <a16:creationId xmlns:a16="http://schemas.microsoft.com/office/drawing/2014/main" id="{D47CD955-945D-4D83-A781-694F5B8A9744}"/>
+                <a16:creationId xmlns:a16="http://schemas.microsoft.com/office/drawing/2014/main" id="{DB0F34D2-B4A9-4264-8AEC-AE055EA0D571}"/>
               </a:ext>
             </a:extLst>
           </p:cNvPr>
@@ -5458,7 +5458,7 @@
           <p:cNvPr id="6" name="">
             <a:extLst xmlns:a="http://schemas.openxmlformats.org/drawingml/2006/main">
               <a:ext uri="{FF2B5EF4-FFF2-40B4-BE49-F238E27FC236}">
-                <a16:creationId xmlns:a16="http://schemas.microsoft.com/office/drawing/2014/main" id="{CA880A7A-DE97-4BBE-A17A-83E0E9FB1A06}"/>
+                <a16:creationId xmlns:a16="http://schemas.microsoft.com/office/drawing/2014/main" id="{4AAC93B0-A243-4D30-B7D6-055D35CA222E}"/>
               </a:ext>
             </a:extLst>
           </p:cNvPr>
@@ -5495,7 +5495,7 @@
           <p:nvPr/>
         </p:nvPicPr>
         <p:blipFill>
-          <a:blip xmlns:r="http://schemas.openxmlformats.org/officeDocument/2006/relationships" xmlns:a="http://schemas.openxmlformats.org/drawingml/2006/main" r:embed="R0aefd2a0a04b46e8"/>
+          <a:blip xmlns:r="http://schemas.openxmlformats.org/officeDocument/2006/relationships" xmlns:a="http://schemas.openxmlformats.org/drawingml/2006/main" r:embed="R314b460c335b4255"/>
           <a:stretch xmlns:a="http://schemas.openxmlformats.org/drawingml/2006/main"/>
         </p:blipFill>
         <p:spPr>
@@ -5513,7 +5513,7 @@
           <p:cNvPr id="8" name="">
             <a:extLst xmlns:a="http://schemas.openxmlformats.org/drawingml/2006/main">
               <a:ext uri="{FF2B5EF4-FFF2-40B4-BE49-F238E27FC236}">
-                <a16:creationId xmlns:a16="http://schemas.microsoft.com/office/drawing/2014/main" id="{CE78B43D-093D-46D9-9F5F-72CDF09DABA3}"/>
+                <a16:creationId xmlns:a16="http://schemas.microsoft.com/office/drawing/2014/main" id="{B91B125F-20D9-4396-BD07-0D65AF939905}"/>
               </a:ext>
             </a:extLst>
           </p:cNvPr>
@@ -5563,7 +5563,7 @@
           <p:cNvPr id="9" name="">
             <a:extLst xmlns:a="http://schemas.openxmlformats.org/drawingml/2006/main">
               <a:ext uri="{FF2B5EF4-FFF2-40B4-BE49-F238E27FC236}">
-                <a16:creationId xmlns:a16="http://schemas.microsoft.com/office/drawing/2014/main" id="{9A22EDB4-925D-4AE9-8741-7F6357632E4C}"/>
+                <a16:creationId xmlns:a16="http://schemas.microsoft.com/office/drawing/2014/main" id="{C300545B-BE6C-446C-BBA2-B6A06BEA1A4A}"/>
               </a:ext>
             </a:extLst>
           </p:cNvPr>
@@ -5613,7 +5613,7 @@
           <p:cNvPr id="10" name="">
             <a:extLst xmlns:a="http://schemas.openxmlformats.org/drawingml/2006/main">
               <a:ext uri="{FF2B5EF4-FFF2-40B4-BE49-F238E27FC236}">
-                <a16:creationId xmlns:a16="http://schemas.microsoft.com/office/drawing/2014/main" id="{ADE5391C-5089-40A7-BC39-157C906D4258}"/>
+                <a16:creationId xmlns:a16="http://schemas.microsoft.com/office/drawing/2014/main" id="{E564743D-BE48-47F1-B17D-35E6266A4255}"/>
               </a:ext>
             </a:extLst>
           </p:cNvPr>
@@ -5663,7 +5663,7 @@
           <p:cNvPr id="11" name="">
             <a:extLst xmlns:a="http://schemas.openxmlformats.org/drawingml/2006/main">
               <a:ext uri="{FF2B5EF4-FFF2-40B4-BE49-F238E27FC236}">
-                <a16:creationId xmlns:a16="http://schemas.microsoft.com/office/drawing/2014/main" id="{E7015E56-22DF-4C57-AF66-48FAB81A59B4}"/>
+                <a16:creationId xmlns:a16="http://schemas.microsoft.com/office/drawing/2014/main" id="{5F080073-4AF2-451C-A151-09DBB70A18BE}"/>
               </a:ext>
             </a:extLst>
           </p:cNvPr>
@@ -5713,7 +5713,7 @@
           <p:cNvPr id="12" name="">
             <a:extLst xmlns:a="http://schemas.openxmlformats.org/drawingml/2006/main">
               <a:ext uri="{FF2B5EF4-FFF2-40B4-BE49-F238E27FC236}">
-                <a16:creationId xmlns:a16="http://schemas.microsoft.com/office/drawing/2014/main" id="{FB82A92F-9FF2-4787-BDF8-F70A683B5581}"/>
+                <a16:creationId xmlns:a16="http://schemas.microsoft.com/office/drawing/2014/main" id="{EF014A11-F61F-4E00-9995-3A6F37F49686}"/>
               </a:ext>
             </a:extLst>
           </p:cNvPr>
@@ -5763,7 +5763,7 @@
           <p:cNvPr id="13" name="">
             <a:extLst xmlns:a="http://schemas.openxmlformats.org/drawingml/2006/main">
               <a:ext uri="{FF2B5EF4-FFF2-40B4-BE49-F238E27FC236}">
-                <a16:creationId xmlns:a16="http://schemas.microsoft.com/office/drawing/2014/main" id="{D6A1B55D-EF36-44AF-B63A-9EE223FE7A42}"/>
+                <a16:creationId xmlns:a16="http://schemas.microsoft.com/office/drawing/2014/main" id="{1BBE4CBE-A1CF-4FFC-B336-7579E35B5508}"/>
               </a:ext>
             </a:extLst>
           </p:cNvPr>
@@ -5813,7 +5813,7 @@
           <p:cNvPr id="14" name="">
             <a:extLst xmlns:a="http://schemas.openxmlformats.org/drawingml/2006/main">
               <a:ext uri="{FF2B5EF4-FFF2-40B4-BE49-F238E27FC236}">
-                <a16:creationId xmlns:a16="http://schemas.microsoft.com/office/drawing/2014/main" id="{BB5B478C-6CE8-4539-98D1-E3CC389ECF01}"/>
+                <a16:creationId xmlns:a16="http://schemas.microsoft.com/office/drawing/2014/main" id="{FBD99984-C78B-40FA-97A8-A4B7F19D2599}"/>
               </a:ext>
             </a:extLst>
           </p:cNvPr>
@@ -5863,7 +5863,7 @@
           <p:cNvPr id="15" name="">
             <a:extLst xmlns:a="http://schemas.openxmlformats.org/drawingml/2006/main">
               <a:ext uri="{FF2B5EF4-FFF2-40B4-BE49-F238E27FC236}">
-                <a16:creationId xmlns:a16="http://schemas.microsoft.com/office/drawing/2014/main" id="{BD785FC9-6706-4D78-B96E-1D7D63916664}"/>
+                <a16:creationId xmlns:a16="http://schemas.microsoft.com/office/drawing/2014/main" id="{221274B8-AF5F-4E7F-8DAC-D36483EF6727}"/>
               </a:ext>
             </a:extLst>
           </p:cNvPr>
@@ -5913,7 +5913,7 @@
           <p:cNvPr id="16" name="">
             <a:extLst xmlns:a="http://schemas.openxmlformats.org/drawingml/2006/main">
               <a:ext uri="{FF2B5EF4-FFF2-40B4-BE49-F238E27FC236}">
-                <a16:creationId xmlns:a16="http://schemas.microsoft.com/office/drawing/2014/main" id="{1ABDBEE8-CA82-43DE-A2EA-79435D70FF3F}"/>
+                <a16:creationId xmlns:a16="http://schemas.microsoft.com/office/drawing/2014/main" id="{86E503AD-16A7-4C82-B30D-206C94103234}"/>
               </a:ext>
             </a:extLst>
           </p:cNvPr>
@@ -5963,7 +5963,7 @@
           <p:cNvPr id="17" name="">
             <a:extLst xmlns:a="http://schemas.openxmlformats.org/drawingml/2006/main">
               <a:ext uri="{FF2B5EF4-FFF2-40B4-BE49-F238E27FC236}">
-                <a16:creationId xmlns:a16="http://schemas.microsoft.com/office/drawing/2014/main" id="{A6B8210B-66F2-4CB7-8D83-EA7915509AB2}"/>
+                <a16:creationId xmlns:a16="http://schemas.microsoft.com/office/drawing/2014/main" id="{C6A85FCF-80AD-403C-9407-B79C7588CBBF}"/>
               </a:ext>
             </a:extLst>
           </p:cNvPr>
@@ -6011,7 +6011,7 @@
     </p:spTree>
     <p:extLst>
       <p:ext uri="{BB962C8B-B14F-4D97-AF65-F5344CB8AC3E}">
-        <p14:creationId xmlns:p14="http://schemas.microsoft.com/office/powerpoint/2010/main" val="1657373207"/>
+        <p14:creationId xmlns:p14="http://schemas.microsoft.com/office/powerpoint/2010/main" val="2134881027"/>
       </p:ext>
     </p:extLst>
   </p:cSld>
@@ -6042,7 +6042,7 @@
           <p:cNvPr id="1" name="">
             <a:extLst xmlns:a="http://schemas.openxmlformats.org/drawingml/2006/main">
               <a:ext uri="{FF2B5EF4-FFF2-40B4-BE49-F238E27FC236}">
-                <a16:creationId xmlns:a16="http://schemas.microsoft.com/office/drawing/2014/main" id="{590EA87D-AA3C-4134-9199-44E159532397}"/>
+                <a16:creationId xmlns:a16="http://schemas.microsoft.com/office/drawing/2014/main" id="{6741ACB9-B7E9-4D45-9616-6C1A8E4E3EE8}"/>
               </a:ext>
             </a:extLst>
           </p:cNvPr>
@@ -6075,7 +6075,7 @@
           <p:cNvPr id="2" name="">
             <a:extLst xmlns:a="http://schemas.openxmlformats.org/drawingml/2006/main">
               <a:ext uri="{FF2B5EF4-FFF2-40B4-BE49-F238E27FC236}">
-                <a16:creationId xmlns:a16="http://schemas.microsoft.com/office/drawing/2014/main" id="{B5C3C527-5AE6-4776-9AAD-6A762C1B0981}"/>
+                <a16:creationId xmlns:a16="http://schemas.microsoft.com/office/drawing/2014/main" id="{87DCC9E9-90A0-4B21-8FB4-57AB251CDB12}"/>
               </a:ext>
             </a:extLst>
           </p:cNvPr>
@@ -6108,7 +6108,7 @@
           <p:cNvPr id="3" name="">
             <a:extLst xmlns:a="http://schemas.openxmlformats.org/drawingml/2006/main">
               <a:ext uri="{FF2B5EF4-FFF2-40B4-BE49-F238E27FC236}">
-                <a16:creationId xmlns:a16="http://schemas.microsoft.com/office/drawing/2014/main" id="{6F6F6AFE-9EE1-4A95-9603-D12F420B2506}"/>
+                <a16:creationId xmlns:a16="http://schemas.microsoft.com/office/drawing/2014/main" id="{BFA5FA1B-C499-4541-AA69-2952C20CCD37}"/>
               </a:ext>
             </a:extLst>
           </p:cNvPr>
@@ -6158,7 +6158,7 @@
           <p:cNvPr id="4" name="">
             <a:extLst xmlns:a="http://schemas.openxmlformats.org/drawingml/2006/main">
               <a:ext uri="{FF2B5EF4-FFF2-40B4-BE49-F238E27FC236}">
-                <a16:creationId xmlns:a16="http://schemas.microsoft.com/office/drawing/2014/main" id="{70ECFF27-3E95-4194-BCC5-79337F7F1F5C}"/>
+                <a16:creationId xmlns:a16="http://schemas.microsoft.com/office/drawing/2014/main" id="{E8CFBCB1-0221-483F-8717-1458E9A0A2BF}"/>
               </a:ext>
             </a:extLst>
           </p:cNvPr>
@@ -6208,7 +6208,7 @@
           <p:cNvPr id="5" name="">
             <a:extLst xmlns:a="http://schemas.openxmlformats.org/drawingml/2006/main">
               <a:ext uri="{FF2B5EF4-FFF2-40B4-BE49-F238E27FC236}">
-                <a16:creationId xmlns:a16="http://schemas.microsoft.com/office/drawing/2014/main" id="{7DCB0F80-D0C9-4003-9FBF-0D371203518B}"/>
+                <a16:creationId xmlns:a16="http://schemas.microsoft.com/office/drawing/2014/main" id="{E7A4873D-8264-444C-95A4-E92F039EB9F4}"/>
               </a:ext>
             </a:extLst>
           </p:cNvPr>
@@ -6258,7 +6258,7 @@
           <p:cNvPr id="6" name="">
             <a:extLst xmlns:a="http://schemas.openxmlformats.org/drawingml/2006/main">
               <a:ext uri="{FF2B5EF4-FFF2-40B4-BE49-F238E27FC236}">
-                <a16:creationId xmlns:a16="http://schemas.microsoft.com/office/drawing/2014/main" id="{CDD23748-B558-4F22-B5C5-99679A9DC4D6}"/>
+                <a16:creationId xmlns:a16="http://schemas.microsoft.com/office/drawing/2014/main" id="{50244F08-757A-4F64-9A14-FDC8A5B257B2}"/>
               </a:ext>
             </a:extLst>
           </p:cNvPr>
@@ -6295,13 +6295,13 @@
           <p:nvPr/>
         </p:nvPicPr>
         <p:blipFill>
-          <a:blip xmlns:r="http://schemas.openxmlformats.org/officeDocument/2006/relationships" xmlns:a="http://schemas.openxmlformats.org/drawingml/2006/main" r:embed="R06737f89e3d84af4"/>
+          <a:blip xmlns:r="http://schemas.openxmlformats.org/officeDocument/2006/relationships" xmlns:a="http://schemas.openxmlformats.org/drawingml/2006/main" r:embed="R8db4e62e3e884ccb"/>
           <a:stretch xmlns:a="http://schemas.openxmlformats.org/drawingml/2006/main"/>
         </p:blipFill>
         <p:spPr>
           <a:xfrm xmlns:a="http://schemas.openxmlformats.org/drawingml/2006/main">
-            <a:off x="3038080" y="1381125"/>
-            <a:ext cx="5734839" cy="2952750"/>
+            <a:off x="2747320" y="1381125"/>
+            <a:ext cx="6316360" cy="2952750"/>
           </a:xfrm>
           <a:prstGeom xmlns:a="http://schemas.openxmlformats.org/drawingml/2006/main" prst="rect">
             <a:avLst/>
@@ -6313,7 +6313,7 @@
           <p:cNvPr id="8" name="">
             <a:extLst xmlns:a="http://schemas.openxmlformats.org/drawingml/2006/main">
               <a:ext uri="{FF2B5EF4-FFF2-40B4-BE49-F238E27FC236}">
-                <a16:creationId xmlns:a16="http://schemas.microsoft.com/office/drawing/2014/main" id="{953472DD-3620-4DA4-8DCC-A92551664992}"/>
+                <a16:creationId xmlns:a16="http://schemas.microsoft.com/office/drawing/2014/main" id="{845DB312-4FD5-44D4-AF04-08663D514342}"/>
               </a:ext>
             </a:extLst>
           </p:cNvPr>
@@ -6369,7 +6369,7 @@
           <p:cNvPr id="9" name="">
             <a:extLst xmlns:a="http://schemas.openxmlformats.org/drawingml/2006/main">
               <a:ext uri="{FF2B5EF4-FFF2-40B4-BE49-F238E27FC236}">
-                <a16:creationId xmlns:a16="http://schemas.microsoft.com/office/drawing/2014/main" id="{A90B4F07-F0F0-429B-AFB3-4260B368E8DB}"/>
+                <a16:creationId xmlns:a16="http://schemas.microsoft.com/office/drawing/2014/main" id="{58DC8726-E342-402B-A30A-0DD00F5BDFE5}"/>
               </a:ext>
             </a:extLst>
           </p:cNvPr>
@@ -6425,7 +6425,7 @@
           <p:cNvPr id="10" name="">
             <a:extLst xmlns:a="http://schemas.openxmlformats.org/drawingml/2006/main">
               <a:ext uri="{FF2B5EF4-FFF2-40B4-BE49-F238E27FC236}">
-                <a16:creationId xmlns:a16="http://schemas.microsoft.com/office/drawing/2014/main" id="{F8744807-B525-4F75-BAC1-0C054B35A459}"/>
+                <a16:creationId xmlns:a16="http://schemas.microsoft.com/office/drawing/2014/main" id="{BBD0B031-7BE3-4449-AFA8-8584A02BC14D}"/>
               </a:ext>
             </a:extLst>
           </p:cNvPr>
@@ -6481,7 +6481,7 @@
           <p:cNvPr id="11" name="">
             <a:extLst xmlns:a="http://schemas.openxmlformats.org/drawingml/2006/main">
               <a:ext uri="{FF2B5EF4-FFF2-40B4-BE49-F238E27FC236}">
-                <a16:creationId xmlns:a16="http://schemas.microsoft.com/office/drawing/2014/main" id="{7021F5BE-58B5-4F39-9453-C4BB75D14CC7}"/>
+                <a16:creationId xmlns:a16="http://schemas.microsoft.com/office/drawing/2014/main" id="{58183D5A-68C0-485C-A553-610BA49DFA82}"/>
               </a:ext>
             </a:extLst>
           </p:cNvPr>
@@ -6537,7 +6537,7 @@
           <p:cNvPr id="12" name="">
             <a:extLst xmlns:a="http://schemas.openxmlformats.org/drawingml/2006/main">
               <a:ext uri="{FF2B5EF4-FFF2-40B4-BE49-F238E27FC236}">
-                <a16:creationId xmlns:a16="http://schemas.microsoft.com/office/drawing/2014/main" id="{3D296DDA-DB8A-4104-AE19-709548733FDE}"/>
+                <a16:creationId xmlns:a16="http://schemas.microsoft.com/office/drawing/2014/main" id="{2C9B0774-65A9-433F-AD1F-B2AD27C37F30}"/>
               </a:ext>
             </a:extLst>
           </p:cNvPr>
@@ -6587,7 +6587,7 @@
           <p:cNvPr id="13" name="">
             <a:extLst xmlns:a="http://schemas.openxmlformats.org/drawingml/2006/main">
               <a:ext uri="{FF2B5EF4-FFF2-40B4-BE49-F238E27FC236}">
-                <a16:creationId xmlns:a16="http://schemas.microsoft.com/office/drawing/2014/main" id="{F388F6F1-2376-4D66-B11D-903F3A00116A}"/>
+                <a16:creationId xmlns:a16="http://schemas.microsoft.com/office/drawing/2014/main" id="{01173005-6497-43FD-8B21-F4FC0B55B472}"/>
               </a:ext>
             </a:extLst>
           </p:cNvPr>
@@ -6635,7 +6635,7 @@
     </p:spTree>
     <p:extLst>
       <p:ext uri="{BB962C8B-B14F-4D97-AF65-F5344CB8AC3E}">
-        <p14:creationId xmlns:p14="http://schemas.microsoft.com/office/powerpoint/2010/main" val="1835321808"/>
+        <p14:creationId xmlns:p14="http://schemas.microsoft.com/office/powerpoint/2010/main" val="1155367168"/>
       </p:ext>
     </p:extLst>
   </p:cSld>
@@ -6666,7 +6666,7 @@
           <p:cNvPr id="1" name="">
             <a:extLst xmlns:a="http://schemas.openxmlformats.org/drawingml/2006/main">
               <a:ext uri="{FF2B5EF4-FFF2-40B4-BE49-F238E27FC236}">
-                <a16:creationId xmlns:a16="http://schemas.microsoft.com/office/drawing/2014/main" id="{AE944E90-78E6-410E-A33E-7D43AA5AB464}"/>
+                <a16:creationId xmlns:a16="http://schemas.microsoft.com/office/drawing/2014/main" id="{66BF951B-B791-4D7B-88B4-68DE45D85438}"/>
               </a:ext>
             </a:extLst>
           </p:cNvPr>
@@ -6699,7 +6699,7 @@
           <p:cNvPr id="2" name="">
             <a:extLst xmlns:a="http://schemas.openxmlformats.org/drawingml/2006/main">
               <a:ext uri="{FF2B5EF4-FFF2-40B4-BE49-F238E27FC236}">
-                <a16:creationId xmlns:a16="http://schemas.microsoft.com/office/drawing/2014/main" id="{AE14C3D5-1C6E-4E2E-AE1E-EF181A2B50D8}"/>
+                <a16:creationId xmlns:a16="http://schemas.microsoft.com/office/drawing/2014/main" id="{544CEE55-83A8-42D2-B346-E55BCA4BD318}"/>
               </a:ext>
             </a:extLst>
           </p:cNvPr>
@@ -6732,7 +6732,7 @@
           <p:cNvPr id="3" name="">
             <a:extLst xmlns:a="http://schemas.openxmlformats.org/drawingml/2006/main">
               <a:ext uri="{FF2B5EF4-FFF2-40B4-BE49-F238E27FC236}">
-                <a16:creationId xmlns:a16="http://schemas.microsoft.com/office/drawing/2014/main" id="{75584E7F-1B94-4777-A30B-A7A0905188EE}"/>
+                <a16:creationId xmlns:a16="http://schemas.microsoft.com/office/drawing/2014/main" id="{28D61556-0030-4353-8ABC-40DDE55A73F1}"/>
               </a:ext>
             </a:extLst>
           </p:cNvPr>
@@ -6782,7 +6782,7 @@
           <p:cNvPr id="4" name="">
             <a:extLst xmlns:a="http://schemas.openxmlformats.org/drawingml/2006/main">
               <a:ext uri="{FF2B5EF4-FFF2-40B4-BE49-F238E27FC236}">
-                <a16:creationId xmlns:a16="http://schemas.microsoft.com/office/drawing/2014/main" id="{B5FC7695-6BBD-4D99-A2A5-AE6DD4254803}"/>
+                <a16:creationId xmlns:a16="http://schemas.microsoft.com/office/drawing/2014/main" id="{C5B44919-9094-42D7-B016-B00F46377BEB}"/>
               </a:ext>
             </a:extLst>
           </p:cNvPr>
@@ -6832,7 +6832,7 @@
           <p:cNvPr id="5" name="">
             <a:extLst xmlns:a="http://schemas.openxmlformats.org/drawingml/2006/main">
               <a:ext uri="{FF2B5EF4-FFF2-40B4-BE49-F238E27FC236}">
-                <a16:creationId xmlns:a16="http://schemas.microsoft.com/office/drawing/2014/main" id="{9DED0800-15C5-47FF-B33E-C17075A770CA}"/>
+                <a16:creationId xmlns:a16="http://schemas.microsoft.com/office/drawing/2014/main" id="{E81BFD9A-6864-4ABB-B65C-1DA71EEEE306}"/>
               </a:ext>
             </a:extLst>
           </p:cNvPr>
@@ -6882,7 +6882,7 @@
           <p:cNvPr id="6" name="">
             <a:extLst xmlns:a="http://schemas.openxmlformats.org/drawingml/2006/main">
               <a:ext uri="{FF2B5EF4-FFF2-40B4-BE49-F238E27FC236}">
-                <a16:creationId xmlns:a16="http://schemas.microsoft.com/office/drawing/2014/main" id="{2A5D015A-15DF-43BE-B0C3-16CF247F2562}"/>
+                <a16:creationId xmlns:a16="http://schemas.microsoft.com/office/drawing/2014/main" id="{F8876E0E-6AB7-4201-BB93-FC7F995CDF8B}"/>
               </a:ext>
             </a:extLst>
           </p:cNvPr>
@@ -6919,13 +6919,13 @@
           <p:nvPr/>
         </p:nvPicPr>
         <p:blipFill>
-          <a:blip xmlns:r="http://schemas.openxmlformats.org/officeDocument/2006/relationships" xmlns:a="http://schemas.openxmlformats.org/drawingml/2006/main" r:embed="R6fccbfe6081e411b"/>
+          <a:blip xmlns:r="http://schemas.openxmlformats.org/officeDocument/2006/relationships" xmlns:a="http://schemas.openxmlformats.org/drawingml/2006/main" r:embed="R87df4f31272b485c"/>
           <a:stretch xmlns:a="http://schemas.openxmlformats.org/drawingml/2006/main"/>
         </p:blipFill>
         <p:spPr>
           <a:xfrm xmlns:a="http://schemas.openxmlformats.org/drawingml/2006/main">
-            <a:off x="666750" y="1865317"/>
-            <a:ext cx="5334000" cy="2746366"/>
+            <a:off x="666750" y="1957253"/>
+            <a:ext cx="5334000" cy="2562494"/>
           </a:xfrm>
           <a:prstGeom xmlns:a="http://schemas.openxmlformats.org/drawingml/2006/main" prst="rect">
             <a:avLst/>
@@ -6941,13 +6941,13 @@
           <p:nvPr/>
         </p:nvPicPr>
         <p:blipFill>
-          <a:blip xmlns:r="http://schemas.openxmlformats.org/officeDocument/2006/relationships" xmlns:a="http://schemas.openxmlformats.org/drawingml/2006/main" r:embed="R6889629a508f4cc4"/>
+          <a:blip xmlns:r="http://schemas.openxmlformats.org/officeDocument/2006/relationships" xmlns:a="http://schemas.openxmlformats.org/drawingml/2006/main" r:embed="R6f788737b16a4ce8"/>
           <a:stretch xmlns:a="http://schemas.openxmlformats.org/drawingml/2006/main"/>
         </p:blipFill>
         <p:spPr>
           <a:xfrm xmlns:a="http://schemas.openxmlformats.org/drawingml/2006/main">
-            <a:off x="6286500" y="1865317"/>
-            <a:ext cx="5334000" cy="2746366"/>
+            <a:off x="6286500" y="1957253"/>
+            <a:ext cx="5334000" cy="2562494"/>
           </a:xfrm>
           <a:prstGeom xmlns:a="http://schemas.openxmlformats.org/drawingml/2006/main" prst="rect">
             <a:avLst/>
@@ -6959,7 +6959,7 @@
           <p:cNvPr id="9" name="">
             <a:extLst xmlns:a="http://schemas.openxmlformats.org/drawingml/2006/main">
               <a:ext uri="{FF2B5EF4-FFF2-40B4-BE49-F238E27FC236}">
-                <a16:creationId xmlns:a16="http://schemas.microsoft.com/office/drawing/2014/main" id="{7D50419B-B367-4C09-94C2-6699BC1067A5}"/>
+                <a16:creationId xmlns:a16="http://schemas.microsoft.com/office/drawing/2014/main" id="{A45DA7F7-F0F1-4CB3-898B-011D903CD998}"/>
               </a:ext>
             </a:extLst>
           </p:cNvPr>
@@ -7009,7 +7009,7 @@
           <p:cNvPr id="10" name="">
             <a:extLst xmlns:a="http://schemas.openxmlformats.org/drawingml/2006/main">
               <a:ext uri="{FF2B5EF4-FFF2-40B4-BE49-F238E27FC236}">
-                <a16:creationId xmlns:a16="http://schemas.microsoft.com/office/drawing/2014/main" id="{25563533-EB05-4DB2-A9D3-30A07E5E889A}"/>
+                <a16:creationId xmlns:a16="http://schemas.microsoft.com/office/drawing/2014/main" id="{A70E1739-AA51-4564-A3F0-EEE19E6212F6}"/>
               </a:ext>
             </a:extLst>
           </p:cNvPr>
@@ -7059,7 +7059,7 @@
           <p:cNvPr id="11" name="">
             <a:extLst xmlns:a="http://schemas.openxmlformats.org/drawingml/2006/main">
               <a:ext uri="{FF2B5EF4-FFF2-40B4-BE49-F238E27FC236}">
-                <a16:creationId xmlns:a16="http://schemas.microsoft.com/office/drawing/2014/main" id="{1213ADD8-386C-4653-B491-9A79CD8C9FC3}"/>
+                <a16:creationId xmlns:a16="http://schemas.microsoft.com/office/drawing/2014/main" id="{CE2ACA58-DF84-40C1-923C-92BB4F69F180}"/>
               </a:ext>
             </a:extLst>
           </p:cNvPr>
@@ -7107,7 +7107,7 @@
     </p:spTree>
     <p:extLst>
       <p:ext uri="{BB962C8B-B14F-4D97-AF65-F5344CB8AC3E}">
-        <p14:creationId xmlns:p14="http://schemas.microsoft.com/office/powerpoint/2010/main" val="1015240549"/>
+        <p14:creationId xmlns:p14="http://schemas.microsoft.com/office/powerpoint/2010/main" val="328981584"/>
       </p:ext>
     </p:extLst>
   </p:cSld>
@@ -7138,7 +7138,7 @@
           <p:cNvPr id="1" name="">
             <a:extLst xmlns:a="http://schemas.openxmlformats.org/drawingml/2006/main">
               <a:ext uri="{FF2B5EF4-FFF2-40B4-BE49-F238E27FC236}">
-                <a16:creationId xmlns:a16="http://schemas.microsoft.com/office/drawing/2014/main" id="{0E1E0D6A-B4C6-4460-A3AF-B20176AEC1EA}"/>
+                <a16:creationId xmlns:a16="http://schemas.microsoft.com/office/drawing/2014/main" id="{1E6A6ABB-A3AB-4594-B69E-0D6013B0FB3D}"/>
               </a:ext>
             </a:extLst>
           </p:cNvPr>
@@ -7171,7 +7171,7 @@
           <p:cNvPr id="2" name="">
             <a:extLst xmlns:a="http://schemas.openxmlformats.org/drawingml/2006/main">
               <a:ext uri="{FF2B5EF4-FFF2-40B4-BE49-F238E27FC236}">
-                <a16:creationId xmlns:a16="http://schemas.microsoft.com/office/drawing/2014/main" id="{A14AFC46-6CCB-4A73-B6D0-7E5711EEF549}"/>
+                <a16:creationId xmlns:a16="http://schemas.microsoft.com/office/drawing/2014/main" id="{FBC54C1F-B4BA-419A-B672-5EE5CD5AD8C9}"/>
               </a:ext>
             </a:extLst>
           </p:cNvPr>
@@ -7204,7 +7204,7 @@
           <p:cNvPr id="3" name="">
             <a:extLst xmlns:a="http://schemas.openxmlformats.org/drawingml/2006/main">
               <a:ext uri="{FF2B5EF4-FFF2-40B4-BE49-F238E27FC236}">
-                <a16:creationId xmlns:a16="http://schemas.microsoft.com/office/drawing/2014/main" id="{336E7126-7428-46EC-BE41-5FCCCC3336D4}"/>
+                <a16:creationId xmlns:a16="http://schemas.microsoft.com/office/drawing/2014/main" id="{5E35EAD5-4F4E-446E-A96F-000AF9004CE0}"/>
               </a:ext>
             </a:extLst>
           </p:cNvPr>
@@ -7254,7 +7254,7 @@
           <p:cNvPr id="4" name="">
             <a:extLst xmlns:a="http://schemas.openxmlformats.org/drawingml/2006/main">
               <a:ext uri="{FF2B5EF4-FFF2-40B4-BE49-F238E27FC236}">
-                <a16:creationId xmlns:a16="http://schemas.microsoft.com/office/drawing/2014/main" id="{B8559073-3A83-4FD9-AD3B-9FDBF65D484E}"/>
+                <a16:creationId xmlns:a16="http://schemas.microsoft.com/office/drawing/2014/main" id="{8F69FC5C-5EBB-4384-8EF4-812E23B7D6A9}"/>
               </a:ext>
             </a:extLst>
           </p:cNvPr>
@@ -7304,7 +7304,7 @@
           <p:cNvPr id="5" name="">
             <a:extLst xmlns:a="http://schemas.openxmlformats.org/drawingml/2006/main">
               <a:ext uri="{FF2B5EF4-FFF2-40B4-BE49-F238E27FC236}">
-                <a16:creationId xmlns:a16="http://schemas.microsoft.com/office/drawing/2014/main" id="{8A9CF86D-B329-4BEA-A738-8197238C473B}"/>
+                <a16:creationId xmlns:a16="http://schemas.microsoft.com/office/drawing/2014/main" id="{315E7D75-5854-44EA-9C06-607AF910916C}"/>
               </a:ext>
             </a:extLst>
           </p:cNvPr>
@@ -7354,7 +7354,7 @@
           <p:cNvPr id="6" name="">
             <a:extLst xmlns:a="http://schemas.openxmlformats.org/drawingml/2006/main">
               <a:ext uri="{FF2B5EF4-FFF2-40B4-BE49-F238E27FC236}">
-                <a16:creationId xmlns:a16="http://schemas.microsoft.com/office/drawing/2014/main" id="{FD9ED136-30CC-4C51-A7AE-09CF5ADE60CD}"/>
+                <a16:creationId xmlns:a16="http://schemas.microsoft.com/office/drawing/2014/main" id="{B1CA45D5-E76F-4018-9E4D-4C1F31DC3242}"/>
               </a:ext>
             </a:extLst>
           </p:cNvPr>
@@ -7387,7 +7387,7 @@
           <p:cNvPr id="7" name="">
             <a:extLst xmlns:a="http://schemas.openxmlformats.org/drawingml/2006/main">
               <a:ext uri="{FF2B5EF4-FFF2-40B4-BE49-F238E27FC236}">
-                <a16:creationId xmlns:a16="http://schemas.microsoft.com/office/drawing/2014/main" id="{8FDA8A66-5CFB-44C6-822E-EC845676C5B9}"/>
+                <a16:creationId xmlns:a16="http://schemas.microsoft.com/office/drawing/2014/main" id="{C55EA7A5-0D4B-42E0-942C-ACCF186573E9}"/>
               </a:ext>
             </a:extLst>
           </p:cNvPr>
@@ -7460,7 +7460,7 @@
           <p:cNvPr id="8" name="">
             <a:extLst xmlns:a="http://schemas.openxmlformats.org/drawingml/2006/main">
               <a:ext uri="{FF2B5EF4-FFF2-40B4-BE49-F238E27FC236}">
-                <a16:creationId xmlns:a16="http://schemas.microsoft.com/office/drawing/2014/main" id="{6C19BF6A-8D0B-48B7-B9E8-EEC1E50E161F}"/>
+                <a16:creationId xmlns:a16="http://schemas.microsoft.com/office/drawing/2014/main" id="{39287757-22BA-4FEE-91CD-F10A692344C8}"/>
               </a:ext>
             </a:extLst>
           </p:cNvPr>
@@ -7533,7 +7533,7 @@
           <p:cNvPr id="9" name="">
             <a:extLst xmlns:a="http://schemas.openxmlformats.org/drawingml/2006/main">
               <a:ext uri="{FF2B5EF4-FFF2-40B4-BE49-F238E27FC236}">
-                <a16:creationId xmlns:a16="http://schemas.microsoft.com/office/drawing/2014/main" id="{ED00D7BE-0B44-4FEE-A496-807F548B026E}"/>
+                <a16:creationId xmlns:a16="http://schemas.microsoft.com/office/drawing/2014/main" id="{9D5451B7-8190-42EC-B960-59F61C46E179}"/>
               </a:ext>
             </a:extLst>
           </p:cNvPr>
@@ -7606,7 +7606,7 @@
           <p:cNvPr id="10" name="">
             <a:extLst xmlns:a="http://schemas.openxmlformats.org/drawingml/2006/main">
               <a:ext uri="{FF2B5EF4-FFF2-40B4-BE49-F238E27FC236}">
-                <a16:creationId xmlns:a16="http://schemas.microsoft.com/office/drawing/2014/main" id="{6C23835E-AA01-4F01-ADAA-55E9DD547242}"/>
+                <a16:creationId xmlns:a16="http://schemas.microsoft.com/office/drawing/2014/main" id="{160657DD-2BDF-44DF-AFD4-328377661C87}"/>
               </a:ext>
             </a:extLst>
           </p:cNvPr>
@@ -7679,7 +7679,7 @@
           <p:cNvPr id="11" name="">
             <a:extLst xmlns:a="http://schemas.openxmlformats.org/drawingml/2006/main">
               <a:ext uri="{FF2B5EF4-FFF2-40B4-BE49-F238E27FC236}">
-                <a16:creationId xmlns:a16="http://schemas.microsoft.com/office/drawing/2014/main" id="{9C44839F-8124-4B97-8E2C-DFAF9EE373E5}"/>
+                <a16:creationId xmlns:a16="http://schemas.microsoft.com/office/drawing/2014/main" id="{82A7DCE1-A2FE-430B-893F-DD238E2D2236}"/>
               </a:ext>
             </a:extLst>
           </p:cNvPr>
@@ -7729,7 +7729,7 @@
           <p:cNvPr id="12" name="">
             <a:extLst xmlns:a="http://schemas.openxmlformats.org/drawingml/2006/main">
               <a:ext uri="{FF2B5EF4-FFF2-40B4-BE49-F238E27FC236}">
-                <a16:creationId xmlns:a16="http://schemas.microsoft.com/office/drawing/2014/main" id="{308DBFE6-0E5E-400A-8EBB-7181C33424BD}"/>
+                <a16:creationId xmlns:a16="http://schemas.microsoft.com/office/drawing/2014/main" id="{7E47019E-B477-4A3B-A4AD-AD92C1A9A84F}"/>
               </a:ext>
             </a:extLst>
           </p:cNvPr>
@@ -7779,7 +7779,7 @@
           <p:cNvPr id="13" name="">
             <a:extLst xmlns:a="http://schemas.openxmlformats.org/drawingml/2006/main">
               <a:ext uri="{FF2B5EF4-FFF2-40B4-BE49-F238E27FC236}">
-                <a16:creationId xmlns:a16="http://schemas.microsoft.com/office/drawing/2014/main" id="{E8A1F157-D7D8-4CCE-9F3F-FC31D0563628}"/>
+                <a16:creationId xmlns:a16="http://schemas.microsoft.com/office/drawing/2014/main" id="{78C4AAFE-E5F2-4027-B6A0-2AAB291CC196}"/>
               </a:ext>
             </a:extLst>
           </p:cNvPr>
@@ -7829,7 +7829,7 @@
           <p:cNvPr id="14" name="">
             <a:extLst xmlns:a="http://schemas.openxmlformats.org/drawingml/2006/main">
               <a:ext uri="{FF2B5EF4-FFF2-40B4-BE49-F238E27FC236}">
-                <a16:creationId xmlns:a16="http://schemas.microsoft.com/office/drawing/2014/main" id="{9AEDE02D-DD3D-4C03-B5F0-34D9AC0CADAA}"/>
+                <a16:creationId xmlns:a16="http://schemas.microsoft.com/office/drawing/2014/main" id="{BCC1D316-2FF7-4C23-B5D6-0B452F2B5AAA}"/>
               </a:ext>
             </a:extLst>
           </p:cNvPr>
@@ -7879,7 +7879,7 @@
           <p:cNvPr id="15" name="">
             <a:extLst xmlns:a="http://schemas.openxmlformats.org/drawingml/2006/main">
               <a:ext uri="{FF2B5EF4-FFF2-40B4-BE49-F238E27FC236}">
-                <a16:creationId xmlns:a16="http://schemas.microsoft.com/office/drawing/2014/main" id="{0874990E-99CE-4CA0-81DD-084A82006A15}"/>
+                <a16:creationId xmlns:a16="http://schemas.microsoft.com/office/drawing/2014/main" id="{4C637A9D-99C3-4AE2-A210-CE64E458F6BB}"/>
               </a:ext>
             </a:extLst>
           </p:cNvPr>
@@ -7929,7 +7929,7 @@
           <p:cNvPr id="16" name="">
             <a:extLst xmlns:a="http://schemas.openxmlformats.org/drawingml/2006/main">
               <a:ext uri="{FF2B5EF4-FFF2-40B4-BE49-F238E27FC236}">
-                <a16:creationId xmlns:a16="http://schemas.microsoft.com/office/drawing/2014/main" id="{DB8E25BA-9BA1-4C0D-B5AE-3C649152AD0A}"/>
+                <a16:creationId xmlns:a16="http://schemas.microsoft.com/office/drawing/2014/main" id="{25959F72-039D-42CD-8E11-9465227EB287}"/>
               </a:ext>
             </a:extLst>
           </p:cNvPr>
@@ -7979,7 +7979,7 @@
           <p:cNvPr id="17" name="">
             <a:extLst xmlns:a="http://schemas.openxmlformats.org/drawingml/2006/main">
               <a:ext uri="{FF2B5EF4-FFF2-40B4-BE49-F238E27FC236}">
-                <a16:creationId xmlns:a16="http://schemas.microsoft.com/office/drawing/2014/main" id="{07E7B631-A522-460B-B357-370AF04EA54F}"/>
+                <a16:creationId xmlns:a16="http://schemas.microsoft.com/office/drawing/2014/main" id="{79ADF777-308E-45F1-A1D1-6ABD9C258956}"/>
               </a:ext>
             </a:extLst>
           </p:cNvPr>
@@ -8029,7 +8029,7 @@
           <p:cNvPr id="18" name="">
             <a:extLst xmlns:a="http://schemas.openxmlformats.org/drawingml/2006/main">
               <a:ext uri="{FF2B5EF4-FFF2-40B4-BE49-F238E27FC236}">
-                <a16:creationId xmlns:a16="http://schemas.microsoft.com/office/drawing/2014/main" id="{3D7BBB55-770F-4E25-8579-111ECD7A8ED8}"/>
+                <a16:creationId xmlns:a16="http://schemas.microsoft.com/office/drawing/2014/main" id="{C234F0C0-1B60-4A95-9807-167EC22111E7}"/>
               </a:ext>
             </a:extLst>
           </p:cNvPr>
@@ -8077,7 +8077,7 @@
     </p:spTree>
     <p:extLst>
       <p:ext uri="{BB962C8B-B14F-4D97-AF65-F5344CB8AC3E}">
-        <p14:creationId xmlns:p14="http://schemas.microsoft.com/office/powerpoint/2010/main" val="1950483786"/>
+        <p14:creationId xmlns:p14="http://schemas.microsoft.com/office/powerpoint/2010/main" val="577721322"/>
       </p:ext>
     </p:extLst>
   </p:cSld>
@@ -8108,7 +8108,7 @@
           <p:cNvPr id="1" name="">
             <a:extLst xmlns:a="http://schemas.openxmlformats.org/drawingml/2006/main">
               <a:ext uri="{FF2B5EF4-FFF2-40B4-BE49-F238E27FC236}">
-                <a16:creationId xmlns:a16="http://schemas.microsoft.com/office/drawing/2014/main" id="{042E9C2A-85B2-458B-B8F1-3981876040E7}"/>
+                <a16:creationId xmlns:a16="http://schemas.microsoft.com/office/drawing/2014/main" id="{03AB67E8-ADAE-44CC-8C68-E1C5E170E91E}"/>
               </a:ext>
             </a:extLst>
           </p:cNvPr>
@@ -8141,7 +8141,7 @@
           <p:cNvPr id="2" name="">
             <a:extLst xmlns:a="http://schemas.openxmlformats.org/drawingml/2006/main">
               <a:ext uri="{FF2B5EF4-FFF2-40B4-BE49-F238E27FC236}">
-                <a16:creationId xmlns:a16="http://schemas.microsoft.com/office/drawing/2014/main" id="{B808AC5C-A3B5-4964-B237-1D6A9BD0F02F}"/>
+                <a16:creationId xmlns:a16="http://schemas.microsoft.com/office/drawing/2014/main" id="{E4BAEE21-8D47-45C4-A903-37825DEE2E73}"/>
               </a:ext>
             </a:extLst>
           </p:cNvPr>
@@ -8174,7 +8174,7 @@
           <p:cNvPr id="3" name="">
             <a:extLst xmlns:a="http://schemas.openxmlformats.org/drawingml/2006/main">
               <a:ext uri="{FF2B5EF4-FFF2-40B4-BE49-F238E27FC236}">
-                <a16:creationId xmlns:a16="http://schemas.microsoft.com/office/drawing/2014/main" id="{01ED0619-B2FE-4D68-B36C-4AE80C8EE08D}"/>
+                <a16:creationId xmlns:a16="http://schemas.microsoft.com/office/drawing/2014/main" id="{9B348955-CEA9-4887-974A-2BBA4DDA9D98}"/>
               </a:ext>
             </a:extLst>
           </p:cNvPr>
@@ -8224,7 +8224,7 @@
           <p:cNvPr id="4" name="">
             <a:extLst xmlns:a="http://schemas.openxmlformats.org/drawingml/2006/main">
               <a:ext uri="{FF2B5EF4-FFF2-40B4-BE49-F238E27FC236}">
-                <a16:creationId xmlns:a16="http://schemas.microsoft.com/office/drawing/2014/main" id="{96341C4B-381D-4B77-970C-8FFB28D67607}"/>
+                <a16:creationId xmlns:a16="http://schemas.microsoft.com/office/drawing/2014/main" id="{3495F7EC-F59E-4407-BC22-B9B648DF2C51}"/>
               </a:ext>
             </a:extLst>
           </p:cNvPr>
@@ -8274,7 +8274,7 @@
           <p:cNvPr id="5" name="">
             <a:extLst xmlns:a="http://schemas.openxmlformats.org/drawingml/2006/main">
               <a:ext uri="{FF2B5EF4-FFF2-40B4-BE49-F238E27FC236}">
-                <a16:creationId xmlns:a16="http://schemas.microsoft.com/office/drawing/2014/main" id="{17BF6C3A-3791-45ED-A477-E9F537F1F490}"/>
+                <a16:creationId xmlns:a16="http://schemas.microsoft.com/office/drawing/2014/main" id="{7B9A82EE-C02A-47F2-B10C-4632AD9E7C52}"/>
               </a:ext>
             </a:extLst>
           </p:cNvPr>
@@ -8324,7 +8324,7 @@
           <p:cNvPr id="6" name="">
             <a:extLst xmlns:a="http://schemas.openxmlformats.org/drawingml/2006/main">
               <a:ext uri="{FF2B5EF4-FFF2-40B4-BE49-F238E27FC236}">
-                <a16:creationId xmlns:a16="http://schemas.microsoft.com/office/drawing/2014/main" id="{BE6E60BE-C071-4941-874B-54E66559E291}"/>
+                <a16:creationId xmlns:a16="http://schemas.microsoft.com/office/drawing/2014/main" id="{26A01264-3954-454B-BC4B-EAD03A5AB1A4}"/>
               </a:ext>
             </a:extLst>
           </p:cNvPr>
@@ -8361,7 +8361,7 @@
           <p:nvPr/>
         </p:nvPicPr>
         <p:blipFill>
-          <a:blip xmlns:r="http://schemas.openxmlformats.org/officeDocument/2006/relationships" xmlns:a="http://schemas.openxmlformats.org/drawingml/2006/main" r:embed="Rcbf39d8675864ecd"/>
+          <a:blip xmlns:r="http://schemas.openxmlformats.org/officeDocument/2006/relationships" xmlns:a="http://schemas.openxmlformats.org/drawingml/2006/main" r:embed="R53e1ce8a96504e7d"/>
           <a:stretch xmlns:a="http://schemas.openxmlformats.org/drawingml/2006/main"/>
         </p:blipFill>
         <p:spPr>
@@ -8383,7 +8383,7 @@
           <p:nvPr/>
         </p:nvPicPr>
         <p:blipFill>
-          <a:blip xmlns:r="http://schemas.openxmlformats.org/officeDocument/2006/relationships" xmlns:a="http://schemas.openxmlformats.org/drawingml/2006/main" r:embed="Rcb739ca2712e48b5"/>
+          <a:blip xmlns:r="http://schemas.openxmlformats.org/officeDocument/2006/relationships" xmlns:a="http://schemas.openxmlformats.org/drawingml/2006/main" r:embed="R330204c4f4ea496a"/>
           <a:stretch xmlns:a="http://schemas.openxmlformats.org/drawingml/2006/main"/>
         </p:blipFill>
         <p:spPr>
@@ -8401,7 +8401,7 @@
           <p:cNvPr id="9" name="">
             <a:extLst xmlns:a="http://schemas.openxmlformats.org/drawingml/2006/main">
               <a:ext uri="{FF2B5EF4-FFF2-40B4-BE49-F238E27FC236}">
-                <a16:creationId xmlns:a16="http://schemas.microsoft.com/office/drawing/2014/main" id="{BF55902B-7025-4D2C-92BE-FE270F75B66B}"/>
+                <a16:creationId xmlns:a16="http://schemas.microsoft.com/office/drawing/2014/main" id="{E5D5344F-CBD9-41E6-9167-F5784A3597A3}"/>
               </a:ext>
             </a:extLst>
           </p:cNvPr>
@@ -8451,7 +8451,7 @@
           <p:cNvPr id="10" name="">
             <a:extLst xmlns:a="http://schemas.openxmlformats.org/drawingml/2006/main">
               <a:ext uri="{FF2B5EF4-FFF2-40B4-BE49-F238E27FC236}">
-                <a16:creationId xmlns:a16="http://schemas.microsoft.com/office/drawing/2014/main" id="{50032D0D-0A15-485D-8367-243BAE5C2A7E}"/>
+                <a16:creationId xmlns:a16="http://schemas.microsoft.com/office/drawing/2014/main" id="{7C968FB1-0506-4682-A8F2-82006A1EBCF4}"/>
               </a:ext>
             </a:extLst>
           </p:cNvPr>
@@ -8501,7 +8501,7 @@
           <p:cNvPr id="11" name="">
             <a:extLst xmlns:a="http://schemas.openxmlformats.org/drawingml/2006/main">
               <a:ext uri="{FF2B5EF4-FFF2-40B4-BE49-F238E27FC236}">
-                <a16:creationId xmlns:a16="http://schemas.microsoft.com/office/drawing/2014/main" id="{2BAF04E9-940F-4391-9FCC-5CD04CAE8282}"/>
+                <a16:creationId xmlns:a16="http://schemas.microsoft.com/office/drawing/2014/main" id="{C152CAD0-9B2C-49B5-8D4C-152041070BFA}"/>
               </a:ext>
             </a:extLst>
           </p:cNvPr>
@@ -8549,7 +8549,7 @@
     </p:spTree>
     <p:extLst>
       <p:ext uri="{BB962C8B-B14F-4D97-AF65-F5344CB8AC3E}">
-        <p14:creationId xmlns:p14="http://schemas.microsoft.com/office/powerpoint/2010/main" val="316107444"/>
+        <p14:creationId xmlns:p14="http://schemas.microsoft.com/office/powerpoint/2010/main" val="1910905215"/>
       </p:ext>
     </p:extLst>
   </p:cSld>
@@ -8580,7 +8580,7 @@
           <p:cNvPr id="1" name="">
             <a:extLst xmlns:a="http://schemas.openxmlformats.org/drawingml/2006/main">
               <a:ext uri="{FF2B5EF4-FFF2-40B4-BE49-F238E27FC236}">
-                <a16:creationId xmlns:a16="http://schemas.microsoft.com/office/drawing/2014/main" id="{939A240A-3FF6-4795-BF30-295045EA7242}"/>
+                <a16:creationId xmlns:a16="http://schemas.microsoft.com/office/drawing/2014/main" id="{9CA2E082-8DE2-4235-AABD-B89E4AF41DE1}"/>
               </a:ext>
             </a:extLst>
           </p:cNvPr>
@@ -8613,7 +8613,7 @@
           <p:cNvPr id="2" name="">
             <a:extLst xmlns:a="http://schemas.openxmlformats.org/drawingml/2006/main">
               <a:ext uri="{FF2B5EF4-FFF2-40B4-BE49-F238E27FC236}">
-                <a16:creationId xmlns:a16="http://schemas.microsoft.com/office/drawing/2014/main" id="{76036D1D-CDDE-4EB9-81D0-505813A809E2}"/>
+                <a16:creationId xmlns:a16="http://schemas.microsoft.com/office/drawing/2014/main" id="{AFEF48A0-D53F-4AE4-9A74-411BCCE36E0C}"/>
               </a:ext>
             </a:extLst>
           </p:cNvPr>
@@ -8646,7 +8646,7 @@
           <p:cNvPr id="3" name="">
             <a:extLst xmlns:a="http://schemas.openxmlformats.org/drawingml/2006/main">
               <a:ext uri="{FF2B5EF4-FFF2-40B4-BE49-F238E27FC236}">
-                <a16:creationId xmlns:a16="http://schemas.microsoft.com/office/drawing/2014/main" id="{7E4FC6D1-8E51-4D68-8333-AEB00A62DE18}"/>
+                <a16:creationId xmlns:a16="http://schemas.microsoft.com/office/drawing/2014/main" id="{B010E662-4E94-48D5-9597-6FF5652B8663}"/>
               </a:ext>
             </a:extLst>
           </p:cNvPr>
@@ -8696,7 +8696,7 @@
           <p:cNvPr id="4" name="">
             <a:extLst xmlns:a="http://schemas.openxmlformats.org/drawingml/2006/main">
               <a:ext uri="{FF2B5EF4-FFF2-40B4-BE49-F238E27FC236}">
-                <a16:creationId xmlns:a16="http://schemas.microsoft.com/office/drawing/2014/main" id="{1D3E6560-78DD-4D52-8028-88E6109372F4}"/>
+                <a16:creationId xmlns:a16="http://schemas.microsoft.com/office/drawing/2014/main" id="{40BE2C09-8C60-4FD4-B773-6F6E5C402A32}"/>
               </a:ext>
             </a:extLst>
           </p:cNvPr>
@@ -8746,7 +8746,7 @@
           <p:cNvPr id="5" name="">
             <a:extLst xmlns:a="http://schemas.openxmlformats.org/drawingml/2006/main">
               <a:ext uri="{FF2B5EF4-FFF2-40B4-BE49-F238E27FC236}">
-                <a16:creationId xmlns:a16="http://schemas.microsoft.com/office/drawing/2014/main" id="{9FB2FE20-58E5-4666-91B5-0E73EFFBAFE4}"/>
+                <a16:creationId xmlns:a16="http://schemas.microsoft.com/office/drawing/2014/main" id="{477C3519-6C30-4B2F-8BC7-84D6B704A53E}"/>
               </a:ext>
             </a:extLst>
           </p:cNvPr>
@@ -8796,7 +8796,7 @@
           <p:cNvPr id="6" name="">
             <a:extLst xmlns:a="http://schemas.openxmlformats.org/drawingml/2006/main">
               <a:ext uri="{FF2B5EF4-FFF2-40B4-BE49-F238E27FC236}">
-                <a16:creationId xmlns:a16="http://schemas.microsoft.com/office/drawing/2014/main" id="{F8CC20C9-39CF-4013-9E62-B8E12459D9AE}"/>
+                <a16:creationId xmlns:a16="http://schemas.microsoft.com/office/drawing/2014/main" id="{269A0587-B425-4A39-8B87-37DEABA1EB44}"/>
               </a:ext>
             </a:extLst>
           </p:cNvPr>
@@ -8833,7 +8833,7 @@
           <p:nvPr/>
         </p:nvPicPr>
         <p:blipFill>
-          <a:blip xmlns:r="http://schemas.openxmlformats.org/officeDocument/2006/relationships" xmlns:a="http://schemas.openxmlformats.org/drawingml/2006/main" r:embed="R4901c00c377142c3"/>
+          <a:blip xmlns:r="http://schemas.openxmlformats.org/officeDocument/2006/relationships" xmlns:a="http://schemas.openxmlformats.org/drawingml/2006/main" r:embed="Rd7c37cd9aeeb447b"/>
           <a:stretch xmlns:a="http://schemas.openxmlformats.org/drawingml/2006/main"/>
         </p:blipFill>
         <p:spPr>
@@ -8855,7 +8855,7 @@
           <p:nvPr/>
         </p:nvPicPr>
         <p:blipFill>
-          <a:blip xmlns:r="http://schemas.openxmlformats.org/officeDocument/2006/relationships" xmlns:a="http://schemas.openxmlformats.org/drawingml/2006/main" r:embed="R7757b31f1a924ea3"/>
+          <a:blip xmlns:r="http://schemas.openxmlformats.org/officeDocument/2006/relationships" xmlns:a="http://schemas.openxmlformats.org/drawingml/2006/main" r:embed="R3fc984f66cbf4407"/>
           <a:stretch xmlns:a="http://schemas.openxmlformats.org/drawingml/2006/main"/>
         </p:blipFill>
         <p:spPr>
@@ -8873,7 +8873,7 @@
           <p:cNvPr id="9" name="">
             <a:extLst xmlns:a="http://schemas.openxmlformats.org/drawingml/2006/main">
               <a:ext uri="{FF2B5EF4-FFF2-40B4-BE49-F238E27FC236}">
-                <a16:creationId xmlns:a16="http://schemas.microsoft.com/office/drawing/2014/main" id="{2216E0FF-8752-4711-AC3D-5AE7651D86BF}"/>
+                <a16:creationId xmlns:a16="http://schemas.microsoft.com/office/drawing/2014/main" id="{6E0DE1E5-051D-4BE4-8FE6-F78264BF95E2}"/>
               </a:ext>
             </a:extLst>
           </p:cNvPr>
@@ -8923,7 +8923,7 @@
           <p:cNvPr id="10" name="">
             <a:extLst xmlns:a="http://schemas.openxmlformats.org/drawingml/2006/main">
               <a:ext uri="{FF2B5EF4-FFF2-40B4-BE49-F238E27FC236}">
-                <a16:creationId xmlns:a16="http://schemas.microsoft.com/office/drawing/2014/main" id="{4BA99A2A-9940-4B2F-BAB2-C16F60B7219B}"/>
+                <a16:creationId xmlns:a16="http://schemas.microsoft.com/office/drawing/2014/main" id="{BF896325-F72D-4600-B74E-3D3FB2B658AD}"/>
               </a:ext>
             </a:extLst>
           </p:cNvPr>
@@ -8973,7 +8973,7 @@
           <p:cNvPr id="11" name="">
             <a:extLst xmlns:a="http://schemas.openxmlformats.org/drawingml/2006/main">
               <a:ext uri="{FF2B5EF4-FFF2-40B4-BE49-F238E27FC236}">
-                <a16:creationId xmlns:a16="http://schemas.microsoft.com/office/drawing/2014/main" id="{4F21FA9D-166C-4225-B328-55BD9EAE2871}"/>
+                <a16:creationId xmlns:a16="http://schemas.microsoft.com/office/drawing/2014/main" id="{1CFD2AF1-8FDE-4EEC-8D2D-461CE80DB3D6}"/>
               </a:ext>
             </a:extLst>
           </p:cNvPr>
@@ -9023,7 +9023,7 @@
           <p:cNvPr id="12" name="">
             <a:extLst xmlns:a="http://schemas.openxmlformats.org/drawingml/2006/main">
               <a:ext uri="{FF2B5EF4-FFF2-40B4-BE49-F238E27FC236}">
-                <a16:creationId xmlns:a16="http://schemas.microsoft.com/office/drawing/2014/main" id="{31CD8CFC-1119-4772-9E78-CC94CD75E767}"/>
+                <a16:creationId xmlns:a16="http://schemas.microsoft.com/office/drawing/2014/main" id="{F617756A-ABD0-41A2-A217-7E534D1604F3}"/>
               </a:ext>
             </a:extLst>
           </p:cNvPr>
@@ -9073,7 +9073,7 @@
           <p:cNvPr id="13" name="">
             <a:extLst xmlns:a="http://schemas.openxmlformats.org/drawingml/2006/main">
               <a:ext uri="{FF2B5EF4-FFF2-40B4-BE49-F238E27FC236}">
-                <a16:creationId xmlns:a16="http://schemas.microsoft.com/office/drawing/2014/main" id="{1D8E0523-3697-4038-8C73-860C006C4374}"/>
+                <a16:creationId xmlns:a16="http://schemas.microsoft.com/office/drawing/2014/main" id="{8A5EBB2D-333A-41D9-A1C0-294B2DE8715E}"/>
               </a:ext>
             </a:extLst>
           </p:cNvPr>
@@ -9123,7 +9123,7 @@
           <p:cNvPr id="14" name="">
             <a:extLst xmlns:a="http://schemas.openxmlformats.org/drawingml/2006/main">
               <a:ext uri="{FF2B5EF4-FFF2-40B4-BE49-F238E27FC236}">
-                <a16:creationId xmlns:a16="http://schemas.microsoft.com/office/drawing/2014/main" id="{067DB48D-37F7-42F9-B292-4F2194022AC4}"/>
+                <a16:creationId xmlns:a16="http://schemas.microsoft.com/office/drawing/2014/main" id="{7642B417-4A97-4F5F-B9CE-D9039ECB1F1B}"/>
               </a:ext>
             </a:extLst>
           </p:cNvPr>
@@ -9173,7 +9173,7 @@
           <p:cNvPr id="15" name="">
             <a:extLst xmlns:a="http://schemas.openxmlformats.org/drawingml/2006/main">
               <a:ext uri="{FF2B5EF4-FFF2-40B4-BE49-F238E27FC236}">
-                <a16:creationId xmlns:a16="http://schemas.microsoft.com/office/drawing/2014/main" id="{F949990A-A45C-4463-991E-9A71D4612F67}"/>
+                <a16:creationId xmlns:a16="http://schemas.microsoft.com/office/drawing/2014/main" id="{45F9A07C-B04C-4985-8877-D68924EEDDF9}"/>
               </a:ext>
             </a:extLst>
           </p:cNvPr>
@@ -9223,7 +9223,7 @@
           <p:cNvPr id="16" name="">
             <a:extLst xmlns:a="http://schemas.openxmlformats.org/drawingml/2006/main">
               <a:ext uri="{FF2B5EF4-FFF2-40B4-BE49-F238E27FC236}">
-                <a16:creationId xmlns:a16="http://schemas.microsoft.com/office/drawing/2014/main" id="{19B55B2C-CA50-4F5A-9E3C-027D205324B1}"/>
+                <a16:creationId xmlns:a16="http://schemas.microsoft.com/office/drawing/2014/main" id="{B2422C8B-F779-4130-AB02-4FD1F2CA595D}"/>
               </a:ext>
             </a:extLst>
           </p:cNvPr>
@@ -9271,7 +9271,7 @@
     </p:spTree>
     <p:extLst>
       <p:ext uri="{BB962C8B-B14F-4D97-AF65-F5344CB8AC3E}">
-        <p14:creationId xmlns:p14="http://schemas.microsoft.com/office/powerpoint/2010/main" val="1222529628"/>
+        <p14:creationId xmlns:p14="http://schemas.microsoft.com/office/powerpoint/2010/main" val="790054904"/>
       </p:ext>
     </p:extLst>
   </p:cSld>

</xml_diff>